<commit_message>
Evaluate learned view weighting
</commit_message>
<xml_diff>
--- a/submission/CricketShot_Presentation.pptx
+++ b/submission/CricketShot_Presentation.pptx
@@ -5,7 +5,7 @@
     <p:sldMasterId id="2147483648" r:id="rId1"/>
   </p:sldMasterIdLst>
   <p:notesMasterIdLst>
-    <p:notesMasterId r:id="rId18"/>
+    <p:notesMasterId r:id="rId19"/>
   </p:notesMasterIdLst>
   <p:sldIdLst>
     <p:sldId id="256" r:id="rId2"/>
@@ -24,6 +24,7 @@
     <p:sldId id="269" r:id="rId15"/>
     <p:sldId id="270" r:id="rId16"/>
     <p:sldId id="271" r:id="rId17"/>
+    <p:sldId id="272" r:id="rId18"/>
   </p:sldIdLst>
   <p:sldSz cx="12192000" cy="6858000"/>
   <p:notesSz cx="6858000" cy="9144000"/>
@@ -205,7 +206,7 @@
             </a:lvl1pPr>
           </a:lstStyle>
           <a:p>
-            <a:fld id="{0A0CB448-8CD0-43B2-873A-FF1FC171ACA2}" type="datetimeFigureOut">
+            <a:fld id="{2AB85FD1-3046-4769-AE0B-D618BF128588}" type="datetimeFigureOut">
               <a:rPr lang="en-IN" smtClean="0"/>
               <a:t>19-10-2026</a:t>
             </a:fld>
@@ -364,7 +365,7 @@
             </a:lvl1pPr>
           </a:lstStyle>
           <a:p>
-            <a:fld id="{CB6D05BF-3823-4251-85D6-8F40948E3712}" type="slidenum">
+            <a:fld id="{4AA5213A-272A-46DE-A19A-34290041A493}" type="slidenum">
               <a:rPr lang="en-IN" smtClean="0"/>
               <a:t>‹#›</a:t>
             </a:fld>
@@ -375,7 +376,7 @@
     </p:spTree>
     <p:extLst>
       <p:ext uri="{BB962C8B-B14F-4D97-AF65-F5344CB8AC3E}">
-        <p14:creationId xmlns:p14="http://schemas.microsoft.com/office/powerpoint/2010/main" val="2249882167"/>
+        <p14:creationId xmlns:p14="http://schemas.microsoft.com/office/powerpoint/2010/main" val="2188669798"/>
       </p:ext>
     </p:extLst>
   </p:cSld>
@@ -542,7 +543,7 @@
           <a:bodyPr/>
           <a:lstStyle/>
           <a:p>
-            <a:fld id="{CB6D05BF-3823-4251-85D6-8F40948E3712}" type="slidenum">
+            <a:fld id="{4AA5213A-272A-46DE-A19A-34290041A493}" type="slidenum">
               <a:rPr lang="en-IN" smtClean="0"/>
               <a:t>1</a:t>
             </a:fld>
@@ -553,7 +554,7 @@
     </p:spTree>
     <p:extLst>
       <p:ext uri="{BB962C8B-B14F-4D97-AF65-F5344CB8AC3E}">
-        <p14:creationId xmlns:p14="http://schemas.microsoft.com/office/powerpoint/2010/main" val="117299915"/>
+        <p14:creationId xmlns:p14="http://schemas.microsoft.com/office/powerpoint/2010/main" val="4194381756"/>
       </p:ext>
     </p:extLst>
   </p:cSld>
@@ -630,7 +631,7 @@
           <a:bodyPr/>
           <a:lstStyle/>
           <a:p>
-            <a:fld id="{CB6D05BF-3823-4251-85D6-8F40948E3712}" type="slidenum">
+            <a:fld id="{4AA5213A-272A-46DE-A19A-34290041A493}" type="slidenum">
               <a:rPr lang="en-IN" smtClean="0"/>
               <a:t>10</a:t>
             </a:fld>
@@ -641,7 +642,7 @@
     </p:spTree>
     <p:extLst>
       <p:ext uri="{BB962C8B-B14F-4D97-AF65-F5344CB8AC3E}">
-        <p14:creationId xmlns:p14="http://schemas.microsoft.com/office/powerpoint/2010/main" val="1800606735"/>
+        <p14:creationId xmlns:p14="http://schemas.microsoft.com/office/powerpoint/2010/main" val="1237195612"/>
       </p:ext>
     </p:extLst>
   </p:cSld>
@@ -718,7 +719,7 @@
           <a:bodyPr/>
           <a:lstStyle/>
           <a:p>
-            <a:fld id="{CB6D05BF-3823-4251-85D6-8F40948E3712}" type="slidenum">
+            <a:fld id="{4AA5213A-272A-46DE-A19A-34290041A493}" type="slidenum">
               <a:rPr lang="en-IN" smtClean="0"/>
               <a:t>11</a:t>
             </a:fld>
@@ -729,7 +730,7 @@
     </p:spTree>
     <p:extLst>
       <p:ext uri="{BB962C8B-B14F-4D97-AF65-F5344CB8AC3E}">
-        <p14:creationId xmlns:p14="http://schemas.microsoft.com/office/powerpoint/2010/main" val="2926563933"/>
+        <p14:creationId xmlns:p14="http://schemas.microsoft.com/office/powerpoint/2010/main" val="3210066702"/>
       </p:ext>
     </p:extLst>
   </p:cSld>
@@ -806,7 +807,7 @@
           <a:bodyPr/>
           <a:lstStyle/>
           <a:p>
-            <a:fld id="{CB6D05BF-3823-4251-85D6-8F40948E3712}" type="slidenum">
+            <a:fld id="{4AA5213A-272A-46DE-A19A-34290041A493}" type="slidenum">
               <a:rPr lang="en-IN" smtClean="0"/>
               <a:t>12</a:t>
             </a:fld>
@@ -817,7 +818,7 @@
     </p:spTree>
     <p:extLst>
       <p:ext uri="{BB962C8B-B14F-4D97-AF65-F5344CB8AC3E}">
-        <p14:creationId xmlns:p14="http://schemas.microsoft.com/office/powerpoint/2010/main" val="1865189731"/>
+        <p14:creationId xmlns:p14="http://schemas.microsoft.com/office/powerpoint/2010/main" val="2705128930"/>
       </p:ext>
     </p:extLst>
   </p:cSld>
@@ -894,7 +895,7 @@
           <a:bodyPr/>
           <a:lstStyle/>
           <a:p>
-            <a:fld id="{CB6D05BF-3823-4251-85D6-8F40948E3712}" type="slidenum">
+            <a:fld id="{4AA5213A-272A-46DE-A19A-34290041A493}" type="slidenum">
               <a:rPr lang="en-IN" smtClean="0"/>
               <a:t>13</a:t>
             </a:fld>
@@ -905,7 +906,7 @@
     </p:spTree>
     <p:extLst>
       <p:ext uri="{BB962C8B-B14F-4D97-AF65-F5344CB8AC3E}">
-        <p14:creationId xmlns:p14="http://schemas.microsoft.com/office/powerpoint/2010/main" val="3628834908"/>
+        <p14:creationId xmlns:p14="http://schemas.microsoft.com/office/powerpoint/2010/main" val="3932707134"/>
       </p:ext>
     </p:extLst>
   </p:cSld>
@@ -982,7 +983,7 @@
           <a:bodyPr/>
           <a:lstStyle/>
           <a:p>
-            <a:fld id="{CB6D05BF-3823-4251-85D6-8F40948E3712}" type="slidenum">
+            <a:fld id="{4AA5213A-272A-46DE-A19A-34290041A493}" type="slidenum">
               <a:rPr lang="en-IN" smtClean="0"/>
               <a:t>14</a:t>
             </a:fld>
@@ -993,7 +994,7 @@
     </p:spTree>
     <p:extLst>
       <p:ext uri="{BB962C8B-B14F-4D97-AF65-F5344CB8AC3E}">
-        <p14:creationId xmlns:p14="http://schemas.microsoft.com/office/powerpoint/2010/main" val="3278748687"/>
+        <p14:creationId xmlns:p14="http://schemas.microsoft.com/office/powerpoint/2010/main" val="561185659"/>
       </p:ext>
     </p:extLst>
   </p:cSld>
@@ -1070,7 +1071,7 @@
           <a:bodyPr/>
           <a:lstStyle/>
           <a:p>
-            <a:fld id="{CB6D05BF-3823-4251-85D6-8F40948E3712}" type="slidenum">
+            <a:fld id="{4AA5213A-272A-46DE-A19A-34290041A493}" type="slidenum">
               <a:rPr lang="en-IN" smtClean="0"/>
               <a:t>15</a:t>
             </a:fld>
@@ -1081,7 +1082,7 @@
     </p:spTree>
     <p:extLst>
       <p:ext uri="{BB962C8B-B14F-4D97-AF65-F5344CB8AC3E}">
-        <p14:creationId xmlns:p14="http://schemas.microsoft.com/office/powerpoint/2010/main" val="1485376136"/>
+        <p14:creationId xmlns:p14="http://schemas.microsoft.com/office/powerpoint/2010/main" val="4136491437"/>
       </p:ext>
     </p:extLst>
   </p:cSld>
@@ -1137,7 +1138,7 @@
           <a:p>
             <a:r>
               <a:rPr lang="en-US"/>
-              <a:t>Use only for questions. Equal 30.2% majority accuracy means weak video recognition, despite higher macro F1. Fixed crop followed pilot test feedback. Source: https://www.kaggle.com/datasets/amittalmale/cricket-shots . Image audit: pHash &lt;=6 bits with thumbnail MAD, rotations/mirrors, then 15 feature neighbors within cosine .20. ORB binary matching, .72 ratio, &gt;=16 matches, &gt;=12 RANSAC inliers, &gt;=65% inlier fraction, &gt;=8% hull coverage. These are evaluation tools, not a novel shot classifier. Other sources: https://github.com/onnx/models ; https://github.com/scikit-learn/scikit-learn ; https://github.com/microsoft/onnxruntime ; https://github.com/opencv/opencv ; https://arxiv.org/abs/1608.00859 . Full URLs, saved evidence and complete code appendix accompany the report.</a:t>
+              <a:t>Exploratory follow-up after original test results were known. Established mixture-of-experts idea: Jacobs et al. (1991), https://www.cs.toronto.edu/~hinton/absps/jjnh91.pdf . Three experts with C=10 and T=1. No new CNN pass or CNN training. Gate inputs: each expert entropy/log4, maximum and margin; pairwise total variation; embedding cosine distance. Training-only out-of-fold means/std standardize 13 inputs, std lower bound .05. Slopes/intercepts give42 coefficients. Class-balanced NLL, L2 slopes, unpenalized biases. Search L2 .01,.1,1,10, validation macro F1, stronger regularization wins ties. Constant control learns .176 global, nearly zero crop, .824 contrast. Adaptive and constant test predictions are identical. Adaptive minus contrast: -0.11 accuracy points, paired visual-group 95% interval [-.79,+.68]. Concat validation F1=79.6%, so the frozen deployment rule rejects this gate. This is not nested CV: C was selected in the earlier validation study. Stored fold lists, OOF scores, protocol, selection and test predictions are in results/fusion. No new architecture or reliable gain is claimed.</a:t>
             </a:r>
             <a:endParaRPr lang="en-IN"/>
           </a:p>
@@ -1158,7 +1159,7 @@
           <a:bodyPr/>
           <a:lstStyle/>
           <a:p>
-            <a:fld id="{CB6D05BF-3823-4251-85D6-8F40948E3712}" type="slidenum">
+            <a:fld id="{4AA5213A-272A-46DE-A19A-34290041A493}" type="slidenum">
               <a:rPr lang="en-IN" smtClean="0"/>
               <a:t>16</a:t>
             </a:fld>
@@ -1169,7 +1170,95 @@
     </p:spTree>
     <p:extLst>
       <p:ext uri="{BB962C8B-B14F-4D97-AF65-F5344CB8AC3E}">
-        <p14:creationId xmlns:p14="http://schemas.microsoft.com/office/powerpoint/2010/main" val="3125352997"/>
+        <p14:creationId xmlns:p14="http://schemas.microsoft.com/office/powerpoint/2010/main" val="397433071"/>
+      </p:ext>
+    </p:extLst>
+  </p:cSld>
+  <p:clrMapOvr>
+    <a:masterClrMapping/>
+  </p:clrMapOvr>
+</p:notes>
+</file>
+
+<file path=ppt/notesSlides/notesSlide17.xml><?xml version="1.0" encoding="utf-8"?>
+<p:notes xmlns:a="http://schemas.openxmlformats.org/drawingml/2006/main" xmlns:r="http://schemas.openxmlformats.org/officeDocument/2006/relationships" xmlns:p="http://schemas.openxmlformats.org/presentationml/2006/main">
+  <p:cSld>
+    <p:spTree>
+      <p:nvGrpSpPr>
+        <p:cNvPr id="1" name=""/>
+        <p:cNvGrpSpPr/>
+        <p:nvPr/>
+      </p:nvGrpSpPr>
+      <p:grpSpPr>
+        <a:xfrm>
+          <a:off x="0" y="0"/>
+          <a:ext cx="0" cy="0"/>
+          <a:chOff x="0" y="0"/>
+          <a:chExt cx="0" cy="0"/>
+        </a:xfrm>
+      </p:grpSpPr>
+      <p:sp>
+        <p:nvSpPr>
+          <p:cNvPr id="2" name="Slide Image Placeholder 1"/>
+          <p:cNvSpPr>
+            <a:spLocks noGrp="1" noRot="1" noChangeAspect="1"/>
+          </p:cNvSpPr>
+          <p:nvPr>
+            <p:ph type="sldImg"/>
+          </p:nvPr>
+        </p:nvSpPr>
+        <p:spPr/>
+      </p:sp>
+      <p:sp>
+        <p:nvSpPr>
+          <p:cNvPr id="3" name="Notes Placeholder 2"/>
+          <p:cNvSpPr>
+            <a:spLocks noGrp="1"/>
+          </p:cNvSpPr>
+          <p:nvPr>
+            <p:ph type="body" idx="1"/>
+          </p:nvPr>
+        </p:nvSpPr>
+        <p:spPr/>
+        <p:txBody>
+          <a:bodyPr/>
+          <a:lstStyle/>
+          <a:p>
+            <a:r>
+              <a:rPr lang="en-US"/>
+              <a:t>Use only for questions. Equal 30.2% majority accuracy means weak video recognition, despite higher macro F1. Fixed crop followed pilot test feedback. Source: https://www.kaggle.com/datasets/amittalmale/cricket-shots . Image audit: pHash &lt;=6 bits with thumbnail MAD, rotations/mirrors, then 15 feature neighbors within cosine .20. ORB binary matching, .72 ratio, &gt;=16 matches, &gt;=12 RANSAC inliers, &gt;=65% inlier fraction, &gt;=8% hull coverage. These are evaluation tools, not a novel shot classifier. Other sources: https://github.com/onnx/models ; https://github.com/scikit-learn/scikit-learn ; https://github.com/microsoft/onnxruntime ; https://github.com/opencv/opencv ; https://arxiv.org/abs/1608.00859 . Full URLs, saved evidence and complete code appendix accompany the report.</a:t>
+            </a:r>
+            <a:endParaRPr lang="en-IN"/>
+          </a:p>
+        </p:txBody>
+      </p:sp>
+      <p:sp>
+        <p:nvSpPr>
+          <p:cNvPr id="4" name="Slide Number Placeholder 3"/>
+          <p:cNvSpPr>
+            <a:spLocks noGrp="1"/>
+          </p:cNvSpPr>
+          <p:nvPr>
+            <p:ph type="sldNum" sz="quarter" idx="5"/>
+          </p:nvPr>
+        </p:nvSpPr>
+        <p:spPr/>
+        <p:txBody>
+          <a:bodyPr/>
+          <a:lstStyle/>
+          <a:p>
+            <a:fld id="{4AA5213A-272A-46DE-A19A-34290041A493}" type="slidenum">
+              <a:rPr lang="en-IN" smtClean="0"/>
+              <a:t>17</a:t>
+            </a:fld>
+            <a:endParaRPr lang="en-IN"/>
+          </a:p>
+        </p:txBody>
+      </p:sp>
+    </p:spTree>
+    <p:extLst>
+      <p:ext uri="{BB962C8B-B14F-4D97-AF65-F5344CB8AC3E}">
+        <p14:creationId xmlns:p14="http://schemas.microsoft.com/office/powerpoint/2010/main" val="1667817277"/>
       </p:ext>
     </p:extLst>
   </p:cSld>
@@ -1246,7 +1335,7 @@
           <a:bodyPr/>
           <a:lstStyle/>
           <a:p>
-            <a:fld id="{CB6D05BF-3823-4251-85D6-8F40948E3712}" type="slidenum">
+            <a:fld id="{4AA5213A-272A-46DE-A19A-34290041A493}" type="slidenum">
               <a:rPr lang="en-IN" smtClean="0"/>
               <a:t>2</a:t>
             </a:fld>
@@ -1257,7 +1346,7 @@
     </p:spTree>
     <p:extLst>
       <p:ext uri="{BB962C8B-B14F-4D97-AF65-F5344CB8AC3E}">
-        <p14:creationId xmlns:p14="http://schemas.microsoft.com/office/powerpoint/2010/main" val="1510356705"/>
+        <p14:creationId xmlns:p14="http://schemas.microsoft.com/office/powerpoint/2010/main" val="3201299443"/>
       </p:ext>
     </p:extLst>
   </p:cSld>
@@ -1333,7 +1422,7 @@
           <a:bodyPr/>
           <a:lstStyle/>
           <a:p>
-            <a:fld id="{CB6D05BF-3823-4251-85D6-8F40948E3712}" type="slidenum">
+            <a:fld id="{4AA5213A-272A-46DE-A19A-34290041A493}" type="slidenum">
               <a:rPr lang="en-IN" smtClean="0"/>
               <a:t>3</a:t>
             </a:fld>
@@ -1344,7 +1433,7 @@
     </p:spTree>
     <p:extLst>
       <p:ext uri="{BB962C8B-B14F-4D97-AF65-F5344CB8AC3E}">
-        <p14:creationId xmlns:p14="http://schemas.microsoft.com/office/powerpoint/2010/main" val="2884638227"/>
+        <p14:creationId xmlns:p14="http://schemas.microsoft.com/office/powerpoint/2010/main" val="864504012"/>
       </p:ext>
     </p:extLst>
   </p:cSld>
@@ -1421,7 +1510,7 @@
           <a:bodyPr/>
           <a:lstStyle/>
           <a:p>
-            <a:fld id="{CB6D05BF-3823-4251-85D6-8F40948E3712}" type="slidenum">
+            <a:fld id="{4AA5213A-272A-46DE-A19A-34290041A493}" type="slidenum">
               <a:rPr lang="en-IN" smtClean="0"/>
               <a:t>4</a:t>
             </a:fld>
@@ -1432,7 +1521,7 @@
     </p:spTree>
     <p:extLst>
       <p:ext uri="{BB962C8B-B14F-4D97-AF65-F5344CB8AC3E}">
-        <p14:creationId xmlns:p14="http://schemas.microsoft.com/office/powerpoint/2010/main" val="4069658076"/>
+        <p14:creationId xmlns:p14="http://schemas.microsoft.com/office/powerpoint/2010/main" val="2507618464"/>
       </p:ext>
     </p:extLst>
   </p:cSld>
@@ -1509,7 +1598,7 @@
           <a:bodyPr/>
           <a:lstStyle/>
           <a:p>
-            <a:fld id="{CB6D05BF-3823-4251-85D6-8F40948E3712}" type="slidenum">
+            <a:fld id="{4AA5213A-272A-46DE-A19A-34290041A493}" type="slidenum">
               <a:rPr lang="en-IN" smtClean="0"/>
               <a:t>5</a:t>
             </a:fld>
@@ -1520,7 +1609,7 @@
     </p:spTree>
     <p:extLst>
       <p:ext uri="{BB962C8B-B14F-4D97-AF65-F5344CB8AC3E}">
-        <p14:creationId xmlns:p14="http://schemas.microsoft.com/office/powerpoint/2010/main" val="2785798324"/>
+        <p14:creationId xmlns:p14="http://schemas.microsoft.com/office/powerpoint/2010/main" val="50751310"/>
       </p:ext>
     </p:extLst>
   </p:cSld>
@@ -1597,7 +1686,7 @@
           <a:bodyPr/>
           <a:lstStyle/>
           <a:p>
-            <a:fld id="{CB6D05BF-3823-4251-85D6-8F40948E3712}" type="slidenum">
+            <a:fld id="{4AA5213A-272A-46DE-A19A-34290041A493}" type="slidenum">
               <a:rPr lang="en-IN" smtClean="0"/>
               <a:t>6</a:t>
             </a:fld>
@@ -1608,7 +1697,7 @@
     </p:spTree>
     <p:extLst>
       <p:ext uri="{BB962C8B-B14F-4D97-AF65-F5344CB8AC3E}">
-        <p14:creationId xmlns:p14="http://schemas.microsoft.com/office/powerpoint/2010/main" val="1378751336"/>
+        <p14:creationId xmlns:p14="http://schemas.microsoft.com/office/powerpoint/2010/main" val="904135411"/>
       </p:ext>
     </p:extLst>
   </p:cSld>
@@ -1685,7 +1774,7 @@
           <a:bodyPr/>
           <a:lstStyle/>
           <a:p>
-            <a:fld id="{CB6D05BF-3823-4251-85D6-8F40948E3712}" type="slidenum">
+            <a:fld id="{4AA5213A-272A-46DE-A19A-34290041A493}" type="slidenum">
               <a:rPr lang="en-IN" smtClean="0"/>
               <a:t>7</a:t>
             </a:fld>
@@ -1696,7 +1785,7 @@
     </p:spTree>
     <p:extLst>
       <p:ext uri="{BB962C8B-B14F-4D97-AF65-F5344CB8AC3E}">
-        <p14:creationId xmlns:p14="http://schemas.microsoft.com/office/powerpoint/2010/main" val="2713292730"/>
+        <p14:creationId xmlns:p14="http://schemas.microsoft.com/office/powerpoint/2010/main" val="2450398750"/>
       </p:ext>
     </p:extLst>
   </p:cSld>
@@ -1773,7 +1862,7 @@
           <a:bodyPr/>
           <a:lstStyle/>
           <a:p>
-            <a:fld id="{CB6D05BF-3823-4251-85D6-8F40948E3712}" type="slidenum">
+            <a:fld id="{4AA5213A-272A-46DE-A19A-34290041A493}" type="slidenum">
               <a:rPr lang="en-IN" smtClean="0"/>
               <a:t>8</a:t>
             </a:fld>
@@ -1784,7 +1873,7 @@
     </p:spTree>
     <p:extLst>
       <p:ext uri="{BB962C8B-B14F-4D97-AF65-F5344CB8AC3E}">
-        <p14:creationId xmlns:p14="http://schemas.microsoft.com/office/powerpoint/2010/main" val="3950751163"/>
+        <p14:creationId xmlns:p14="http://schemas.microsoft.com/office/powerpoint/2010/main" val="4029942261"/>
       </p:ext>
     </p:extLst>
   </p:cSld>
@@ -1861,7 +1950,7 @@
           <a:bodyPr/>
           <a:lstStyle/>
           <a:p>
-            <a:fld id="{CB6D05BF-3823-4251-85D6-8F40948E3712}" type="slidenum">
+            <a:fld id="{4AA5213A-272A-46DE-A19A-34290041A493}" type="slidenum">
               <a:rPr lang="en-IN" smtClean="0"/>
               <a:t>9</a:t>
             </a:fld>
@@ -1872,7 +1961,7 @@
     </p:spTree>
     <p:extLst>
       <p:ext uri="{BB962C8B-B14F-4D97-AF65-F5344CB8AC3E}">
-        <p14:creationId xmlns:p14="http://schemas.microsoft.com/office/powerpoint/2010/main" val="3181840052"/>
+        <p14:creationId xmlns:p14="http://schemas.microsoft.com/office/powerpoint/2010/main" val="1013084671"/>
       </p:ext>
     </p:extLst>
   </p:cSld>
@@ -1904,7 +1993,7 @@
           <p:cNvPr id="2" name="Title 1">
             <a:extLst>
               <a:ext uri="{FF2B5EF4-FFF2-40B4-BE49-F238E27FC236}">
-                <a16:creationId xmlns:a16="http://schemas.microsoft.com/office/drawing/2014/main" id="{716E1839-1072-7A4C-2D15-0E56DE762A91}"/>
+                <a16:creationId xmlns:a16="http://schemas.microsoft.com/office/drawing/2014/main" id="{F481EC0F-7120-514A-8F49-A997FBADA31F}"/>
               </a:ext>
             </a:extLst>
           </p:cNvPr>
@@ -1942,7 +2031,7 @@
           <p:cNvPr id="3" name="Subtitle 2">
             <a:extLst>
               <a:ext uri="{FF2B5EF4-FFF2-40B4-BE49-F238E27FC236}">
-                <a16:creationId xmlns:a16="http://schemas.microsoft.com/office/drawing/2014/main" id="{958C9CD2-5793-CADE-5BDF-0EDDF318D910}"/>
+                <a16:creationId xmlns:a16="http://schemas.microsoft.com/office/drawing/2014/main" id="{491E7FF8-C664-9818-B1C1-44B09DCA81A1}"/>
               </a:ext>
             </a:extLst>
           </p:cNvPr>
@@ -2013,7 +2102,7 @@
           <p:cNvPr id="4" name="Date Placeholder 3">
             <a:extLst>
               <a:ext uri="{FF2B5EF4-FFF2-40B4-BE49-F238E27FC236}">
-                <a16:creationId xmlns:a16="http://schemas.microsoft.com/office/drawing/2014/main" id="{C7409789-81F8-7D59-1CD6-7CD2ECEBF96E}"/>
+                <a16:creationId xmlns:a16="http://schemas.microsoft.com/office/drawing/2014/main" id="{EA122A85-E50E-B6C1-55CB-983104B37036}"/>
               </a:ext>
             </a:extLst>
           </p:cNvPr>
@@ -2029,7 +2118,7 @@
           <a:bodyPr/>
           <a:lstStyle/>
           <a:p>
-            <a:fld id="{DDF74FE0-EBC5-4AB9-800B-A335A3F14358}" type="datetimeFigureOut">
+            <a:fld id="{E76C1D1B-AA06-4462-8688-FBED31F28147}" type="datetimeFigureOut">
               <a:rPr lang="en-IN" smtClean="0"/>
               <a:t>19-10-2026</a:t>
             </a:fld>
@@ -2042,7 +2131,7 @@
           <p:cNvPr id="5" name="Footer Placeholder 4">
             <a:extLst>
               <a:ext uri="{FF2B5EF4-FFF2-40B4-BE49-F238E27FC236}">
-                <a16:creationId xmlns:a16="http://schemas.microsoft.com/office/drawing/2014/main" id="{3CB5837B-90B8-A97E-536A-216B57C0542B}"/>
+                <a16:creationId xmlns:a16="http://schemas.microsoft.com/office/drawing/2014/main" id="{D21A4E10-B8BB-8588-4EEF-F3F72361960A}"/>
               </a:ext>
             </a:extLst>
           </p:cNvPr>
@@ -2067,7 +2156,7 @@
           <p:cNvPr id="6" name="Slide Number Placeholder 5">
             <a:extLst>
               <a:ext uri="{FF2B5EF4-FFF2-40B4-BE49-F238E27FC236}">
-                <a16:creationId xmlns:a16="http://schemas.microsoft.com/office/drawing/2014/main" id="{DBFC46DF-0B84-5467-E423-E5C925875079}"/>
+                <a16:creationId xmlns:a16="http://schemas.microsoft.com/office/drawing/2014/main" id="{B5C22462-5038-5229-C3C5-D64DB616C78F}"/>
               </a:ext>
             </a:extLst>
           </p:cNvPr>
@@ -2083,7 +2172,7 @@
           <a:bodyPr/>
           <a:lstStyle/>
           <a:p>
-            <a:fld id="{937938ED-2178-43B3-9AAE-1648119C4B05}" type="slidenum">
+            <a:fld id="{3A465F51-8CAF-4CA4-B81F-97E2B4F072C2}" type="slidenum">
               <a:rPr lang="en-IN" smtClean="0"/>
               <a:t>‹#›</a:t>
             </a:fld>
@@ -2094,7 +2183,7 @@
     </p:spTree>
     <p:extLst>
       <p:ext uri="{BB962C8B-B14F-4D97-AF65-F5344CB8AC3E}">
-        <p14:creationId xmlns:p14="http://schemas.microsoft.com/office/powerpoint/2010/main" val="875530539"/>
+        <p14:creationId xmlns:p14="http://schemas.microsoft.com/office/powerpoint/2010/main" val="3221950894"/>
       </p:ext>
     </p:extLst>
   </p:cSld>
@@ -2126,7 +2215,7 @@
           <p:cNvPr id="2" name="Title 1">
             <a:extLst>
               <a:ext uri="{FF2B5EF4-FFF2-40B4-BE49-F238E27FC236}">
-                <a16:creationId xmlns:a16="http://schemas.microsoft.com/office/drawing/2014/main" id="{197D6B74-C42C-BB25-F993-BD1D904CA05C}"/>
+                <a16:creationId xmlns:a16="http://schemas.microsoft.com/office/drawing/2014/main" id="{B0625B52-BBB6-F396-D12E-A5A3CF42B820}"/>
               </a:ext>
             </a:extLst>
           </p:cNvPr>
@@ -2155,7 +2244,7 @@
           <p:cNvPr id="3" name="Vertical Text Placeholder 2">
             <a:extLst>
               <a:ext uri="{FF2B5EF4-FFF2-40B4-BE49-F238E27FC236}">
-                <a16:creationId xmlns:a16="http://schemas.microsoft.com/office/drawing/2014/main" id="{1E102F80-0842-95B4-CA98-9821D94A7709}"/>
+                <a16:creationId xmlns:a16="http://schemas.microsoft.com/office/drawing/2014/main" id="{9C87811D-15D8-2E63-9951-AF6AC65269AE}"/>
               </a:ext>
             </a:extLst>
           </p:cNvPr>
@@ -2213,7 +2302,7 @@
           <p:cNvPr id="4" name="Date Placeholder 3">
             <a:extLst>
               <a:ext uri="{FF2B5EF4-FFF2-40B4-BE49-F238E27FC236}">
-                <a16:creationId xmlns:a16="http://schemas.microsoft.com/office/drawing/2014/main" id="{1497F151-1563-24F4-C39C-B7BC57FCD608}"/>
+                <a16:creationId xmlns:a16="http://schemas.microsoft.com/office/drawing/2014/main" id="{78058160-46E2-06D9-3645-485D8030144C}"/>
               </a:ext>
             </a:extLst>
           </p:cNvPr>
@@ -2229,7 +2318,7 @@
           <a:bodyPr/>
           <a:lstStyle/>
           <a:p>
-            <a:fld id="{DDF74FE0-EBC5-4AB9-800B-A335A3F14358}" type="datetimeFigureOut">
+            <a:fld id="{E76C1D1B-AA06-4462-8688-FBED31F28147}" type="datetimeFigureOut">
               <a:rPr lang="en-IN" smtClean="0"/>
               <a:t>19-10-2026</a:t>
             </a:fld>
@@ -2242,7 +2331,7 @@
           <p:cNvPr id="5" name="Footer Placeholder 4">
             <a:extLst>
               <a:ext uri="{FF2B5EF4-FFF2-40B4-BE49-F238E27FC236}">
-                <a16:creationId xmlns:a16="http://schemas.microsoft.com/office/drawing/2014/main" id="{B55E07A8-D1AB-FCDB-35F5-17583AF1DA31}"/>
+                <a16:creationId xmlns:a16="http://schemas.microsoft.com/office/drawing/2014/main" id="{CD74A6D5-C18C-C6E6-4761-885D2830B807}"/>
               </a:ext>
             </a:extLst>
           </p:cNvPr>
@@ -2267,7 +2356,7 @@
           <p:cNvPr id="6" name="Slide Number Placeholder 5">
             <a:extLst>
               <a:ext uri="{FF2B5EF4-FFF2-40B4-BE49-F238E27FC236}">
-                <a16:creationId xmlns:a16="http://schemas.microsoft.com/office/drawing/2014/main" id="{5AB74005-DA92-1D87-3E46-56465DE42343}"/>
+                <a16:creationId xmlns:a16="http://schemas.microsoft.com/office/drawing/2014/main" id="{F7FB4500-D7FB-1B19-C5EE-F114AF0720A6}"/>
               </a:ext>
             </a:extLst>
           </p:cNvPr>
@@ -2283,7 +2372,7 @@
           <a:bodyPr/>
           <a:lstStyle/>
           <a:p>
-            <a:fld id="{937938ED-2178-43B3-9AAE-1648119C4B05}" type="slidenum">
+            <a:fld id="{3A465F51-8CAF-4CA4-B81F-97E2B4F072C2}" type="slidenum">
               <a:rPr lang="en-IN" smtClean="0"/>
               <a:t>‹#›</a:t>
             </a:fld>
@@ -2294,7 +2383,7 @@
     </p:spTree>
     <p:extLst>
       <p:ext uri="{BB962C8B-B14F-4D97-AF65-F5344CB8AC3E}">
-        <p14:creationId xmlns:p14="http://schemas.microsoft.com/office/powerpoint/2010/main" val="638435247"/>
+        <p14:creationId xmlns:p14="http://schemas.microsoft.com/office/powerpoint/2010/main" val="3102081504"/>
       </p:ext>
     </p:extLst>
   </p:cSld>
@@ -2326,7 +2415,7 @@
           <p:cNvPr id="2" name="Vertical Title 1">
             <a:extLst>
               <a:ext uri="{FF2B5EF4-FFF2-40B4-BE49-F238E27FC236}">
-                <a16:creationId xmlns:a16="http://schemas.microsoft.com/office/drawing/2014/main" id="{AC75DA39-A18A-257C-FAB1-89C072B15CB1}"/>
+                <a16:creationId xmlns:a16="http://schemas.microsoft.com/office/drawing/2014/main" id="{CFC98674-F19F-9D15-B4CC-339B7440F265}"/>
               </a:ext>
             </a:extLst>
           </p:cNvPr>
@@ -2360,7 +2449,7 @@
           <p:cNvPr id="3" name="Vertical Text Placeholder 2">
             <a:extLst>
               <a:ext uri="{FF2B5EF4-FFF2-40B4-BE49-F238E27FC236}">
-                <a16:creationId xmlns:a16="http://schemas.microsoft.com/office/drawing/2014/main" id="{F1AEA553-26FB-E4C0-48A2-ADE4BBE19DD3}"/>
+                <a16:creationId xmlns:a16="http://schemas.microsoft.com/office/drawing/2014/main" id="{5E87178C-7669-D6CB-35C1-E5E998F03782}"/>
               </a:ext>
             </a:extLst>
           </p:cNvPr>
@@ -2423,7 +2512,7 @@
           <p:cNvPr id="4" name="Date Placeholder 3">
             <a:extLst>
               <a:ext uri="{FF2B5EF4-FFF2-40B4-BE49-F238E27FC236}">
-                <a16:creationId xmlns:a16="http://schemas.microsoft.com/office/drawing/2014/main" id="{E913954C-CFFF-6F6E-EFFC-078CF6808632}"/>
+                <a16:creationId xmlns:a16="http://schemas.microsoft.com/office/drawing/2014/main" id="{E5A105C8-4737-1F72-D9B1-9DC0A2A7C8F6}"/>
               </a:ext>
             </a:extLst>
           </p:cNvPr>
@@ -2439,7 +2528,7 @@
           <a:bodyPr/>
           <a:lstStyle/>
           <a:p>
-            <a:fld id="{DDF74FE0-EBC5-4AB9-800B-A335A3F14358}" type="datetimeFigureOut">
+            <a:fld id="{E76C1D1B-AA06-4462-8688-FBED31F28147}" type="datetimeFigureOut">
               <a:rPr lang="en-IN" smtClean="0"/>
               <a:t>19-10-2026</a:t>
             </a:fld>
@@ -2452,7 +2541,7 @@
           <p:cNvPr id="5" name="Footer Placeholder 4">
             <a:extLst>
               <a:ext uri="{FF2B5EF4-FFF2-40B4-BE49-F238E27FC236}">
-                <a16:creationId xmlns:a16="http://schemas.microsoft.com/office/drawing/2014/main" id="{F5C86339-98F0-7C36-60A3-999CEBE3FF6B}"/>
+                <a16:creationId xmlns:a16="http://schemas.microsoft.com/office/drawing/2014/main" id="{ECF44B8D-6392-93FF-4E29-0C906AEC7884}"/>
               </a:ext>
             </a:extLst>
           </p:cNvPr>
@@ -2477,7 +2566,7 @@
           <p:cNvPr id="6" name="Slide Number Placeholder 5">
             <a:extLst>
               <a:ext uri="{FF2B5EF4-FFF2-40B4-BE49-F238E27FC236}">
-                <a16:creationId xmlns:a16="http://schemas.microsoft.com/office/drawing/2014/main" id="{1359C2F5-1633-4372-5881-C9AA6C02A969}"/>
+                <a16:creationId xmlns:a16="http://schemas.microsoft.com/office/drawing/2014/main" id="{8D7CF9FF-4779-CAEF-E91D-6F0F3FDC138F}"/>
               </a:ext>
             </a:extLst>
           </p:cNvPr>
@@ -2493,7 +2582,7 @@
           <a:bodyPr/>
           <a:lstStyle/>
           <a:p>
-            <a:fld id="{937938ED-2178-43B3-9AAE-1648119C4B05}" type="slidenum">
+            <a:fld id="{3A465F51-8CAF-4CA4-B81F-97E2B4F072C2}" type="slidenum">
               <a:rPr lang="en-IN" smtClean="0"/>
               <a:t>‹#›</a:t>
             </a:fld>
@@ -2504,7 +2593,7 @@
     </p:spTree>
     <p:extLst>
       <p:ext uri="{BB962C8B-B14F-4D97-AF65-F5344CB8AC3E}">
-        <p14:creationId xmlns:p14="http://schemas.microsoft.com/office/powerpoint/2010/main" val="2139768494"/>
+        <p14:creationId xmlns:p14="http://schemas.microsoft.com/office/powerpoint/2010/main" val="385738295"/>
       </p:ext>
     </p:extLst>
   </p:cSld>
@@ -2536,7 +2625,7 @@
           <p:cNvPr id="2" name="Title 1">
             <a:extLst>
               <a:ext uri="{FF2B5EF4-FFF2-40B4-BE49-F238E27FC236}">
-                <a16:creationId xmlns:a16="http://schemas.microsoft.com/office/drawing/2014/main" id="{C546E4BA-E18C-F385-6FA9-05CCC4581F4D}"/>
+                <a16:creationId xmlns:a16="http://schemas.microsoft.com/office/drawing/2014/main" id="{8090D4BE-60E8-235A-190A-EA41B3A8D415}"/>
               </a:ext>
             </a:extLst>
           </p:cNvPr>
@@ -2565,7 +2654,7 @@
           <p:cNvPr id="3" name="Content Placeholder 2">
             <a:extLst>
               <a:ext uri="{FF2B5EF4-FFF2-40B4-BE49-F238E27FC236}">
-                <a16:creationId xmlns:a16="http://schemas.microsoft.com/office/drawing/2014/main" id="{59374049-31BC-9B20-9CC9-B0DED08E7DB6}"/>
+                <a16:creationId xmlns:a16="http://schemas.microsoft.com/office/drawing/2014/main" id="{E0F75527-3256-6DE3-4EE2-0161C0482179}"/>
               </a:ext>
             </a:extLst>
           </p:cNvPr>
@@ -2623,7 +2712,7 @@
           <p:cNvPr id="4" name="Date Placeholder 3">
             <a:extLst>
               <a:ext uri="{FF2B5EF4-FFF2-40B4-BE49-F238E27FC236}">
-                <a16:creationId xmlns:a16="http://schemas.microsoft.com/office/drawing/2014/main" id="{C70D595A-B3A4-B8C5-2AA7-EB25B2F0747B}"/>
+                <a16:creationId xmlns:a16="http://schemas.microsoft.com/office/drawing/2014/main" id="{45FABFEB-B6D0-D0A5-024A-4F5E9225A8F0}"/>
               </a:ext>
             </a:extLst>
           </p:cNvPr>
@@ -2639,7 +2728,7 @@
           <a:bodyPr/>
           <a:lstStyle/>
           <a:p>
-            <a:fld id="{DDF74FE0-EBC5-4AB9-800B-A335A3F14358}" type="datetimeFigureOut">
+            <a:fld id="{E76C1D1B-AA06-4462-8688-FBED31F28147}" type="datetimeFigureOut">
               <a:rPr lang="en-IN" smtClean="0"/>
               <a:t>19-10-2026</a:t>
             </a:fld>
@@ -2652,7 +2741,7 @@
           <p:cNvPr id="5" name="Footer Placeholder 4">
             <a:extLst>
               <a:ext uri="{FF2B5EF4-FFF2-40B4-BE49-F238E27FC236}">
-                <a16:creationId xmlns:a16="http://schemas.microsoft.com/office/drawing/2014/main" id="{84D3E644-AFA2-B637-4119-4C938D31322F}"/>
+                <a16:creationId xmlns:a16="http://schemas.microsoft.com/office/drawing/2014/main" id="{5109E4CC-52D8-49D6-1416-E4467DB3E11C}"/>
               </a:ext>
             </a:extLst>
           </p:cNvPr>
@@ -2677,7 +2766,7 @@
           <p:cNvPr id="6" name="Slide Number Placeholder 5">
             <a:extLst>
               <a:ext uri="{FF2B5EF4-FFF2-40B4-BE49-F238E27FC236}">
-                <a16:creationId xmlns:a16="http://schemas.microsoft.com/office/drawing/2014/main" id="{8C673581-0ECE-F0B1-A568-2489AFD3CAAE}"/>
+                <a16:creationId xmlns:a16="http://schemas.microsoft.com/office/drawing/2014/main" id="{D165522A-F974-011B-F7F2-C14AB7C54D7A}"/>
               </a:ext>
             </a:extLst>
           </p:cNvPr>
@@ -2693,7 +2782,7 @@
           <a:bodyPr/>
           <a:lstStyle/>
           <a:p>
-            <a:fld id="{937938ED-2178-43B3-9AAE-1648119C4B05}" type="slidenum">
+            <a:fld id="{3A465F51-8CAF-4CA4-B81F-97E2B4F072C2}" type="slidenum">
               <a:rPr lang="en-IN" smtClean="0"/>
               <a:t>‹#›</a:t>
             </a:fld>
@@ -2704,7 +2793,7 @@
     </p:spTree>
     <p:extLst>
       <p:ext uri="{BB962C8B-B14F-4D97-AF65-F5344CB8AC3E}">
-        <p14:creationId xmlns:p14="http://schemas.microsoft.com/office/powerpoint/2010/main" val="2935971010"/>
+        <p14:creationId xmlns:p14="http://schemas.microsoft.com/office/powerpoint/2010/main" val="4181409426"/>
       </p:ext>
     </p:extLst>
   </p:cSld>
@@ -2736,7 +2825,7 @@
           <p:cNvPr id="2" name="Title 1">
             <a:extLst>
               <a:ext uri="{FF2B5EF4-FFF2-40B4-BE49-F238E27FC236}">
-                <a16:creationId xmlns:a16="http://schemas.microsoft.com/office/drawing/2014/main" id="{7BDD5B24-70B0-E62B-77F8-1ED20A996A75}"/>
+                <a16:creationId xmlns:a16="http://schemas.microsoft.com/office/drawing/2014/main" id="{E043EAEA-B0C7-3E07-5FF3-CA088E9CB4E8}"/>
               </a:ext>
             </a:extLst>
           </p:cNvPr>
@@ -2774,7 +2863,7 @@
           <p:cNvPr id="3" name="Text Placeholder 2">
             <a:extLst>
               <a:ext uri="{FF2B5EF4-FFF2-40B4-BE49-F238E27FC236}">
-                <a16:creationId xmlns:a16="http://schemas.microsoft.com/office/drawing/2014/main" id="{46111E76-6FDF-1E45-BD50-BF45A6DD96F7}"/>
+                <a16:creationId xmlns:a16="http://schemas.microsoft.com/office/drawing/2014/main" id="{5C07B916-2EF4-B9EA-04CB-635DFC61E041}"/>
               </a:ext>
             </a:extLst>
           </p:cNvPr>
@@ -2899,7 +2988,7 @@
           <p:cNvPr id="4" name="Date Placeholder 3">
             <a:extLst>
               <a:ext uri="{FF2B5EF4-FFF2-40B4-BE49-F238E27FC236}">
-                <a16:creationId xmlns:a16="http://schemas.microsoft.com/office/drawing/2014/main" id="{A8D4240D-854D-28C5-F473-1CB104CD1230}"/>
+                <a16:creationId xmlns:a16="http://schemas.microsoft.com/office/drawing/2014/main" id="{4A2580D5-BC59-0A73-CCB5-AAC894ABE22E}"/>
               </a:ext>
             </a:extLst>
           </p:cNvPr>
@@ -2915,7 +3004,7 @@
           <a:bodyPr/>
           <a:lstStyle/>
           <a:p>
-            <a:fld id="{DDF74FE0-EBC5-4AB9-800B-A335A3F14358}" type="datetimeFigureOut">
+            <a:fld id="{E76C1D1B-AA06-4462-8688-FBED31F28147}" type="datetimeFigureOut">
               <a:rPr lang="en-IN" smtClean="0"/>
               <a:t>19-10-2026</a:t>
             </a:fld>
@@ -2928,7 +3017,7 @@
           <p:cNvPr id="5" name="Footer Placeholder 4">
             <a:extLst>
               <a:ext uri="{FF2B5EF4-FFF2-40B4-BE49-F238E27FC236}">
-                <a16:creationId xmlns:a16="http://schemas.microsoft.com/office/drawing/2014/main" id="{47F1E4DD-26A2-6215-D336-3FE193C0357E}"/>
+                <a16:creationId xmlns:a16="http://schemas.microsoft.com/office/drawing/2014/main" id="{24A00842-BE5A-C3FF-8F67-6D5A45466C21}"/>
               </a:ext>
             </a:extLst>
           </p:cNvPr>
@@ -2953,7 +3042,7 @@
           <p:cNvPr id="6" name="Slide Number Placeholder 5">
             <a:extLst>
               <a:ext uri="{FF2B5EF4-FFF2-40B4-BE49-F238E27FC236}">
-                <a16:creationId xmlns:a16="http://schemas.microsoft.com/office/drawing/2014/main" id="{6ECC9CA8-1873-7F27-C009-628D7A4DC97D}"/>
+                <a16:creationId xmlns:a16="http://schemas.microsoft.com/office/drawing/2014/main" id="{883D34F2-5435-D072-D47D-BCD076D5E04C}"/>
               </a:ext>
             </a:extLst>
           </p:cNvPr>
@@ -2969,7 +3058,7 @@
           <a:bodyPr/>
           <a:lstStyle/>
           <a:p>
-            <a:fld id="{937938ED-2178-43B3-9AAE-1648119C4B05}" type="slidenum">
+            <a:fld id="{3A465F51-8CAF-4CA4-B81F-97E2B4F072C2}" type="slidenum">
               <a:rPr lang="en-IN" smtClean="0"/>
               <a:t>‹#›</a:t>
             </a:fld>
@@ -2980,7 +3069,7 @@
     </p:spTree>
     <p:extLst>
       <p:ext uri="{BB962C8B-B14F-4D97-AF65-F5344CB8AC3E}">
-        <p14:creationId xmlns:p14="http://schemas.microsoft.com/office/powerpoint/2010/main" val="419232040"/>
+        <p14:creationId xmlns:p14="http://schemas.microsoft.com/office/powerpoint/2010/main" val="1588132546"/>
       </p:ext>
     </p:extLst>
   </p:cSld>
@@ -3012,7 +3101,7 @@
           <p:cNvPr id="2" name="Title 1">
             <a:extLst>
               <a:ext uri="{FF2B5EF4-FFF2-40B4-BE49-F238E27FC236}">
-                <a16:creationId xmlns:a16="http://schemas.microsoft.com/office/drawing/2014/main" id="{9B83FB1A-5C36-F56A-3280-05D03E966616}"/>
+                <a16:creationId xmlns:a16="http://schemas.microsoft.com/office/drawing/2014/main" id="{7960E171-542C-A5A8-0A10-B4E09F902D78}"/>
               </a:ext>
             </a:extLst>
           </p:cNvPr>
@@ -3041,7 +3130,7 @@
           <p:cNvPr id="3" name="Content Placeholder 2">
             <a:extLst>
               <a:ext uri="{FF2B5EF4-FFF2-40B4-BE49-F238E27FC236}">
-                <a16:creationId xmlns:a16="http://schemas.microsoft.com/office/drawing/2014/main" id="{39397153-FAF2-C048-2150-C094CB46595D}"/>
+                <a16:creationId xmlns:a16="http://schemas.microsoft.com/office/drawing/2014/main" id="{A94181B6-EA6F-B186-0702-772E0D57253D}"/>
               </a:ext>
             </a:extLst>
           </p:cNvPr>
@@ -3104,7 +3193,7 @@
           <p:cNvPr id="4" name="Content Placeholder 3">
             <a:extLst>
               <a:ext uri="{FF2B5EF4-FFF2-40B4-BE49-F238E27FC236}">
-                <a16:creationId xmlns:a16="http://schemas.microsoft.com/office/drawing/2014/main" id="{E89D5A36-93C7-1274-60BE-960883F3BB1E}"/>
+                <a16:creationId xmlns:a16="http://schemas.microsoft.com/office/drawing/2014/main" id="{BAFC398C-8661-D019-C3F4-4A976E2A64DA}"/>
               </a:ext>
             </a:extLst>
           </p:cNvPr>
@@ -3167,7 +3256,7 @@
           <p:cNvPr id="5" name="Date Placeholder 4">
             <a:extLst>
               <a:ext uri="{FF2B5EF4-FFF2-40B4-BE49-F238E27FC236}">
-                <a16:creationId xmlns:a16="http://schemas.microsoft.com/office/drawing/2014/main" id="{1FD054BA-7E9F-18CF-35DC-5740185E8B6C}"/>
+                <a16:creationId xmlns:a16="http://schemas.microsoft.com/office/drawing/2014/main" id="{7B59C235-830A-33D0-B137-4874C98ECD57}"/>
               </a:ext>
             </a:extLst>
           </p:cNvPr>
@@ -3183,7 +3272,7 @@
           <a:bodyPr/>
           <a:lstStyle/>
           <a:p>
-            <a:fld id="{DDF74FE0-EBC5-4AB9-800B-A335A3F14358}" type="datetimeFigureOut">
+            <a:fld id="{E76C1D1B-AA06-4462-8688-FBED31F28147}" type="datetimeFigureOut">
               <a:rPr lang="en-IN" smtClean="0"/>
               <a:t>19-10-2026</a:t>
             </a:fld>
@@ -3196,7 +3285,7 @@
           <p:cNvPr id="6" name="Footer Placeholder 5">
             <a:extLst>
               <a:ext uri="{FF2B5EF4-FFF2-40B4-BE49-F238E27FC236}">
-                <a16:creationId xmlns:a16="http://schemas.microsoft.com/office/drawing/2014/main" id="{83741CB5-1DF8-6133-8367-DBD600E9682E}"/>
+                <a16:creationId xmlns:a16="http://schemas.microsoft.com/office/drawing/2014/main" id="{DEA1105E-EA44-A3C4-20DE-5CF58D6B5C2F}"/>
               </a:ext>
             </a:extLst>
           </p:cNvPr>
@@ -3221,7 +3310,7 @@
           <p:cNvPr id="7" name="Slide Number Placeholder 6">
             <a:extLst>
               <a:ext uri="{FF2B5EF4-FFF2-40B4-BE49-F238E27FC236}">
-                <a16:creationId xmlns:a16="http://schemas.microsoft.com/office/drawing/2014/main" id="{691044BB-D95A-5721-CC29-1152D9B34110}"/>
+                <a16:creationId xmlns:a16="http://schemas.microsoft.com/office/drawing/2014/main" id="{048C5936-9FDC-26DF-8E45-85F8450B1254}"/>
               </a:ext>
             </a:extLst>
           </p:cNvPr>
@@ -3237,7 +3326,7 @@
           <a:bodyPr/>
           <a:lstStyle/>
           <a:p>
-            <a:fld id="{937938ED-2178-43B3-9AAE-1648119C4B05}" type="slidenum">
+            <a:fld id="{3A465F51-8CAF-4CA4-B81F-97E2B4F072C2}" type="slidenum">
               <a:rPr lang="en-IN" smtClean="0"/>
               <a:t>‹#›</a:t>
             </a:fld>
@@ -3248,7 +3337,7 @@
     </p:spTree>
     <p:extLst>
       <p:ext uri="{BB962C8B-B14F-4D97-AF65-F5344CB8AC3E}">
-        <p14:creationId xmlns:p14="http://schemas.microsoft.com/office/powerpoint/2010/main" val="3761249564"/>
+        <p14:creationId xmlns:p14="http://schemas.microsoft.com/office/powerpoint/2010/main" val="4146848975"/>
       </p:ext>
     </p:extLst>
   </p:cSld>
@@ -3280,7 +3369,7 @@
           <p:cNvPr id="2" name="Title 1">
             <a:extLst>
               <a:ext uri="{FF2B5EF4-FFF2-40B4-BE49-F238E27FC236}">
-                <a16:creationId xmlns:a16="http://schemas.microsoft.com/office/drawing/2014/main" id="{5332D856-4E70-D7A6-B7A8-D0A1491F86A0}"/>
+                <a16:creationId xmlns:a16="http://schemas.microsoft.com/office/drawing/2014/main" id="{060C36B3-B242-5C90-3C70-F26ABBFFBDB6}"/>
               </a:ext>
             </a:extLst>
           </p:cNvPr>
@@ -3314,7 +3403,7 @@
           <p:cNvPr id="3" name="Text Placeholder 2">
             <a:extLst>
               <a:ext uri="{FF2B5EF4-FFF2-40B4-BE49-F238E27FC236}">
-                <a16:creationId xmlns:a16="http://schemas.microsoft.com/office/drawing/2014/main" id="{A1ED72D7-1537-C151-6661-F4C47FC83DAD}"/>
+                <a16:creationId xmlns:a16="http://schemas.microsoft.com/office/drawing/2014/main" id="{A2857304-C8F2-CC8A-5B92-7795EEBBE454}"/>
               </a:ext>
             </a:extLst>
           </p:cNvPr>
@@ -3385,7 +3474,7 @@
           <p:cNvPr id="4" name="Content Placeholder 3">
             <a:extLst>
               <a:ext uri="{FF2B5EF4-FFF2-40B4-BE49-F238E27FC236}">
-                <a16:creationId xmlns:a16="http://schemas.microsoft.com/office/drawing/2014/main" id="{926F7022-DBE2-4700-D0EC-65E922AF0BB1}"/>
+                <a16:creationId xmlns:a16="http://schemas.microsoft.com/office/drawing/2014/main" id="{EBEBDF62-69E0-A7B4-C293-029E19DC749E}"/>
               </a:ext>
             </a:extLst>
           </p:cNvPr>
@@ -3448,7 +3537,7 @@
           <p:cNvPr id="5" name="Text Placeholder 4">
             <a:extLst>
               <a:ext uri="{FF2B5EF4-FFF2-40B4-BE49-F238E27FC236}">
-                <a16:creationId xmlns:a16="http://schemas.microsoft.com/office/drawing/2014/main" id="{7A9BE0F4-083D-B399-6B9C-99D005D8A1F7}"/>
+                <a16:creationId xmlns:a16="http://schemas.microsoft.com/office/drawing/2014/main" id="{FE69FAD4-746C-2697-0BA7-53199275EB8A}"/>
               </a:ext>
             </a:extLst>
           </p:cNvPr>
@@ -3519,7 +3608,7 @@
           <p:cNvPr id="6" name="Content Placeholder 5">
             <a:extLst>
               <a:ext uri="{FF2B5EF4-FFF2-40B4-BE49-F238E27FC236}">
-                <a16:creationId xmlns:a16="http://schemas.microsoft.com/office/drawing/2014/main" id="{AEDDB603-514C-9943-714B-4A00058D414D}"/>
+                <a16:creationId xmlns:a16="http://schemas.microsoft.com/office/drawing/2014/main" id="{98B45219-90A8-5C50-B01D-033830FA8D28}"/>
               </a:ext>
             </a:extLst>
           </p:cNvPr>
@@ -3582,7 +3671,7 @@
           <p:cNvPr id="7" name="Date Placeholder 6">
             <a:extLst>
               <a:ext uri="{FF2B5EF4-FFF2-40B4-BE49-F238E27FC236}">
-                <a16:creationId xmlns:a16="http://schemas.microsoft.com/office/drawing/2014/main" id="{4F279CAF-656E-7442-8FAC-111B1EC7C478}"/>
+                <a16:creationId xmlns:a16="http://schemas.microsoft.com/office/drawing/2014/main" id="{FC21A295-20E0-82C6-3957-E25FE9445FF6}"/>
               </a:ext>
             </a:extLst>
           </p:cNvPr>
@@ -3598,7 +3687,7 @@
           <a:bodyPr/>
           <a:lstStyle/>
           <a:p>
-            <a:fld id="{DDF74FE0-EBC5-4AB9-800B-A335A3F14358}" type="datetimeFigureOut">
+            <a:fld id="{E76C1D1B-AA06-4462-8688-FBED31F28147}" type="datetimeFigureOut">
               <a:rPr lang="en-IN" smtClean="0"/>
               <a:t>19-10-2026</a:t>
             </a:fld>
@@ -3611,7 +3700,7 @@
           <p:cNvPr id="8" name="Footer Placeholder 7">
             <a:extLst>
               <a:ext uri="{FF2B5EF4-FFF2-40B4-BE49-F238E27FC236}">
-                <a16:creationId xmlns:a16="http://schemas.microsoft.com/office/drawing/2014/main" id="{17AC5EE4-8A79-B4EC-C29D-A077EA258042}"/>
+                <a16:creationId xmlns:a16="http://schemas.microsoft.com/office/drawing/2014/main" id="{1415EE14-FF03-61CF-0C53-7DD9C104FF1D}"/>
               </a:ext>
             </a:extLst>
           </p:cNvPr>
@@ -3636,7 +3725,7 @@
           <p:cNvPr id="9" name="Slide Number Placeholder 8">
             <a:extLst>
               <a:ext uri="{FF2B5EF4-FFF2-40B4-BE49-F238E27FC236}">
-                <a16:creationId xmlns:a16="http://schemas.microsoft.com/office/drawing/2014/main" id="{DCAF8873-4FD6-DBCD-51F8-B0CB069C9755}"/>
+                <a16:creationId xmlns:a16="http://schemas.microsoft.com/office/drawing/2014/main" id="{CFC3DD40-7048-5588-0370-67DEC622C548}"/>
               </a:ext>
             </a:extLst>
           </p:cNvPr>
@@ -3652,7 +3741,7 @@
           <a:bodyPr/>
           <a:lstStyle/>
           <a:p>
-            <a:fld id="{937938ED-2178-43B3-9AAE-1648119C4B05}" type="slidenum">
+            <a:fld id="{3A465F51-8CAF-4CA4-B81F-97E2B4F072C2}" type="slidenum">
               <a:rPr lang="en-IN" smtClean="0"/>
               <a:t>‹#›</a:t>
             </a:fld>
@@ -3663,7 +3752,7 @@
     </p:spTree>
     <p:extLst>
       <p:ext uri="{BB962C8B-B14F-4D97-AF65-F5344CB8AC3E}">
-        <p14:creationId xmlns:p14="http://schemas.microsoft.com/office/powerpoint/2010/main" val="4212934535"/>
+        <p14:creationId xmlns:p14="http://schemas.microsoft.com/office/powerpoint/2010/main" val="1639068902"/>
       </p:ext>
     </p:extLst>
   </p:cSld>
@@ -3695,7 +3784,7 @@
           <p:cNvPr id="2" name="Title 1">
             <a:extLst>
               <a:ext uri="{FF2B5EF4-FFF2-40B4-BE49-F238E27FC236}">
-                <a16:creationId xmlns:a16="http://schemas.microsoft.com/office/drawing/2014/main" id="{C3F2EB36-9AA5-4E32-525C-9BC8F998E0FB}"/>
+                <a16:creationId xmlns:a16="http://schemas.microsoft.com/office/drawing/2014/main" id="{70106098-9544-AD2B-E8D6-117B313BA5FD}"/>
               </a:ext>
             </a:extLst>
           </p:cNvPr>
@@ -3724,7 +3813,7 @@
           <p:cNvPr id="3" name="Date Placeholder 2">
             <a:extLst>
               <a:ext uri="{FF2B5EF4-FFF2-40B4-BE49-F238E27FC236}">
-                <a16:creationId xmlns:a16="http://schemas.microsoft.com/office/drawing/2014/main" id="{7793E4B8-9D2E-0387-88BE-41905B369BB3}"/>
+                <a16:creationId xmlns:a16="http://schemas.microsoft.com/office/drawing/2014/main" id="{B4E4F078-BBBF-2A9E-B202-A35BDE64D079}"/>
               </a:ext>
             </a:extLst>
           </p:cNvPr>
@@ -3740,7 +3829,7 @@
           <a:bodyPr/>
           <a:lstStyle/>
           <a:p>
-            <a:fld id="{DDF74FE0-EBC5-4AB9-800B-A335A3F14358}" type="datetimeFigureOut">
+            <a:fld id="{E76C1D1B-AA06-4462-8688-FBED31F28147}" type="datetimeFigureOut">
               <a:rPr lang="en-IN" smtClean="0"/>
               <a:t>19-10-2026</a:t>
             </a:fld>
@@ -3753,7 +3842,7 @@
           <p:cNvPr id="4" name="Footer Placeholder 3">
             <a:extLst>
               <a:ext uri="{FF2B5EF4-FFF2-40B4-BE49-F238E27FC236}">
-                <a16:creationId xmlns:a16="http://schemas.microsoft.com/office/drawing/2014/main" id="{F4F92089-0110-EA24-78B2-ED1589208531}"/>
+                <a16:creationId xmlns:a16="http://schemas.microsoft.com/office/drawing/2014/main" id="{75D3D041-4580-3A0D-BD4B-00DE3E786978}"/>
               </a:ext>
             </a:extLst>
           </p:cNvPr>
@@ -3778,7 +3867,7 @@
           <p:cNvPr id="5" name="Slide Number Placeholder 4">
             <a:extLst>
               <a:ext uri="{FF2B5EF4-FFF2-40B4-BE49-F238E27FC236}">
-                <a16:creationId xmlns:a16="http://schemas.microsoft.com/office/drawing/2014/main" id="{5084F1AA-3F7D-243F-149D-7874AB6C7DF8}"/>
+                <a16:creationId xmlns:a16="http://schemas.microsoft.com/office/drawing/2014/main" id="{E78875B9-E67A-3C22-EF2B-6B8FBB204F0B}"/>
               </a:ext>
             </a:extLst>
           </p:cNvPr>
@@ -3794,7 +3883,7 @@
           <a:bodyPr/>
           <a:lstStyle/>
           <a:p>
-            <a:fld id="{937938ED-2178-43B3-9AAE-1648119C4B05}" type="slidenum">
+            <a:fld id="{3A465F51-8CAF-4CA4-B81F-97E2B4F072C2}" type="slidenum">
               <a:rPr lang="en-IN" smtClean="0"/>
               <a:t>‹#›</a:t>
             </a:fld>
@@ -3805,7 +3894,7 @@
     </p:spTree>
     <p:extLst>
       <p:ext uri="{BB962C8B-B14F-4D97-AF65-F5344CB8AC3E}">
-        <p14:creationId xmlns:p14="http://schemas.microsoft.com/office/powerpoint/2010/main" val="1447700378"/>
+        <p14:creationId xmlns:p14="http://schemas.microsoft.com/office/powerpoint/2010/main" val="488765615"/>
       </p:ext>
     </p:extLst>
   </p:cSld>
@@ -3837,7 +3926,7 @@
           <p:cNvPr id="2" name="Date Placeholder 1">
             <a:extLst>
               <a:ext uri="{FF2B5EF4-FFF2-40B4-BE49-F238E27FC236}">
-                <a16:creationId xmlns:a16="http://schemas.microsoft.com/office/drawing/2014/main" id="{9136E848-83C7-8824-3787-BA012C0C1EEA}"/>
+                <a16:creationId xmlns:a16="http://schemas.microsoft.com/office/drawing/2014/main" id="{A39D0E0A-3314-27A2-83A4-738DFC77C56B}"/>
               </a:ext>
             </a:extLst>
           </p:cNvPr>
@@ -3853,7 +3942,7 @@
           <a:bodyPr/>
           <a:lstStyle/>
           <a:p>
-            <a:fld id="{DDF74FE0-EBC5-4AB9-800B-A335A3F14358}" type="datetimeFigureOut">
+            <a:fld id="{E76C1D1B-AA06-4462-8688-FBED31F28147}" type="datetimeFigureOut">
               <a:rPr lang="en-IN" smtClean="0"/>
               <a:t>19-10-2026</a:t>
             </a:fld>
@@ -3866,7 +3955,7 @@
           <p:cNvPr id="3" name="Footer Placeholder 2">
             <a:extLst>
               <a:ext uri="{FF2B5EF4-FFF2-40B4-BE49-F238E27FC236}">
-                <a16:creationId xmlns:a16="http://schemas.microsoft.com/office/drawing/2014/main" id="{EF2598AE-3ECB-A026-C5BA-8485B15A4896}"/>
+                <a16:creationId xmlns:a16="http://schemas.microsoft.com/office/drawing/2014/main" id="{056F6249-FB37-F794-0563-FBE6EFE13F39}"/>
               </a:ext>
             </a:extLst>
           </p:cNvPr>
@@ -3891,7 +3980,7 @@
           <p:cNvPr id="4" name="Slide Number Placeholder 3">
             <a:extLst>
               <a:ext uri="{FF2B5EF4-FFF2-40B4-BE49-F238E27FC236}">
-                <a16:creationId xmlns:a16="http://schemas.microsoft.com/office/drawing/2014/main" id="{E6D6FB99-65E0-5A40-BFC0-1BBB89FE8E20}"/>
+                <a16:creationId xmlns:a16="http://schemas.microsoft.com/office/drawing/2014/main" id="{2DFF9891-773F-5281-3EB9-584D3A71500B}"/>
               </a:ext>
             </a:extLst>
           </p:cNvPr>
@@ -3907,7 +3996,7 @@
           <a:bodyPr/>
           <a:lstStyle/>
           <a:p>
-            <a:fld id="{937938ED-2178-43B3-9AAE-1648119C4B05}" type="slidenum">
+            <a:fld id="{3A465F51-8CAF-4CA4-B81F-97E2B4F072C2}" type="slidenum">
               <a:rPr lang="en-IN" smtClean="0"/>
               <a:t>‹#›</a:t>
             </a:fld>
@@ -3918,7 +4007,7 @@
     </p:spTree>
     <p:extLst>
       <p:ext uri="{BB962C8B-B14F-4D97-AF65-F5344CB8AC3E}">
-        <p14:creationId xmlns:p14="http://schemas.microsoft.com/office/powerpoint/2010/main" val="3663843266"/>
+        <p14:creationId xmlns:p14="http://schemas.microsoft.com/office/powerpoint/2010/main" val="1606054591"/>
       </p:ext>
     </p:extLst>
   </p:cSld>
@@ -3950,7 +4039,7 @@
           <p:cNvPr id="2" name="Title 1">
             <a:extLst>
               <a:ext uri="{FF2B5EF4-FFF2-40B4-BE49-F238E27FC236}">
-                <a16:creationId xmlns:a16="http://schemas.microsoft.com/office/drawing/2014/main" id="{C3DDFAC1-8FF1-6E12-9287-26821641BD73}"/>
+                <a16:creationId xmlns:a16="http://schemas.microsoft.com/office/drawing/2014/main" id="{CA0759EB-FF34-EFA3-D28D-1AF68A428827}"/>
               </a:ext>
             </a:extLst>
           </p:cNvPr>
@@ -3988,7 +4077,7 @@
           <p:cNvPr id="3" name="Content Placeholder 2">
             <a:extLst>
               <a:ext uri="{FF2B5EF4-FFF2-40B4-BE49-F238E27FC236}">
-                <a16:creationId xmlns:a16="http://schemas.microsoft.com/office/drawing/2014/main" id="{4CB339A6-0CE1-C3C8-1D53-41638E42DCD4}"/>
+                <a16:creationId xmlns:a16="http://schemas.microsoft.com/office/drawing/2014/main" id="{783D45A6-B26F-DC44-B07E-24DC1BAEA426}"/>
               </a:ext>
             </a:extLst>
           </p:cNvPr>
@@ -4079,7 +4168,7 @@
           <p:cNvPr id="4" name="Text Placeholder 3">
             <a:extLst>
               <a:ext uri="{FF2B5EF4-FFF2-40B4-BE49-F238E27FC236}">
-                <a16:creationId xmlns:a16="http://schemas.microsoft.com/office/drawing/2014/main" id="{DFF9F2B1-FE21-907F-2BBA-26250902752E}"/>
+                <a16:creationId xmlns:a16="http://schemas.microsoft.com/office/drawing/2014/main" id="{8891B74B-843D-DDB7-C2C3-A34AAAF0B65B}"/>
               </a:ext>
             </a:extLst>
           </p:cNvPr>
@@ -4150,7 +4239,7 @@
           <p:cNvPr id="5" name="Date Placeholder 4">
             <a:extLst>
               <a:ext uri="{FF2B5EF4-FFF2-40B4-BE49-F238E27FC236}">
-                <a16:creationId xmlns:a16="http://schemas.microsoft.com/office/drawing/2014/main" id="{12385E95-8A70-DED0-4A2E-3F27278ACFC9}"/>
+                <a16:creationId xmlns:a16="http://schemas.microsoft.com/office/drawing/2014/main" id="{410222DD-ACE3-4D6C-E5C0-B5819DA87812}"/>
               </a:ext>
             </a:extLst>
           </p:cNvPr>
@@ -4166,7 +4255,7 @@
           <a:bodyPr/>
           <a:lstStyle/>
           <a:p>
-            <a:fld id="{DDF74FE0-EBC5-4AB9-800B-A335A3F14358}" type="datetimeFigureOut">
+            <a:fld id="{E76C1D1B-AA06-4462-8688-FBED31F28147}" type="datetimeFigureOut">
               <a:rPr lang="en-IN" smtClean="0"/>
               <a:t>19-10-2026</a:t>
             </a:fld>
@@ -4179,7 +4268,7 @@
           <p:cNvPr id="6" name="Footer Placeholder 5">
             <a:extLst>
               <a:ext uri="{FF2B5EF4-FFF2-40B4-BE49-F238E27FC236}">
-                <a16:creationId xmlns:a16="http://schemas.microsoft.com/office/drawing/2014/main" id="{02FBCBB6-0787-B8B4-40CC-50524AB64320}"/>
+                <a16:creationId xmlns:a16="http://schemas.microsoft.com/office/drawing/2014/main" id="{59C84945-50BF-4249-9992-70DE0088B285}"/>
               </a:ext>
             </a:extLst>
           </p:cNvPr>
@@ -4204,7 +4293,7 @@
           <p:cNvPr id="7" name="Slide Number Placeholder 6">
             <a:extLst>
               <a:ext uri="{FF2B5EF4-FFF2-40B4-BE49-F238E27FC236}">
-                <a16:creationId xmlns:a16="http://schemas.microsoft.com/office/drawing/2014/main" id="{D7AE41E5-BD29-497F-9AE2-DF77513B4C95}"/>
+                <a16:creationId xmlns:a16="http://schemas.microsoft.com/office/drawing/2014/main" id="{A90EA504-CE8C-5F3B-0528-6E0DF79CC98F}"/>
               </a:ext>
             </a:extLst>
           </p:cNvPr>
@@ -4220,7 +4309,7 @@
           <a:bodyPr/>
           <a:lstStyle/>
           <a:p>
-            <a:fld id="{937938ED-2178-43B3-9AAE-1648119C4B05}" type="slidenum">
+            <a:fld id="{3A465F51-8CAF-4CA4-B81F-97E2B4F072C2}" type="slidenum">
               <a:rPr lang="en-IN" smtClean="0"/>
               <a:t>‹#›</a:t>
             </a:fld>
@@ -4231,7 +4320,7 @@
     </p:spTree>
     <p:extLst>
       <p:ext uri="{BB962C8B-B14F-4D97-AF65-F5344CB8AC3E}">
-        <p14:creationId xmlns:p14="http://schemas.microsoft.com/office/powerpoint/2010/main" val="750196848"/>
+        <p14:creationId xmlns:p14="http://schemas.microsoft.com/office/powerpoint/2010/main" val="3832691587"/>
       </p:ext>
     </p:extLst>
   </p:cSld>
@@ -4263,7 +4352,7 @@
           <p:cNvPr id="2" name="Title 1">
             <a:extLst>
               <a:ext uri="{FF2B5EF4-FFF2-40B4-BE49-F238E27FC236}">
-                <a16:creationId xmlns:a16="http://schemas.microsoft.com/office/drawing/2014/main" id="{76B1844E-6807-0DC0-5F5F-DFA4493F629A}"/>
+                <a16:creationId xmlns:a16="http://schemas.microsoft.com/office/drawing/2014/main" id="{53EF4962-DD4B-AC57-BB5C-452EEA6C16E2}"/>
               </a:ext>
             </a:extLst>
           </p:cNvPr>
@@ -4301,7 +4390,7 @@
           <p:cNvPr id="3" name="Picture Placeholder 2">
             <a:extLst>
               <a:ext uri="{FF2B5EF4-FFF2-40B4-BE49-F238E27FC236}">
-                <a16:creationId xmlns:a16="http://schemas.microsoft.com/office/drawing/2014/main" id="{26335A1E-405F-5FF7-801A-87F5204EE284}"/>
+                <a16:creationId xmlns:a16="http://schemas.microsoft.com/office/drawing/2014/main" id="{5F7B1136-CA26-6BC6-DFED-46F0B3DD82C0}"/>
               </a:ext>
             </a:extLst>
           </p:cNvPr>
@@ -4368,7 +4457,7 @@
           <p:cNvPr id="4" name="Text Placeholder 3">
             <a:extLst>
               <a:ext uri="{FF2B5EF4-FFF2-40B4-BE49-F238E27FC236}">
-                <a16:creationId xmlns:a16="http://schemas.microsoft.com/office/drawing/2014/main" id="{98934909-4665-7513-8C7B-DADF28F6094B}"/>
+                <a16:creationId xmlns:a16="http://schemas.microsoft.com/office/drawing/2014/main" id="{D9F5B096-3152-8E97-F2DA-43CB4A082CA7}"/>
               </a:ext>
             </a:extLst>
           </p:cNvPr>
@@ -4439,7 +4528,7 @@
           <p:cNvPr id="5" name="Date Placeholder 4">
             <a:extLst>
               <a:ext uri="{FF2B5EF4-FFF2-40B4-BE49-F238E27FC236}">
-                <a16:creationId xmlns:a16="http://schemas.microsoft.com/office/drawing/2014/main" id="{528AED3E-95FB-F3EE-0D85-83423F738A18}"/>
+                <a16:creationId xmlns:a16="http://schemas.microsoft.com/office/drawing/2014/main" id="{C93B5233-AD25-EF7C-91B7-61AF9980A7F8}"/>
               </a:ext>
             </a:extLst>
           </p:cNvPr>
@@ -4455,7 +4544,7 @@
           <a:bodyPr/>
           <a:lstStyle/>
           <a:p>
-            <a:fld id="{DDF74FE0-EBC5-4AB9-800B-A335A3F14358}" type="datetimeFigureOut">
+            <a:fld id="{E76C1D1B-AA06-4462-8688-FBED31F28147}" type="datetimeFigureOut">
               <a:rPr lang="en-IN" smtClean="0"/>
               <a:t>19-10-2026</a:t>
             </a:fld>
@@ -4468,7 +4557,7 @@
           <p:cNvPr id="6" name="Footer Placeholder 5">
             <a:extLst>
               <a:ext uri="{FF2B5EF4-FFF2-40B4-BE49-F238E27FC236}">
-                <a16:creationId xmlns:a16="http://schemas.microsoft.com/office/drawing/2014/main" id="{097210E7-43AF-25AC-35E8-2EA04B64262C}"/>
+                <a16:creationId xmlns:a16="http://schemas.microsoft.com/office/drawing/2014/main" id="{80668771-472C-DC65-EAE6-1CA858D719BF}"/>
               </a:ext>
             </a:extLst>
           </p:cNvPr>
@@ -4493,7 +4582,7 @@
           <p:cNvPr id="7" name="Slide Number Placeholder 6">
             <a:extLst>
               <a:ext uri="{FF2B5EF4-FFF2-40B4-BE49-F238E27FC236}">
-                <a16:creationId xmlns:a16="http://schemas.microsoft.com/office/drawing/2014/main" id="{F2A07760-7CB4-F427-3B98-A1FC6CEB8954}"/>
+                <a16:creationId xmlns:a16="http://schemas.microsoft.com/office/drawing/2014/main" id="{20737601-30BA-1686-4098-79ACE49DA681}"/>
               </a:ext>
             </a:extLst>
           </p:cNvPr>
@@ -4509,7 +4598,7 @@
           <a:bodyPr/>
           <a:lstStyle/>
           <a:p>
-            <a:fld id="{937938ED-2178-43B3-9AAE-1648119C4B05}" type="slidenum">
+            <a:fld id="{3A465F51-8CAF-4CA4-B81F-97E2B4F072C2}" type="slidenum">
               <a:rPr lang="en-IN" smtClean="0"/>
               <a:t>‹#›</a:t>
             </a:fld>
@@ -4520,7 +4609,7 @@
     </p:spTree>
     <p:extLst>
       <p:ext uri="{BB962C8B-B14F-4D97-AF65-F5344CB8AC3E}">
-        <p14:creationId xmlns:p14="http://schemas.microsoft.com/office/powerpoint/2010/main" val="2596804219"/>
+        <p14:creationId xmlns:p14="http://schemas.microsoft.com/office/powerpoint/2010/main" val="1552822637"/>
       </p:ext>
     </p:extLst>
   </p:cSld>
@@ -4557,7 +4646,7 @@
           <p:cNvPr id="2" name="Title Placeholder 1">
             <a:extLst>
               <a:ext uri="{FF2B5EF4-FFF2-40B4-BE49-F238E27FC236}">
-                <a16:creationId xmlns:a16="http://schemas.microsoft.com/office/drawing/2014/main" id="{F8755496-C3F6-EC84-C90D-24DDCD3B75A5}"/>
+                <a16:creationId xmlns:a16="http://schemas.microsoft.com/office/drawing/2014/main" id="{9E2BD6C4-6030-8606-BA11-B9BFB401C523}"/>
               </a:ext>
             </a:extLst>
           </p:cNvPr>
@@ -4596,7 +4685,7 @@
           <p:cNvPr id="3" name="Text Placeholder 2">
             <a:extLst>
               <a:ext uri="{FF2B5EF4-FFF2-40B4-BE49-F238E27FC236}">
-                <a16:creationId xmlns:a16="http://schemas.microsoft.com/office/drawing/2014/main" id="{C70B77BE-6685-7309-6733-90B70D460DEC}"/>
+                <a16:creationId xmlns:a16="http://schemas.microsoft.com/office/drawing/2014/main" id="{EEE2270F-3E22-9401-518E-F5BBF3DABF0B}"/>
               </a:ext>
             </a:extLst>
           </p:cNvPr>
@@ -4664,7 +4753,7 @@
           <p:cNvPr id="4" name="Date Placeholder 3">
             <a:extLst>
               <a:ext uri="{FF2B5EF4-FFF2-40B4-BE49-F238E27FC236}">
-                <a16:creationId xmlns:a16="http://schemas.microsoft.com/office/drawing/2014/main" id="{788A17BD-55F8-AA8F-E794-60DEB4F638D9}"/>
+                <a16:creationId xmlns:a16="http://schemas.microsoft.com/office/drawing/2014/main" id="{3C893608-AAF1-8E92-E8E6-8CC1D04AFA33}"/>
               </a:ext>
             </a:extLst>
           </p:cNvPr>
@@ -4698,7 +4787,7 @@
             </a:lvl1pPr>
           </a:lstStyle>
           <a:p>
-            <a:fld id="{DDF74FE0-EBC5-4AB9-800B-A335A3F14358}" type="datetimeFigureOut">
+            <a:fld id="{E76C1D1B-AA06-4462-8688-FBED31F28147}" type="datetimeFigureOut">
               <a:rPr lang="en-IN" smtClean="0"/>
               <a:t>19-10-2026</a:t>
             </a:fld>
@@ -4711,7 +4800,7 @@
           <p:cNvPr id="5" name="Footer Placeholder 4">
             <a:extLst>
               <a:ext uri="{FF2B5EF4-FFF2-40B4-BE49-F238E27FC236}">
-                <a16:creationId xmlns:a16="http://schemas.microsoft.com/office/drawing/2014/main" id="{EE2F4C87-7EB0-2068-9617-B7B3A9C43335}"/>
+                <a16:creationId xmlns:a16="http://schemas.microsoft.com/office/drawing/2014/main" id="{46730A2E-EA64-39CD-2EF4-78040EF0B731}"/>
               </a:ext>
             </a:extLst>
           </p:cNvPr>
@@ -4754,7 +4843,7 @@
           <p:cNvPr id="6" name="Slide Number Placeholder 5">
             <a:extLst>
               <a:ext uri="{FF2B5EF4-FFF2-40B4-BE49-F238E27FC236}">
-                <a16:creationId xmlns:a16="http://schemas.microsoft.com/office/drawing/2014/main" id="{D508284D-AA35-D54C-6D60-B47373BCE903}"/>
+                <a16:creationId xmlns:a16="http://schemas.microsoft.com/office/drawing/2014/main" id="{721FBA20-BB44-7CC1-3DD8-3A3C7B601D82}"/>
               </a:ext>
             </a:extLst>
           </p:cNvPr>
@@ -4788,7 +4877,7 @@
             </a:lvl1pPr>
           </a:lstStyle>
           <a:p>
-            <a:fld id="{937938ED-2178-43B3-9AAE-1648119C4B05}" type="slidenum">
+            <a:fld id="{3A465F51-8CAF-4CA4-B81F-97E2B4F072C2}" type="slidenum">
               <a:rPr lang="en-IN" smtClean="0"/>
               <a:t>‹#›</a:t>
             </a:fld>
@@ -4799,7 +4888,7 @@
     </p:spTree>
     <p:extLst>
       <p:ext uri="{BB962C8B-B14F-4D97-AF65-F5344CB8AC3E}">
-        <p14:creationId xmlns:p14="http://schemas.microsoft.com/office/powerpoint/2010/main" val="3866621658"/>
+        <p14:creationId xmlns:p14="http://schemas.microsoft.com/office/powerpoint/2010/main" val="1567021486"/>
       </p:ext>
     </p:extLst>
   </p:cSld>
@@ -5130,7 +5219,7 @@
           <p:cNvPr id="2" name="TextBox 1">
             <a:extLst>
               <a:ext uri="{FF2B5EF4-FFF2-40B4-BE49-F238E27FC236}">
-                <a16:creationId xmlns:a16="http://schemas.microsoft.com/office/drawing/2014/main" id="{729CD704-1229-AEBB-CD0B-BF095760F9D4}"/>
+                <a16:creationId xmlns:a16="http://schemas.microsoft.com/office/drawing/2014/main" id="{CF54EC84-BB02-78AB-D98E-82FA50F39018}"/>
               </a:ext>
             </a:extLst>
           </p:cNvPr>
@@ -5175,7 +5264,7 @@
           <p:cNvPr id="3" name="TextBox 2">
             <a:extLst>
               <a:ext uri="{FF2B5EF4-FFF2-40B4-BE49-F238E27FC236}">
-                <a16:creationId xmlns:a16="http://schemas.microsoft.com/office/drawing/2014/main" id="{5A45F18B-61E9-0A96-059C-DFECECAEF07B}"/>
+                <a16:creationId xmlns:a16="http://schemas.microsoft.com/office/drawing/2014/main" id="{BCC0291C-D964-CB1F-612F-39544EBA1F3B}"/>
               </a:ext>
             </a:extLst>
           </p:cNvPr>
@@ -5221,7 +5310,7 @@
           <p:cNvPr id="4" name="TextBox 3">
             <a:extLst>
               <a:ext uri="{FF2B5EF4-FFF2-40B4-BE49-F238E27FC236}">
-                <a16:creationId xmlns:a16="http://schemas.microsoft.com/office/drawing/2014/main" id="{C746DE91-3620-0AD8-EEF9-74CD01893F48}"/>
+                <a16:creationId xmlns:a16="http://schemas.microsoft.com/office/drawing/2014/main" id="{0E90A975-EF49-CA29-0013-E0AEDB18FF3E}"/>
               </a:ext>
             </a:extLst>
           </p:cNvPr>
@@ -5273,7 +5362,7 @@
           <p:cNvPr id="6" name="Picture 5">
             <a:extLst>
               <a:ext uri="{FF2B5EF4-FFF2-40B4-BE49-F238E27FC236}">
-                <a16:creationId xmlns:a16="http://schemas.microsoft.com/office/drawing/2014/main" id="{85E74406-9F7F-535D-20E6-EE7DD43EBB9C}"/>
+                <a16:creationId xmlns:a16="http://schemas.microsoft.com/office/drawing/2014/main" id="{15AFFA4A-A5D4-D3D4-50A9-F1D7D6D6AF2F}"/>
               </a:ext>
             </a:extLst>
           </p:cNvPr>
@@ -5309,7 +5398,7 @@
           <p:cNvPr id="7" name="TextBox 6">
             <a:extLst>
               <a:ext uri="{FF2B5EF4-FFF2-40B4-BE49-F238E27FC236}">
-                <a16:creationId xmlns:a16="http://schemas.microsoft.com/office/drawing/2014/main" id="{1DBB3ED9-50FE-B727-25F6-15EA65EBBB03}"/>
+                <a16:creationId xmlns:a16="http://schemas.microsoft.com/office/drawing/2014/main" id="{68AF3DC9-27B6-DDC1-306E-BF342A82796E}"/>
               </a:ext>
             </a:extLst>
           </p:cNvPr>
@@ -5356,7 +5445,7 @@
           <p:cNvPr id="8" name="TextBox 7">
             <a:extLst>
               <a:ext uri="{FF2B5EF4-FFF2-40B4-BE49-F238E27FC236}">
-                <a16:creationId xmlns:a16="http://schemas.microsoft.com/office/drawing/2014/main" id="{B7BAE007-3F78-CB78-7A6E-3384BFE0574D}"/>
+                <a16:creationId xmlns:a16="http://schemas.microsoft.com/office/drawing/2014/main" id="{BAF1F141-19FC-5A39-61C1-458B440406F5}"/>
               </a:ext>
             </a:extLst>
           </p:cNvPr>
@@ -5399,7 +5488,7 @@
     </p:spTree>
     <p:extLst>
       <p:ext uri="{BB962C8B-B14F-4D97-AF65-F5344CB8AC3E}">
-        <p14:creationId xmlns:p14="http://schemas.microsoft.com/office/powerpoint/2010/main" val="60809029"/>
+        <p14:creationId xmlns:p14="http://schemas.microsoft.com/office/powerpoint/2010/main" val="3609827800"/>
       </p:ext>
     </p:extLst>
   </p:cSld>
@@ -5439,7 +5528,7 @@
           <p:cNvPr id="2" name="TextBox 1">
             <a:extLst>
               <a:ext uri="{FF2B5EF4-FFF2-40B4-BE49-F238E27FC236}">
-                <a16:creationId xmlns:a16="http://schemas.microsoft.com/office/drawing/2014/main" id="{5AFC735A-4FBE-2606-8A32-ED6425752295}"/>
+                <a16:creationId xmlns:a16="http://schemas.microsoft.com/office/drawing/2014/main" id="{AAAA0061-7AE8-D7A6-0549-9DE172A21843}"/>
               </a:ext>
             </a:extLst>
           </p:cNvPr>
@@ -5484,7 +5573,7 @@
           <p:cNvPr id="3" name="TextBox 2">
             <a:extLst>
               <a:ext uri="{FF2B5EF4-FFF2-40B4-BE49-F238E27FC236}">
-                <a16:creationId xmlns:a16="http://schemas.microsoft.com/office/drawing/2014/main" id="{38A509CC-B27B-5C8D-6344-F9FA4799FD47}"/>
+                <a16:creationId xmlns:a16="http://schemas.microsoft.com/office/drawing/2014/main" id="{D9466E73-238D-F574-6D76-0CB732EBE4CA}"/>
               </a:ext>
             </a:extLst>
           </p:cNvPr>
@@ -5535,7 +5624,7 @@
           <p:cNvPr id="4" name="TextBox 3">
             <a:extLst>
               <a:ext uri="{FF2B5EF4-FFF2-40B4-BE49-F238E27FC236}">
-                <a16:creationId xmlns:a16="http://schemas.microsoft.com/office/drawing/2014/main" id="{2DD2C4B0-6BBF-D3A6-E95E-F93FD04CF4F7}"/>
+                <a16:creationId xmlns:a16="http://schemas.microsoft.com/office/drawing/2014/main" id="{A98D82D2-F617-5BE1-03CD-32DE3C7255A3}"/>
               </a:ext>
             </a:extLst>
           </p:cNvPr>
@@ -5587,7 +5676,7 @@
           <p:cNvPr id="5" name="Table 4">
             <a:extLst>
               <a:ext uri="{FF2B5EF4-FFF2-40B4-BE49-F238E27FC236}">
-                <a16:creationId xmlns:a16="http://schemas.microsoft.com/office/drawing/2014/main" id="{6E131E8E-AD7B-9095-4DE7-FD5550397641}"/>
+                <a16:creationId xmlns:a16="http://schemas.microsoft.com/office/drawing/2014/main" id="{97CA1E1D-A110-B33E-EB6A-74A082242EFB}"/>
               </a:ext>
             </a:extLst>
           </p:cNvPr>
@@ -5597,7 +5686,7 @@
           <p:nvPr>
             <p:extLst>
               <p:ext uri="{D42A27DB-BD31-4B8C-83A1-F6EECF244321}">
-                <p14:modId xmlns:p14="http://schemas.microsoft.com/office/powerpoint/2010/main" val="4106356954"/>
+                <p14:modId xmlns:p14="http://schemas.microsoft.com/office/powerpoint/2010/main" val="687454500"/>
               </p:ext>
             </p:extLst>
           </p:nvPr>
@@ -5616,28 +5705,28 @@
                 <a:gridCol w="4064000">
                   <a:extLst>
                     <a:ext uri="{9D8B030D-6E8A-4147-A177-3AD203B41FA5}">
-                      <a16:colId xmlns:a16="http://schemas.microsoft.com/office/drawing/2014/main" val="942351640"/>
+                      <a16:colId xmlns:a16="http://schemas.microsoft.com/office/drawing/2014/main" val="4291281191"/>
                     </a:ext>
                   </a:extLst>
                 </a:gridCol>
                 <a:gridCol w="1524000">
                   <a:extLst>
                     <a:ext uri="{9D8B030D-6E8A-4147-A177-3AD203B41FA5}">
-                      <a16:colId xmlns:a16="http://schemas.microsoft.com/office/drawing/2014/main" val="3131021289"/>
+                      <a16:colId xmlns:a16="http://schemas.microsoft.com/office/drawing/2014/main" val="3223815234"/>
                     </a:ext>
                   </a:extLst>
                 </a:gridCol>
                 <a:gridCol w="2667000">
                   <a:extLst>
                     <a:ext uri="{9D8B030D-6E8A-4147-A177-3AD203B41FA5}">
-                      <a16:colId xmlns:a16="http://schemas.microsoft.com/office/drawing/2014/main" val="2012984853"/>
+                      <a16:colId xmlns:a16="http://schemas.microsoft.com/office/drawing/2014/main" val="312261753"/>
                     </a:ext>
                   </a:extLst>
                 </a:gridCol>
                 <a:gridCol w="2667000">
                   <a:extLst>
                     <a:ext uri="{9D8B030D-6E8A-4147-A177-3AD203B41FA5}">
-                      <a16:colId xmlns:a16="http://schemas.microsoft.com/office/drawing/2014/main" val="3809571636"/>
+                      <a16:colId xmlns:a16="http://schemas.microsoft.com/office/drawing/2014/main" val="3638284303"/>
                     </a:ext>
                   </a:extLst>
                 </a:gridCol>
@@ -5813,7 +5902,7 @@
                 </a:tc>
                 <a:extLst>
                   <a:ext uri="{0D108BD9-81ED-4DB2-BD59-A6C34878D82A}">
-                    <a16:rowId xmlns:a16="http://schemas.microsoft.com/office/drawing/2014/main" val="482410368"/>
+                    <a16:rowId xmlns:a16="http://schemas.microsoft.com/office/drawing/2014/main" val="3053548314"/>
                   </a:ext>
                 </a:extLst>
               </a:tr>
@@ -5988,7 +6077,7 @@
                 </a:tc>
                 <a:extLst>
                   <a:ext uri="{0D108BD9-81ED-4DB2-BD59-A6C34878D82A}">
-                    <a16:rowId xmlns:a16="http://schemas.microsoft.com/office/drawing/2014/main" val="3692162954"/>
+                    <a16:rowId xmlns:a16="http://schemas.microsoft.com/office/drawing/2014/main" val="1295736332"/>
                   </a:ext>
                 </a:extLst>
               </a:tr>
@@ -6163,7 +6252,7 @@
                 </a:tc>
                 <a:extLst>
                   <a:ext uri="{0D108BD9-81ED-4DB2-BD59-A6C34878D82A}">
-                    <a16:rowId xmlns:a16="http://schemas.microsoft.com/office/drawing/2014/main" val="2706094569"/>
+                    <a16:rowId xmlns:a16="http://schemas.microsoft.com/office/drawing/2014/main" val="1441638651"/>
                   </a:ext>
                 </a:extLst>
               </a:tr>
@@ -6338,7 +6427,7 @@
                 </a:tc>
                 <a:extLst>
                   <a:ext uri="{0D108BD9-81ED-4DB2-BD59-A6C34878D82A}">
-                    <a16:rowId xmlns:a16="http://schemas.microsoft.com/office/drawing/2014/main" val="4008685344"/>
+                    <a16:rowId xmlns:a16="http://schemas.microsoft.com/office/drawing/2014/main" val="1938105937"/>
                   </a:ext>
                 </a:extLst>
               </a:tr>
@@ -6351,7 +6440,7 @@
           <p:cNvPr id="6" name="TextBox 5">
             <a:extLst>
               <a:ext uri="{FF2B5EF4-FFF2-40B4-BE49-F238E27FC236}">
-                <a16:creationId xmlns:a16="http://schemas.microsoft.com/office/drawing/2014/main" id="{B17446E6-BF90-88A9-0179-D0329016279A}"/>
+                <a16:creationId xmlns:a16="http://schemas.microsoft.com/office/drawing/2014/main" id="{992E9BD8-3AD0-70CA-E773-64FCF9746E66}"/>
               </a:ext>
             </a:extLst>
           </p:cNvPr>
@@ -6402,7 +6491,7 @@
           <p:cNvPr id="7" name="TextBox 6">
             <a:extLst>
               <a:ext uri="{FF2B5EF4-FFF2-40B4-BE49-F238E27FC236}">
-                <a16:creationId xmlns:a16="http://schemas.microsoft.com/office/drawing/2014/main" id="{632B2B50-C543-4818-711B-7B66228A660A}"/>
+                <a16:creationId xmlns:a16="http://schemas.microsoft.com/office/drawing/2014/main" id="{0863A5CC-C14D-63D2-C973-6CCF6CF9794F}"/>
               </a:ext>
             </a:extLst>
           </p:cNvPr>
@@ -6447,7 +6536,7 @@
           <p:cNvPr id="8" name="TextBox 7">
             <a:extLst>
               <a:ext uri="{FF2B5EF4-FFF2-40B4-BE49-F238E27FC236}">
-                <a16:creationId xmlns:a16="http://schemas.microsoft.com/office/drawing/2014/main" id="{A9D46563-8159-ADCC-E300-E56D019E635E}"/>
+                <a16:creationId xmlns:a16="http://schemas.microsoft.com/office/drawing/2014/main" id="{C670EDE1-2111-C967-9778-97214F2CAFD2}"/>
               </a:ext>
             </a:extLst>
           </p:cNvPr>
@@ -6490,7 +6579,7 @@
     </p:spTree>
     <p:extLst>
       <p:ext uri="{BB962C8B-B14F-4D97-AF65-F5344CB8AC3E}">
-        <p14:creationId xmlns:p14="http://schemas.microsoft.com/office/powerpoint/2010/main" val="2075331251"/>
+        <p14:creationId xmlns:p14="http://schemas.microsoft.com/office/powerpoint/2010/main" val="4246246519"/>
       </p:ext>
     </p:extLst>
   </p:cSld>
@@ -6530,7 +6619,7 @@
           <p:cNvPr id="2" name="TextBox 1">
             <a:extLst>
               <a:ext uri="{FF2B5EF4-FFF2-40B4-BE49-F238E27FC236}">
-                <a16:creationId xmlns:a16="http://schemas.microsoft.com/office/drawing/2014/main" id="{5DB52067-7CCD-7FBA-E31E-DA005B4F3124}"/>
+                <a16:creationId xmlns:a16="http://schemas.microsoft.com/office/drawing/2014/main" id="{F9071AB0-AF21-FD95-C3EF-44E73417630A}"/>
               </a:ext>
             </a:extLst>
           </p:cNvPr>
@@ -6575,7 +6664,7 @@
           <p:cNvPr id="3" name="TextBox 2">
             <a:extLst>
               <a:ext uri="{FF2B5EF4-FFF2-40B4-BE49-F238E27FC236}">
-                <a16:creationId xmlns:a16="http://schemas.microsoft.com/office/drawing/2014/main" id="{D1D58F2D-FEB3-B9B9-2619-C36B285C03D0}"/>
+                <a16:creationId xmlns:a16="http://schemas.microsoft.com/office/drawing/2014/main" id="{23906536-AD6B-E1E5-E3A5-F1B12D8D250C}"/>
               </a:ext>
             </a:extLst>
           </p:cNvPr>
@@ -6626,7 +6715,7 @@
           <p:cNvPr id="4" name="Table 3">
             <a:extLst>
               <a:ext uri="{FF2B5EF4-FFF2-40B4-BE49-F238E27FC236}">
-                <a16:creationId xmlns:a16="http://schemas.microsoft.com/office/drawing/2014/main" id="{8092B2EC-4FC7-6AD1-E7CA-AEE15E4248C1}"/>
+                <a16:creationId xmlns:a16="http://schemas.microsoft.com/office/drawing/2014/main" id="{15C3F325-02F1-E6EF-D658-4885C36CF605}"/>
               </a:ext>
             </a:extLst>
           </p:cNvPr>
@@ -6636,7 +6725,7 @@
           <p:nvPr>
             <p:extLst>
               <p:ext uri="{D42A27DB-BD31-4B8C-83A1-F6EECF244321}">
-                <p14:modId xmlns:p14="http://schemas.microsoft.com/office/powerpoint/2010/main" val="2084035532"/>
+                <p14:modId xmlns:p14="http://schemas.microsoft.com/office/powerpoint/2010/main" val="1094621118"/>
               </p:ext>
             </p:extLst>
           </p:nvPr>
@@ -6655,35 +6744,35 @@
                 <a:gridCol w="3302000">
                   <a:extLst>
                     <a:ext uri="{9D8B030D-6E8A-4147-A177-3AD203B41FA5}">
-                      <a16:colId xmlns:a16="http://schemas.microsoft.com/office/drawing/2014/main" val="505685940"/>
+                      <a16:colId xmlns:a16="http://schemas.microsoft.com/office/drawing/2014/main" val="1032132936"/>
                     </a:ext>
                   </a:extLst>
                 </a:gridCol>
                 <a:gridCol w="1905000">
                   <a:extLst>
                     <a:ext uri="{9D8B030D-6E8A-4147-A177-3AD203B41FA5}">
-                      <a16:colId xmlns:a16="http://schemas.microsoft.com/office/drawing/2014/main" val="2875457233"/>
+                      <a16:colId xmlns:a16="http://schemas.microsoft.com/office/drawing/2014/main" val="3016329069"/>
                     </a:ext>
                   </a:extLst>
                 </a:gridCol>
                 <a:gridCol w="1905000">
                   <a:extLst>
                     <a:ext uri="{9D8B030D-6E8A-4147-A177-3AD203B41FA5}">
-                      <a16:colId xmlns:a16="http://schemas.microsoft.com/office/drawing/2014/main" val="12305160"/>
+                      <a16:colId xmlns:a16="http://schemas.microsoft.com/office/drawing/2014/main" val="2111555908"/>
                     </a:ext>
                   </a:extLst>
                 </a:gridCol>
                 <a:gridCol w="1905000">
                   <a:extLst>
                     <a:ext uri="{9D8B030D-6E8A-4147-A177-3AD203B41FA5}">
-                      <a16:colId xmlns:a16="http://schemas.microsoft.com/office/drawing/2014/main" val="2517738048"/>
+                      <a16:colId xmlns:a16="http://schemas.microsoft.com/office/drawing/2014/main" val="1647208920"/>
                     </a:ext>
                   </a:extLst>
                 </a:gridCol>
                 <a:gridCol w="1905000">
                   <a:extLst>
                     <a:ext uri="{9D8B030D-6E8A-4147-A177-3AD203B41FA5}">
-                      <a16:colId xmlns:a16="http://schemas.microsoft.com/office/drawing/2014/main" val="4292797885"/>
+                      <a16:colId xmlns:a16="http://schemas.microsoft.com/office/drawing/2014/main" val="100652350"/>
                     </a:ext>
                   </a:extLst>
                 </a:gridCol>
@@ -6901,7 +6990,7 @@
                 </a:tc>
                 <a:extLst>
                   <a:ext uri="{0D108BD9-81ED-4DB2-BD59-A6C34878D82A}">
-                    <a16:rowId xmlns:a16="http://schemas.microsoft.com/office/drawing/2014/main" val="615875965"/>
+                    <a16:rowId xmlns:a16="http://schemas.microsoft.com/office/drawing/2014/main" val="1378814693"/>
                   </a:ext>
                 </a:extLst>
               </a:tr>
@@ -7118,7 +7207,7 @@
                 </a:tc>
                 <a:extLst>
                   <a:ext uri="{0D108BD9-81ED-4DB2-BD59-A6C34878D82A}">
-                    <a16:rowId xmlns:a16="http://schemas.microsoft.com/office/drawing/2014/main" val="3360513813"/>
+                    <a16:rowId xmlns:a16="http://schemas.microsoft.com/office/drawing/2014/main" val="1904894850"/>
                   </a:ext>
                 </a:extLst>
               </a:tr>
@@ -7335,7 +7424,7 @@
                 </a:tc>
                 <a:extLst>
                   <a:ext uri="{0D108BD9-81ED-4DB2-BD59-A6C34878D82A}">
-                    <a16:rowId xmlns:a16="http://schemas.microsoft.com/office/drawing/2014/main" val="4029551806"/>
+                    <a16:rowId xmlns:a16="http://schemas.microsoft.com/office/drawing/2014/main" val="945078319"/>
                   </a:ext>
                 </a:extLst>
               </a:tr>
@@ -7552,7 +7641,7 @@
                 </a:tc>
                 <a:extLst>
                   <a:ext uri="{0D108BD9-81ED-4DB2-BD59-A6C34878D82A}">
-                    <a16:rowId xmlns:a16="http://schemas.microsoft.com/office/drawing/2014/main" val="1453545393"/>
+                    <a16:rowId xmlns:a16="http://schemas.microsoft.com/office/drawing/2014/main" val="1622647789"/>
                   </a:ext>
                 </a:extLst>
               </a:tr>
@@ -7769,7 +7858,7 @@
                 </a:tc>
                 <a:extLst>
                   <a:ext uri="{0D108BD9-81ED-4DB2-BD59-A6C34878D82A}">
-                    <a16:rowId xmlns:a16="http://schemas.microsoft.com/office/drawing/2014/main" val="3623195443"/>
+                    <a16:rowId xmlns:a16="http://schemas.microsoft.com/office/drawing/2014/main" val="339253623"/>
                   </a:ext>
                 </a:extLst>
               </a:tr>
@@ -7782,7 +7871,7 @@
           <p:cNvPr id="5" name="TextBox 4">
             <a:extLst>
               <a:ext uri="{FF2B5EF4-FFF2-40B4-BE49-F238E27FC236}">
-                <a16:creationId xmlns:a16="http://schemas.microsoft.com/office/drawing/2014/main" id="{03FAC8D3-749D-BA85-32CE-E2136B2EB22D}"/>
+                <a16:creationId xmlns:a16="http://schemas.microsoft.com/office/drawing/2014/main" id="{65C7C97A-B137-9102-7B74-ACE2BE87D510}"/>
               </a:ext>
             </a:extLst>
           </p:cNvPr>
@@ -7833,7 +7922,7 @@
           <p:cNvPr id="6" name="TextBox 5">
             <a:extLst>
               <a:ext uri="{FF2B5EF4-FFF2-40B4-BE49-F238E27FC236}">
-                <a16:creationId xmlns:a16="http://schemas.microsoft.com/office/drawing/2014/main" id="{0B6899BD-3994-087C-D841-87594CEF31E3}"/>
+                <a16:creationId xmlns:a16="http://schemas.microsoft.com/office/drawing/2014/main" id="{54575D9B-AC45-C6AE-B3D8-B1F0FFC0E12B}"/>
               </a:ext>
             </a:extLst>
           </p:cNvPr>
@@ -7878,7 +7967,7 @@
           <p:cNvPr id="7" name="TextBox 6">
             <a:extLst>
               <a:ext uri="{FF2B5EF4-FFF2-40B4-BE49-F238E27FC236}">
-                <a16:creationId xmlns:a16="http://schemas.microsoft.com/office/drawing/2014/main" id="{E9606B1E-8A42-324B-A863-7DCFD671C319}"/>
+                <a16:creationId xmlns:a16="http://schemas.microsoft.com/office/drawing/2014/main" id="{77827A39-F56C-973F-902F-013CAE7309A1}"/>
               </a:ext>
             </a:extLst>
           </p:cNvPr>
@@ -7921,7 +8010,7 @@
     </p:spTree>
     <p:extLst>
       <p:ext uri="{BB962C8B-B14F-4D97-AF65-F5344CB8AC3E}">
-        <p14:creationId xmlns:p14="http://schemas.microsoft.com/office/powerpoint/2010/main" val="1602161767"/>
+        <p14:creationId xmlns:p14="http://schemas.microsoft.com/office/powerpoint/2010/main" val="3271634043"/>
       </p:ext>
     </p:extLst>
   </p:cSld>
@@ -7961,7 +8050,7 @@
           <p:cNvPr id="2" name="TextBox 1">
             <a:extLst>
               <a:ext uri="{FF2B5EF4-FFF2-40B4-BE49-F238E27FC236}">
-                <a16:creationId xmlns:a16="http://schemas.microsoft.com/office/drawing/2014/main" id="{74784183-0EBA-EF83-D6D7-31C8AC8E5541}"/>
+                <a16:creationId xmlns:a16="http://schemas.microsoft.com/office/drawing/2014/main" id="{3D8F2EF2-3348-CA48-AD92-8F355BF070D7}"/>
               </a:ext>
             </a:extLst>
           </p:cNvPr>
@@ -8012,7 +8101,7 @@
           <p:cNvPr id="3" name="TextBox 2">
             <a:extLst>
               <a:ext uri="{FF2B5EF4-FFF2-40B4-BE49-F238E27FC236}">
-                <a16:creationId xmlns:a16="http://schemas.microsoft.com/office/drawing/2014/main" id="{ADDFDC27-1B53-BA66-10D7-CD97038D0953}"/>
+                <a16:creationId xmlns:a16="http://schemas.microsoft.com/office/drawing/2014/main" id="{A98F7637-CE1E-26DE-2ED1-DF0F3FB081AA}"/>
               </a:ext>
             </a:extLst>
           </p:cNvPr>
@@ -8063,7 +8152,7 @@
           <p:cNvPr id="4" name="TextBox 3">
             <a:extLst>
               <a:ext uri="{FF2B5EF4-FFF2-40B4-BE49-F238E27FC236}">
-                <a16:creationId xmlns:a16="http://schemas.microsoft.com/office/drawing/2014/main" id="{50CE65C1-2569-1742-EE12-CF24070597A7}"/>
+                <a16:creationId xmlns:a16="http://schemas.microsoft.com/office/drawing/2014/main" id="{42A6280B-9E90-CEF0-C21A-55C56DFC8404}"/>
               </a:ext>
             </a:extLst>
           </p:cNvPr>
@@ -8117,7 +8206,7 @@
           <p:cNvPr id="5" name="TextBox 4">
             <a:extLst>
               <a:ext uri="{FF2B5EF4-FFF2-40B4-BE49-F238E27FC236}">
-                <a16:creationId xmlns:a16="http://schemas.microsoft.com/office/drawing/2014/main" id="{BD825728-46F2-A4FF-72F3-13F6C427FEBB}"/>
+                <a16:creationId xmlns:a16="http://schemas.microsoft.com/office/drawing/2014/main" id="{B5CBFC1B-64E3-5327-00D4-1491A903FA32}"/>
               </a:ext>
             </a:extLst>
           </p:cNvPr>
@@ -8169,7 +8258,7 @@
           <p:cNvPr id="6" name="Table 5">
             <a:extLst>
               <a:ext uri="{FF2B5EF4-FFF2-40B4-BE49-F238E27FC236}">
-                <a16:creationId xmlns:a16="http://schemas.microsoft.com/office/drawing/2014/main" id="{DCF0D178-77D6-2751-0385-37E3870F0614}"/>
+                <a16:creationId xmlns:a16="http://schemas.microsoft.com/office/drawing/2014/main" id="{F9B2B38B-DF79-0ADA-7024-EFF59663863A}"/>
               </a:ext>
             </a:extLst>
           </p:cNvPr>
@@ -8179,7 +8268,7 @@
           <p:nvPr>
             <p:extLst>
               <p:ext uri="{D42A27DB-BD31-4B8C-83A1-F6EECF244321}">
-                <p14:modId xmlns:p14="http://schemas.microsoft.com/office/powerpoint/2010/main" val="3851198020"/>
+                <p14:modId xmlns:p14="http://schemas.microsoft.com/office/powerpoint/2010/main" val="1851722445"/>
               </p:ext>
             </p:extLst>
           </p:nvPr>
@@ -8198,21 +8287,21 @@
                 <a:gridCol w="2540000">
                   <a:extLst>
                     <a:ext uri="{9D8B030D-6E8A-4147-A177-3AD203B41FA5}">
-                      <a16:colId xmlns:a16="http://schemas.microsoft.com/office/drawing/2014/main" val="4083259485"/>
+                      <a16:colId xmlns:a16="http://schemas.microsoft.com/office/drawing/2014/main" val="3163166481"/>
                     </a:ext>
                   </a:extLst>
                 </a:gridCol>
                 <a:gridCol w="1397000">
                   <a:extLst>
                     <a:ext uri="{9D8B030D-6E8A-4147-A177-3AD203B41FA5}">
-                      <a16:colId xmlns:a16="http://schemas.microsoft.com/office/drawing/2014/main" val="2604777657"/>
+                      <a16:colId xmlns:a16="http://schemas.microsoft.com/office/drawing/2014/main" val="3557314426"/>
                     </a:ext>
                   </a:extLst>
                 </a:gridCol>
                 <a:gridCol w="1397000">
                   <a:extLst>
                     <a:ext uri="{9D8B030D-6E8A-4147-A177-3AD203B41FA5}">
-                      <a16:colId xmlns:a16="http://schemas.microsoft.com/office/drawing/2014/main" val="4278163778"/>
+                      <a16:colId xmlns:a16="http://schemas.microsoft.com/office/drawing/2014/main" val="2985992820"/>
                     </a:ext>
                   </a:extLst>
                 </a:gridCol>
@@ -8346,7 +8435,7 @@
                 </a:tc>
                 <a:extLst>
                   <a:ext uri="{0D108BD9-81ED-4DB2-BD59-A6C34878D82A}">
-                    <a16:rowId xmlns:a16="http://schemas.microsoft.com/office/drawing/2014/main" val="4197451786"/>
+                    <a16:rowId xmlns:a16="http://schemas.microsoft.com/office/drawing/2014/main" val="2426389894"/>
                   </a:ext>
                 </a:extLst>
               </a:tr>
@@ -8479,7 +8568,7 @@
                 </a:tc>
                 <a:extLst>
                   <a:ext uri="{0D108BD9-81ED-4DB2-BD59-A6C34878D82A}">
-                    <a16:rowId xmlns:a16="http://schemas.microsoft.com/office/drawing/2014/main" val="1407413560"/>
+                    <a16:rowId xmlns:a16="http://schemas.microsoft.com/office/drawing/2014/main" val="1634184537"/>
                   </a:ext>
                 </a:extLst>
               </a:tr>
@@ -8612,7 +8701,7 @@
                 </a:tc>
                 <a:extLst>
                   <a:ext uri="{0D108BD9-81ED-4DB2-BD59-A6C34878D82A}">
-                    <a16:rowId xmlns:a16="http://schemas.microsoft.com/office/drawing/2014/main" val="646978135"/>
+                    <a16:rowId xmlns:a16="http://schemas.microsoft.com/office/drawing/2014/main" val="171385201"/>
                   </a:ext>
                 </a:extLst>
               </a:tr>
@@ -8625,7 +8714,7 @@
           <p:cNvPr id="7" name="TextBox 6">
             <a:extLst>
               <a:ext uri="{FF2B5EF4-FFF2-40B4-BE49-F238E27FC236}">
-                <a16:creationId xmlns:a16="http://schemas.microsoft.com/office/drawing/2014/main" id="{4047BFC7-22ED-6016-89BE-F28D78369A78}"/>
+                <a16:creationId xmlns:a16="http://schemas.microsoft.com/office/drawing/2014/main" id="{54CB9CA4-2741-0F05-53BF-BD6DEF153367}"/>
               </a:ext>
             </a:extLst>
           </p:cNvPr>
@@ -8676,7 +8765,7 @@
           <p:cNvPr id="8" name="TextBox 7">
             <a:extLst>
               <a:ext uri="{FF2B5EF4-FFF2-40B4-BE49-F238E27FC236}">
-                <a16:creationId xmlns:a16="http://schemas.microsoft.com/office/drawing/2014/main" id="{AFC8FFA2-07E6-3C94-98F3-E25BDB908D1C}"/>
+                <a16:creationId xmlns:a16="http://schemas.microsoft.com/office/drawing/2014/main" id="{FF7804B9-57E8-3625-1FA9-E142E39D6090}"/>
               </a:ext>
             </a:extLst>
           </p:cNvPr>
@@ -8721,7 +8810,7 @@
           <p:cNvPr id="9" name="TextBox 8">
             <a:extLst>
               <a:ext uri="{FF2B5EF4-FFF2-40B4-BE49-F238E27FC236}">
-                <a16:creationId xmlns:a16="http://schemas.microsoft.com/office/drawing/2014/main" id="{9D024A44-7FCF-F1D8-83D6-B0B6AF135A90}"/>
+                <a16:creationId xmlns:a16="http://schemas.microsoft.com/office/drawing/2014/main" id="{816E09EE-F6B5-3A39-6F89-D7C2A5BC9C7B}"/>
               </a:ext>
             </a:extLst>
           </p:cNvPr>
@@ -8764,7 +8853,7 @@
     </p:spTree>
     <p:extLst>
       <p:ext uri="{BB962C8B-B14F-4D97-AF65-F5344CB8AC3E}">
-        <p14:creationId xmlns:p14="http://schemas.microsoft.com/office/powerpoint/2010/main" val="4142419670"/>
+        <p14:creationId xmlns:p14="http://schemas.microsoft.com/office/powerpoint/2010/main" val="2856316675"/>
       </p:ext>
     </p:extLst>
   </p:cSld>
@@ -8804,7 +8893,7 @@
           <p:cNvPr id="2" name="TextBox 1">
             <a:extLst>
               <a:ext uri="{FF2B5EF4-FFF2-40B4-BE49-F238E27FC236}">
-                <a16:creationId xmlns:a16="http://schemas.microsoft.com/office/drawing/2014/main" id="{6F2E402F-788C-177D-DD1A-6E53A9983AB6}"/>
+                <a16:creationId xmlns:a16="http://schemas.microsoft.com/office/drawing/2014/main" id="{357C8219-BEE7-C29E-D696-DE8A97687D37}"/>
               </a:ext>
             </a:extLst>
           </p:cNvPr>
@@ -8855,7 +8944,7 @@
           <p:cNvPr id="3" name="TextBox 2">
             <a:extLst>
               <a:ext uri="{FF2B5EF4-FFF2-40B4-BE49-F238E27FC236}">
-                <a16:creationId xmlns:a16="http://schemas.microsoft.com/office/drawing/2014/main" id="{3E6C5B41-E91C-40E5-35E9-0D56919086D1}"/>
+                <a16:creationId xmlns:a16="http://schemas.microsoft.com/office/drawing/2014/main" id="{9875FD38-A847-F8E7-EF99-9A78574BC466}"/>
               </a:ext>
             </a:extLst>
           </p:cNvPr>
@@ -8906,7 +8995,7 @@
           <p:cNvPr id="5" name="Picture 4">
             <a:extLst>
               <a:ext uri="{FF2B5EF4-FFF2-40B4-BE49-F238E27FC236}">
-                <a16:creationId xmlns:a16="http://schemas.microsoft.com/office/drawing/2014/main" id="{33C2030B-463D-33B4-2EE4-6D74086009B3}"/>
+                <a16:creationId xmlns:a16="http://schemas.microsoft.com/office/drawing/2014/main" id="{460A03D5-5738-0975-E50C-77923D13EDA2}"/>
               </a:ext>
             </a:extLst>
           </p:cNvPr>
@@ -8942,7 +9031,7 @@
           <p:cNvPr id="6" name="TextBox 5">
             <a:extLst>
               <a:ext uri="{FF2B5EF4-FFF2-40B4-BE49-F238E27FC236}">
-                <a16:creationId xmlns:a16="http://schemas.microsoft.com/office/drawing/2014/main" id="{5E14F40B-108A-C2DB-0183-0014FF688967}"/>
+                <a16:creationId xmlns:a16="http://schemas.microsoft.com/office/drawing/2014/main" id="{945F4A17-7DBC-4404-B0F9-6B87B5A947B4}"/>
               </a:ext>
             </a:extLst>
           </p:cNvPr>
@@ -8993,7 +9082,7 @@
           <p:cNvPr id="7" name="TextBox 6">
             <a:extLst>
               <a:ext uri="{FF2B5EF4-FFF2-40B4-BE49-F238E27FC236}">
-                <a16:creationId xmlns:a16="http://schemas.microsoft.com/office/drawing/2014/main" id="{9A30C9A4-60D8-48AC-3BFE-9A6BF332EBCD}"/>
+                <a16:creationId xmlns:a16="http://schemas.microsoft.com/office/drawing/2014/main" id="{8ECF35A7-B228-947B-CBD3-A120AA39AB83}"/>
               </a:ext>
             </a:extLst>
           </p:cNvPr>
@@ -9038,7 +9127,7 @@
           <p:cNvPr id="8" name="TextBox 7">
             <a:extLst>
               <a:ext uri="{FF2B5EF4-FFF2-40B4-BE49-F238E27FC236}">
-                <a16:creationId xmlns:a16="http://schemas.microsoft.com/office/drawing/2014/main" id="{81C2B6A7-4AE8-F1F8-EA12-AC4BA114751D}"/>
+                <a16:creationId xmlns:a16="http://schemas.microsoft.com/office/drawing/2014/main" id="{DA6C8472-5042-EE9E-1844-2FDEB24CA342}"/>
               </a:ext>
             </a:extLst>
           </p:cNvPr>
@@ -9081,7 +9170,7 @@
     </p:spTree>
     <p:extLst>
       <p:ext uri="{BB962C8B-B14F-4D97-AF65-F5344CB8AC3E}">
-        <p14:creationId xmlns:p14="http://schemas.microsoft.com/office/powerpoint/2010/main" val="2921581798"/>
+        <p14:creationId xmlns:p14="http://schemas.microsoft.com/office/powerpoint/2010/main" val="3072076701"/>
       </p:ext>
     </p:extLst>
   </p:cSld>
@@ -9121,7 +9210,7 @@
           <p:cNvPr id="2" name="TextBox 1">
             <a:extLst>
               <a:ext uri="{FF2B5EF4-FFF2-40B4-BE49-F238E27FC236}">
-                <a16:creationId xmlns:a16="http://schemas.microsoft.com/office/drawing/2014/main" id="{78FD4821-6AEB-BBB1-BBB7-395E3B0EAC73}"/>
+                <a16:creationId xmlns:a16="http://schemas.microsoft.com/office/drawing/2014/main" id="{1C7F8CC0-6D08-7B45-59F3-BBF15392E154}"/>
               </a:ext>
             </a:extLst>
           </p:cNvPr>
@@ -9166,7 +9255,7 @@
           <p:cNvPr id="3" name="TextBox 2">
             <a:extLst>
               <a:ext uri="{FF2B5EF4-FFF2-40B4-BE49-F238E27FC236}">
-                <a16:creationId xmlns:a16="http://schemas.microsoft.com/office/drawing/2014/main" id="{F5F242B6-6AC7-7DFF-154F-34B6F5182110}"/>
+                <a16:creationId xmlns:a16="http://schemas.microsoft.com/office/drawing/2014/main" id="{74AFFD9F-F7A0-588D-72FA-B46DFAF9F436}"/>
               </a:ext>
             </a:extLst>
           </p:cNvPr>
@@ -9217,7 +9306,7 @@
           <p:cNvPr id="5" name="Picture 4">
             <a:extLst>
               <a:ext uri="{FF2B5EF4-FFF2-40B4-BE49-F238E27FC236}">
-                <a16:creationId xmlns:a16="http://schemas.microsoft.com/office/drawing/2014/main" id="{2C451886-180E-E11B-D55E-84FDF83086B0}"/>
+                <a16:creationId xmlns:a16="http://schemas.microsoft.com/office/drawing/2014/main" id="{E869BD7C-B754-B0AE-EB5F-C296E30F7171}"/>
               </a:ext>
             </a:extLst>
           </p:cNvPr>
@@ -9253,7 +9342,7 @@
           <p:cNvPr id="6" name="TextBox 5">
             <a:extLst>
               <a:ext uri="{FF2B5EF4-FFF2-40B4-BE49-F238E27FC236}">
-                <a16:creationId xmlns:a16="http://schemas.microsoft.com/office/drawing/2014/main" id="{1F826171-4730-F2D7-F782-42A41A222B61}"/>
+                <a16:creationId xmlns:a16="http://schemas.microsoft.com/office/drawing/2014/main" id="{E29206BC-A879-BDD0-25B5-0353882B28DF}"/>
               </a:ext>
             </a:extLst>
           </p:cNvPr>
@@ -9298,7 +9387,7 @@
           <p:cNvPr id="7" name="TextBox 6">
             <a:extLst>
               <a:ext uri="{FF2B5EF4-FFF2-40B4-BE49-F238E27FC236}">
-                <a16:creationId xmlns:a16="http://schemas.microsoft.com/office/drawing/2014/main" id="{30D698A3-3B30-B677-3C74-B3FE874BA7A8}"/>
+                <a16:creationId xmlns:a16="http://schemas.microsoft.com/office/drawing/2014/main" id="{5B86DCB1-F89E-8B1D-0B92-C5C266FB8956}"/>
               </a:ext>
             </a:extLst>
           </p:cNvPr>
@@ -9341,7 +9430,7 @@
     </p:spTree>
     <p:extLst>
       <p:ext uri="{BB962C8B-B14F-4D97-AF65-F5344CB8AC3E}">
-        <p14:creationId xmlns:p14="http://schemas.microsoft.com/office/powerpoint/2010/main" val="2301701190"/>
+        <p14:creationId xmlns:p14="http://schemas.microsoft.com/office/powerpoint/2010/main" val="3088250902"/>
       </p:ext>
     </p:extLst>
   </p:cSld>
@@ -9381,7 +9470,7 @@
           <p:cNvPr id="2" name="TextBox 1">
             <a:extLst>
               <a:ext uri="{FF2B5EF4-FFF2-40B4-BE49-F238E27FC236}">
-                <a16:creationId xmlns:a16="http://schemas.microsoft.com/office/drawing/2014/main" id="{1B6C508C-1A08-18AA-4F2E-E145E495D6CE}"/>
+                <a16:creationId xmlns:a16="http://schemas.microsoft.com/office/drawing/2014/main" id="{F6514883-074A-C1E8-AEF0-8FFE749FB1A1}"/>
               </a:ext>
             </a:extLst>
           </p:cNvPr>
@@ -9426,7 +9515,7 @@
           <p:cNvPr id="3" name="TextBox 2">
             <a:extLst>
               <a:ext uri="{FF2B5EF4-FFF2-40B4-BE49-F238E27FC236}">
-                <a16:creationId xmlns:a16="http://schemas.microsoft.com/office/drawing/2014/main" id="{32A29767-2F1D-4776-1449-12F6012203D7}"/>
+                <a16:creationId xmlns:a16="http://schemas.microsoft.com/office/drawing/2014/main" id="{8E183417-994D-5ECA-0FB8-79662CB9B9F6}"/>
               </a:ext>
             </a:extLst>
           </p:cNvPr>
@@ -9477,7 +9566,7 @@
           <p:cNvPr id="4" name="TextBox 3">
             <a:extLst>
               <a:ext uri="{FF2B5EF4-FFF2-40B4-BE49-F238E27FC236}">
-                <a16:creationId xmlns:a16="http://schemas.microsoft.com/office/drawing/2014/main" id="{E4D2DDD1-E796-0A4D-F852-FD8481D66D85}"/>
+                <a16:creationId xmlns:a16="http://schemas.microsoft.com/office/drawing/2014/main" id="{07F4ED5E-8D6A-7F32-D849-F951948BD9B4}"/>
               </a:ext>
             </a:extLst>
           </p:cNvPr>
@@ -9522,7 +9611,7 @@
           <p:cNvPr id="5" name="TextBox 4">
             <a:extLst>
               <a:ext uri="{FF2B5EF4-FFF2-40B4-BE49-F238E27FC236}">
-                <a16:creationId xmlns:a16="http://schemas.microsoft.com/office/drawing/2014/main" id="{EF4CB36F-39BC-5AB2-2C78-793A5DF728DC}"/>
+                <a16:creationId xmlns:a16="http://schemas.microsoft.com/office/drawing/2014/main" id="{7C99308F-E152-857D-05FB-BFB82ADD489C}"/>
               </a:ext>
             </a:extLst>
           </p:cNvPr>
@@ -9573,7 +9662,7 @@
           <p:cNvPr id="6" name="TextBox 5">
             <a:extLst>
               <a:ext uri="{FF2B5EF4-FFF2-40B4-BE49-F238E27FC236}">
-                <a16:creationId xmlns:a16="http://schemas.microsoft.com/office/drawing/2014/main" id="{6C65F6A9-F98A-33FE-CEA3-A81BED7C4E3A}"/>
+                <a16:creationId xmlns:a16="http://schemas.microsoft.com/office/drawing/2014/main" id="{B2672A35-1A0C-C8B6-091E-AE929FC38D46}"/>
               </a:ext>
             </a:extLst>
           </p:cNvPr>
@@ -9618,7 +9707,7 @@
           <p:cNvPr id="7" name="TextBox 6">
             <a:extLst>
               <a:ext uri="{FF2B5EF4-FFF2-40B4-BE49-F238E27FC236}">
-                <a16:creationId xmlns:a16="http://schemas.microsoft.com/office/drawing/2014/main" id="{F364155C-3E1D-AECE-4449-64D33C278D5B}"/>
+                <a16:creationId xmlns:a16="http://schemas.microsoft.com/office/drawing/2014/main" id="{578022A8-64FD-026D-F893-09BABC198D16}"/>
               </a:ext>
             </a:extLst>
           </p:cNvPr>
@@ -9670,7 +9759,7 @@
           <p:cNvPr id="8" name="TextBox 7">
             <a:extLst>
               <a:ext uri="{FF2B5EF4-FFF2-40B4-BE49-F238E27FC236}">
-                <a16:creationId xmlns:a16="http://schemas.microsoft.com/office/drawing/2014/main" id="{4E96263D-58D9-9B7F-DFDF-08243ABE0364}"/>
+                <a16:creationId xmlns:a16="http://schemas.microsoft.com/office/drawing/2014/main" id="{382F9EF9-98A1-A6E5-8E6D-2198B851FEC7}"/>
               </a:ext>
             </a:extLst>
           </p:cNvPr>
@@ -9721,7 +9810,7 @@
           <p:cNvPr id="9" name="TextBox 8">
             <a:extLst>
               <a:ext uri="{FF2B5EF4-FFF2-40B4-BE49-F238E27FC236}">
-                <a16:creationId xmlns:a16="http://schemas.microsoft.com/office/drawing/2014/main" id="{B5568FF6-CD7B-CBED-F139-1E9B305F8384}"/>
+                <a16:creationId xmlns:a16="http://schemas.microsoft.com/office/drawing/2014/main" id="{27C57052-94AC-A0EF-6D20-BFDC914C4B17}"/>
               </a:ext>
             </a:extLst>
           </p:cNvPr>
@@ -9766,7 +9855,7 @@
           <p:cNvPr id="10" name="TextBox 9">
             <a:extLst>
               <a:ext uri="{FF2B5EF4-FFF2-40B4-BE49-F238E27FC236}">
-                <a16:creationId xmlns:a16="http://schemas.microsoft.com/office/drawing/2014/main" id="{1616F366-AC7F-DF17-2817-16BEAE057A35}"/>
+                <a16:creationId xmlns:a16="http://schemas.microsoft.com/office/drawing/2014/main" id="{71C67DD4-E9B5-E320-069B-4CBA2F66EEE0}"/>
               </a:ext>
             </a:extLst>
           </p:cNvPr>
@@ -9809,7 +9898,7 @@
     </p:spTree>
     <p:extLst>
       <p:ext uri="{BB962C8B-B14F-4D97-AF65-F5344CB8AC3E}">
-        <p14:creationId xmlns:p14="http://schemas.microsoft.com/office/powerpoint/2010/main" val="2627644674"/>
+        <p14:creationId xmlns:p14="http://schemas.microsoft.com/office/powerpoint/2010/main" val="1374742027"/>
       </p:ext>
     </p:extLst>
   </p:cSld>
@@ -9849,7 +9938,1099 @@
           <p:cNvPr id="2" name="TextBox 1">
             <a:extLst>
               <a:ext uri="{FF2B5EF4-FFF2-40B4-BE49-F238E27FC236}">
-                <a16:creationId xmlns:a16="http://schemas.microsoft.com/office/drawing/2014/main" id="{8B689E3D-9D27-3993-6C68-EA2768A436E8}"/>
+                <a16:creationId xmlns:a16="http://schemas.microsoft.com/office/drawing/2014/main" id="{382F05F2-EBA0-7025-C5FD-E7D11816180D}"/>
+              </a:ext>
+            </a:extLst>
+          </p:cNvPr>
+          <p:cNvSpPr txBox="1"/>
+          <p:nvPr/>
+        </p:nvSpPr>
+        <p:spPr>
+          <a:xfrm>
+            <a:off x="609600" y="406399"/>
+            <a:ext cx="10985500" cy="609600"/>
+          </a:xfrm>
+          <a:prstGeom prst="rect">
+            <a:avLst/>
+          </a:prstGeom>
+          <a:noFill/>
+        </p:spPr>
+        <p:txBody>
+          <a:bodyPr vert="horz" wrap="square" lIns="0" tIns="0" rIns="0" bIns="0" rtlCol="0">
+            <a:noAutofit/>
+          </a:bodyPr>
+          <a:lstStyle/>
+          <a:p>
+            <a:pPr>
+              <a:spcAft>
+                <a:spcPts val="800"/>
+              </a:spcAft>
+            </a:pPr>
+            <a:r>
+              <a:rPr lang="en-IN" sz="3200" b="1">
+                <a:solidFill>
+                  <a:srgbClr val="20382A"/>
+                </a:solidFill>
+                <a:latin typeface="Arial" panose="020B0604020202020204" pitchFamily="34" charset="0"/>
+              </a:rPr>
+              <a:t>Backup: learned view weighting</a:t>
+            </a:r>
+          </a:p>
+        </p:txBody>
+      </p:sp>
+      <p:sp>
+        <p:nvSpPr>
+          <p:cNvPr id="3" name="TextBox 2">
+            <a:extLst>
+              <a:ext uri="{FF2B5EF4-FFF2-40B4-BE49-F238E27FC236}">
+                <a16:creationId xmlns:a16="http://schemas.microsoft.com/office/drawing/2014/main" id="{CA4C4C49-3F61-C3A1-9F8E-171561739717}"/>
+              </a:ext>
+            </a:extLst>
+          </p:cNvPr>
+          <p:cNvSpPr txBox="1"/>
+          <p:nvPr/>
+        </p:nvSpPr>
+        <p:spPr>
+          <a:xfrm>
+            <a:off x="622300" y="1142999"/>
+            <a:ext cx="10858500" cy="558800"/>
+          </a:xfrm>
+          <a:prstGeom prst="rect">
+            <a:avLst/>
+          </a:prstGeom>
+          <a:noFill/>
+        </p:spPr>
+        <p:txBody>
+          <a:bodyPr vert="horz" wrap="square" lIns="0" tIns="0" rIns="0" bIns="0" rtlCol="0">
+            <a:noAutofit/>
+          </a:bodyPr>
+          <a:lstStyle/>
+          <a:p>
+            <a:pPr>
+              <a:spcAft>
+                <a:spcPts val="800"/>
+              </a:spcAft>
+            </a:pPr>
+            <a:r>
+              <a:rPr lang="en-US" sz="1500">
+                <a:solidFill>
+                  <a:srgbClr val="72806B"/>
+                </a:solidFill>
+                <a:latin typeface="Arial" panose="020B0604020202020204" pitchFamily="34" charset="0"/>
+              </a:rPr>
+              <a:t>A 42-parameter gate over global, crop and contrast scores</a:t>
+            </a:r>
+            <a:endParaRPr lang="en-IN" sz="1500">
+              <a:solidFill>
+                <a:srgbClr val="72806B"/>
+              </a:solidFill>
+              <a:latin typeface="Arial" panose="020B0604020202020204" pitchFamily="34" charset="0"/>
+            </a:endParaRPr>
+          </a:p>
+        </p:txBody>
+      </p:sp>
+      <p:sp>
+        <p:nvSpPr>
+          <p:cNvPr id="4" name="TextBox 3">
+            <a:extLst>
+              <a:ext uri="{FF2B5EF4-FFF2-40B4-BE49-F238E27FC236}">
+                <a16:creationId xmlns:a16="http://schemas.microsoft.com/office/drawing/2014/main" id="{87B5A1B1-B507-6372-3BD4-1CD97B9F7A3A}"/>
+              </a:ext>
+            </a:extLst>
+          </p:cNvPr>
+          <p:cNvSpPr txBox="1"/>
+          <p:nvPr/>
+        </p:nvSpPr>
+        <p:spPr>
+          <a:xfrm>
+            <a:off x="635000" y="4571999"/>
+            <a:ext cx="10795000" cy="1079500"/>
+          </a:xfrm>
+          <a:prstGeom prst="rect">
+            <a:avLst/>
+          </a:prstGeom>
+          <a:noFill/>
+        </p:spPr>
+        <p:txBody>
+          <a:bodyPr vert="horz" wrap="square" lIns="0" tIns="0" rIns="0" bIns="0" rtlCol="0">
+            <a:noAutofit/>
+          </a:bodyPr>
+          <a:lstStyle/>
+          <a:p>
+            <a:pPr>
+              <a:spcAft>
+                <a:spcPts val="800"/>
+              </a:spcAft>
+            </a:pPr>
+            <a:r>
+              <a:rPr lang="en-US">
+                <a:solidFill>
+                  <a:srgbClr val="20382A"/>
+                </a:solidFill>
+                <a:latin typeface="Arial" panose="020B0604020202020204" pitchFamily="34" charset="0"/>
+              </a:rPr>
+              <a:t>Training: five separate visual-group folds provide gate inputs.
+Validation selects L2 = 10 before this test evaluation.
+Adaptive and constant weights make identical test decisions (618/945).</a:t>
+            </a:r>
+            <a:endParaRPr lang="en-IN">
+              <a:solidFill>
+                <a:srgbClr val="20382A"/>
+              </a:solidFill>
+              <a:latin typeface="Arial" panose="020B0604020202020204" pitchFamily="34" charset="0"/>
+            </a:endParaRPr>
+          </a:p>
+        </p:txBody>
+      </p:sp>
+      <p:graphicFrame>
+        <p:nvGraphicFramePr>
+          <p:cNvPr id="5" name="Table 4">
+            <a:extLst>
+              <a:ext uri="{FF2B5EF4-FFF2-40B4-BE49-F238E27FC236}">
+                <a16:creationId xmlns:a16="http://schemas.microsoft.com/office/drawing/2014/main" id="{9779DB11-F67A-7097-61DD-8EF7CC531FD3}"/>
+              </a:ext>
+            </a:extLst>
+          </p:cNvPr>
+          <p:cNvGraphicFramePr>
+            <a:graphicFrameLocks noGrp="1"/>
+          </p:cNvGraphicFramePr>
+          <p:nvPr>
+            <p:extLst>
+              <p:ext uri="{D42A27DB-BD31-4B8C-83A1-F6EECF244321}">
+                <p14:modId xmlns:p14="http://schemas.microsoft.com/office/powerpoint/2010/main" val="3293800946"/>
+              </p:ext>
+            </p:extLst>
+          </p:nvPr>
+        </p:nvGraphicFramePr>
+        <p:xfrm>
+          <a:off x="635000" y="1841500"/>
+          <a:ext cx="10922000" cy="2603500"/>
+        </p:xfrm>
+        <a:graphic>
+          <a:graphicData uri="http://schemas.openxmlformats.org/drawingml/2006/table">
+            <a:tbl>
+              <a:tblPr firstRow="1" bandRow="1">
+                <a:tableStyleId>{5C22544A-7EE6-4342-B048-85BDC9FD1C3A}</a:tableStyleId>
+              </a:tblPr>
+              <a:tblGrid>
+                <a:gridCol w="4445000">
+                  <a:extLst>
+                    <a:ext uri="{9D8B030D-6E8A-4147-A177-3AD203B41FA5}">
+                      <a16:colId xmlns:a16="http://schemas.microsoft.com/office/drawing/2014/main" val="386033133"/>
+                    </a:ext>
+                  </a:extLst>
+                </a:gridCol>
+                <a:gridCol w="2159000">
+                  <a:extLst>
+                    <a:ext uri="{9D8B030D-6E8A-4147-A177-3AD203B41FA5}">
+                      <a16:colId xmlns:a16="http://schemas.microsoft.com/office/drawing/2014/main" val="3552618037"/>
+                    </a:ext>
+                  </a:extLst>
+                </a:gridCol>
+                <a:gridCol w="2159000">
+                  <a:extLst>
+                    <a:ext uri="{9D8B030D-6E8A-4147-A177-3AD203B41FA5}">
+                      <a16:colId xmlns:a16="http://schemas.microsoft.com/office/drawing/2014/main" val="4127341031"/>
+                    </a:ext>
+                  </a:extLst>
+                </a:gridCol>
+                <a:gridCol w="2159000">
+                  <a:extLst>
+                    <a:ext uri="{9D8B030D-6E8A-4147-A177-3AD203B41FA5}">
+                      <a16:colId xmlns:a16="http://schemas.microsoft.com/office/drawing/2014/main" val="60147"/>
+                    </a:ext>
+                  </a:extLst>
+                </a:gridCol>
+              </a:tblGrid>
+              <a:tr h="650875">
+                <a:tc>
+                  <a:txBody>
+                    <a:bodyPr/>
+                    <a:lstStyle/>
+                    <a:p>
+                      <a:r>
+                        <a:rPr lang="en-IN" sz="1800" b="1">
+                          <a:solidFill>
+                            <a:srgbClr val="FFFFFF"/>
+                          </a:solidFill>
+                          <a:latin typeface="Arial" panose="020B0604020202020204" pitchFamily="34" charset="0"/>
+                        </a:rPr>
+                        <a:t>Fusion</a:t>
+                      </a:r>
+                    </a:p>
+                  </a:txBody>
+                  <a:tcPr marL="114300" marR="76200" marT="63500" marB="50800" anchor="ctr">
+                    <a:lnL w="6350" cmpd="sng">
+                      <a:solidFill>
+                        <a:srgbClr val="D8DFD0"/>
+                      </a:solidFill>
+                    </a:lnL>
+                    <a:lnR w="6350" cmpd="sng">
+                      <a:solidFill>
+                        <a:srgbClr val="D8DFD0"/>
+                      </a:solidFill>
+                    </a:lnR>
+                    <a:lnT w="6350" cmpd="sng">
+                      <a:solidFill>
+                        <a:srgbClr val="D8DFD0"/>
+                      </a:solidFill>
+                    </a:lnT>
+                    <a:lnB w="6350" cmpd="sng">
+                      <a:solidFill>
+                        <a:srgbClr val="D8DFD0"/>
+                      </a:solidFill>
+                    </a:lnB>
+                    <a:solidFill>
+                      <a:srgbClr val="20382A"/>
+                    </a:solidFill>
+                  </a:tcPr>
+                </a:tc>
+                <a:tc>
+                  <a:txBody>
+                    <a:bodyPr/>
+                    <a:lstStyle/>
+                    <a:p>
+                      <a:r>
+                        <a:rPr lang="en-IN" sz="1800" b="1">
+                          <a:solidFill>
+                            <a:srgbClr val="FFFFFF"/>
+                          </a:solidFill>
+                          <a:latin typeface="Arial" panose="020B0604020202020204" pitchFamily="34" charset="0"/>
+                        </a:rPr>
+                        <a:t>Val. F1</a:t>
+                      </a:r>
+                    </a:p>
+                  </a:txBody>
+                  <a:tcPr marL="114300" marR="76200" marT="63500" marB="50800" anchor="ctr">
+                    <a:lnL w="6350" cmpd="sng">
+                      <a:solidFill>
+                        <a:srgbClr val="D8DFD0"/>
+                      </a:solidFill>
+                    </a:lnL>
+                    <a:lnR w="6350" cmpd="sng">
+                      <a:solidFill>
+                        <a:srgbClr val="D8DFD0"/>
+                      </a:solidFill>
+                    </a:lnR>
+                    <a:lnT w="6350" cmpd="sng">
+                      <a:solidFill>
+                        <a:srgbClr val="D8DFD0"/>
+                      </a:solidFill>
+                    </a:lnT>
+                    <a:lnB w="6350" cmpd="sng">
+                      <a:solidFill>
+                        <a:srgbClr val="D8DFD0"/>
+                      </a:solidFill>
+                    </a:lnB>
+                    <a:solidFill>
+                      <a:srgbClr val="20382A"/>
+                    </a:solidFill>
+                  </a:tcPr>
+                </a:tc>
+                <a:tc>
+                  <a:txBody>
+                    <a:bodyPr/>
+                    <a:lstStyle/>
+                    <a:p>
+                      <a:r>
+                        <a:rPr lang="en-IN" sz="1800" b="1">
+                          <a:solidFill>
+                            <a:srgbClr val="FFFFFF"/>
+                          </a:solidFill>
+                          <a:latin typeface="Arial" panose="020B0604020202020204" pitchFamily="34" charset="0"/>
+                        </a:rPr>
+                        <a:t>Test acc.</a:t>
+                      </a:r>
+                    </a:p>
+                  </a:txBody>
+                  <a:tcPr marL="114300" marR="76200" marT="63500" marB="50800" anchor="ctr">
+                    <a:lnL w="6350" cmpd="sng">
+                      <a:solidFill>
+                        <a:srgbClr val="D8DFD0"/>
+                      </a:solidFill>
+                    </a:lnL>
+                    <a:lnR w="6350" cmpd="sng">
+                      <a:solidFill>
+                        <a:srgbClr val="D8DFD0"/>
+                      </a:solidFill>
+                    </a:lnR>
+                    <a:lnT w="6350" cmpd="sng">
+                      <a:solidFill>
+                        <a:srgbClr val="D8DFD0"/>
+                      </a:solidFill>
+                    </a:lnT>
+                    <a:lnB w="6350" cmpd="sng">
+                      <a:solidFill>
+                        <a:srgbClr val="D8DFD0"/>
+                      </a:solidFill>
+                    </a:lnB>
+                    <a:solidFill>
+                      <a:srgbClr val="20382A"/>
+                    </a:solidFill>
+                  </a:tcPr>
+                </a:tc>
+                <a:tc>
+                  <a:txBody>
+                    <a:bodyPr/>
+                    <a:lstStyle/>
+                    <a:p>
+                      <a:r>
+                        <a:rPr lang="en-IN" sz="1800" b="1">
+                          <a:solidFill>
+                            <a:srgbClr val="FFFFFF"/>
+                          </a:solidFill>
+                          <a:latin typeface="Arial" panose="020B0604020202020204" pitchFamily="34" charset="0"/>
+                        </a:rPr>
+                        <a:t>Test F1</a:t>
+                      </a:r>
+                    </a:p>
+                  </a:txBody>
+                  <a:tcPr marL="114300" marR="76200" marT="63500" marB="50800" anchor="ctr">
+                    <a:lnL w="6350" cmpd="sng">
+                      <a:solidFill>
+                        <a:srgbClr val="D8DFD0"/>
+                      </a:solidFill>
+                    </a:lnL>
+                    <a:lnR w="6350" cmpd="sng">
+                      <a:solidFill>
+                        <a:srgbClr val="D8DFD0"/>
+                      </a:solidFill>
+                    </a:lnR>
+                    <a:lnT w="6350" cmpd="sng">
+                      <a:solidFill>
+                        <a:srgbClr val="D8DFD0"/>
+                      </a:solidFill>
+                    </a:lnT>
+                    <a:lnB w="6350" cmpd="sng">
+                      <a:solidFill>
+                        <a:srgbClr val="D8DFD0"/>
+                      </a:solidFill>
+                    </a:lnB>
+                    <a:solidFill>
+                      <a:srgbClr val="20382A"/>
+                    </a:solidFill>
+                  </a:tcPr>
+                </a:tc>
+                <a:extLst>
+                  <a:ext uri="{0D108BD9-81ED-4DB2-BD59-A6C34878D82A}">
+                    <a16:rowId xmlns:a16="http://schemas.microsoft.com/office/drawing/2014/main" val="1550704346"/>
+                  </a:ext>
+                </a:extLst>
+              </a:tr>
+              <a:tr h="650875">
+                <a:tc>
+                  <a:txBody>
+                    <a:bodyPr/>
+                    <a:lstStyle/>
+                    <a:p>
+                      <a:r>
+                        <a:rPr lang="en-IN" sz="1800" b="0">
+                          <a:solidFill>
+                            <a:srgbClr val="20382A"/>
+                          </a:solidFill>
+                          <a:latin typeface="Arial" panose="020B0604020202020204" pitchFamily="34" charset="0"/>
+                        </a:rPr>
+                        <a:t>Uniform weights</a:t>
+                      </a:r>
+                    </a:p>
+                  </a:txBody>
+                  <a:tcPr marL="114300" marR="76200" marT="63500" marB="50800" anchor="ctr">
+                    <a:lnL w="6350" cmpd="sng">
+                      <a:solidFill>
+                        <a:srgbClr val="D8DFD0"/>
+                      </a:solidFill>
+                    </a:lnL>
+                    <a:lnR w="6350" cmpd="sng">
+                      <a:solidFill>
+                        <a:srgbClr val="D8DFD0"/>
+                      </a:solidFill>
+                    </a:lnR>
+                    <a:lnT w="6350" cmpd="sng">
+                      <a:solidFill>
+                        <a:srgbClr val="D8DFD0"/>
+                      </a:solidFill>
+                    </a:lnT>
+                    <a:lnB w="6350" cmpd="sng">
+                      <a:solidFill>
+                        <a:srgbClr val="D8DFD0"/>
+                      </a:solidFill>
+                    </a:lnB>
+                    <a:solidFill>
+                      <a:srgbClr val="FFFFFF"/>
+                    </a:solidFill>
+                  </a:tcPr>
+                </a:tc>
+                <a:tc>
+                  <a:txBody>
+                    <a:bodyPr/>
+                    <a:lstStyle/>
+                    <a:p>
+                      <a:r>
+                        <a:rPr lang="en-IN" sz="1800" b="0">
+                          <a:solidFill>
+                            <a:srgbClr val="20382A"/>
+                          </a:solidFill>
+                          <a:latin typeface="Arial" panose="020B0604020202020204" pitchFamily="34" charset="0"/>
+                        </a:rPr>
+                        <a:t>78.6%</a:t>
+                      </a:r>
+                    </a:p>
+                  </a:txBody>
+                  <a:tcPr marL="114300" marR="76200" marT="63500" marB="50800" anchor="ctr">
+                    <a:lnL w="6350" cmpd="sng">
+                      <a:solidFill>
+                        <a:srgbClr val="D8DFD0"/>
+                      </a:solidFill>
+                    </a:lnL>
+                    <a:lnR w="6350" cmpd="sng">
+                      <a:solidFill>
+                        <a:srgbClr val="D8DFD0"/>
+                      </a:solidFill>
+                    </a:lnR>
+                    <a:lnT w="6350" cmpd="sng">
+                      <a:solidFill>
+                        <a:srgbClr val="D8DFD0"/>
+                      </a:solidFill>
+                    </a:lnT>
+                    <a:lnB w="6350" cmpd="sng">
+                      <a:solidFill>
+                        <a:srgbClr val="D8DFD0"/>
+                      </a:solidFill>
+                    </a:lnB>
+                    <a:solidFill>
+                      <a:srgbClr val="FFFFFF"/>
+                    </a:solidFill>
+                  </a:tcPr>
+                </a:tc>
+                <a:tc>
+                  <a:txBody>
+                    <a:bodyPr/>
+                    <a:lstStyle/>
+                    <a:p>
+                      <a:r>
+                        <a:rPr lang="en-IN" sz="1800" b="0">
+                          <a:solidFill>
+                            <a:srgbClr val="20382A"/>
+                          </a:solidFill>
+                          <a:latin typeface="Arial" panose="020B0604020202020204" pitchFamily="34" charset="0"/>
+                        </a:rPr>
+                        <a:t>65.1%</a:t>
+                      </a:r>
+                    </a:p>
+                  </a:txBody>
+                  <a:tcPr marL="114300" marR="76200" marT="63500" marB="50800" anchor="ctr">
+                    <a:lnL w="6350" cmpd="sng">
+                      <a:solidFill>
+                        <a:srgbClr val="D8DFD0"/>
+                      </a:solidFill>
+                    </a:lnL>
+                    <a:lnR w="6350" cmpd="sng">
+                      <a:solidFill>
+                        <a:srgbClr val="D8DFD0"/>
+                      </a:solidFill>
+                    </a:lnR>
+                    <a:lnT w="6350" cmpd="sng">
+                      <a:solidFill>
+                        <a:srgbClr val="D8DFD0"/>
+                      </a:solidFill>
+                    </a:lnT>
+                    <a:lnB w="6350" cmpd="sng">
+                      <a:solidFill>
+                        <a:srgbClr val="D8DFD0"/>
+                      </a:solidFill>
+                    </a:lnB>
+                    <a:solidFill>
+                      <a:srgbClr val="FFFFFF"/>
+                    </a:solidFill>
+                  </a:tcPr>
+                </a:tc>
+                <a:tc>
+                  <a:txBody>
+                    <a:bodyPr/>
+                    <a:lstStyle/>
+                    <a:p>
+                      <a:r>
+                        <a:rPr lang="en-IN" sz="1800" b="0">
+                          <a:solidFill>
+                            <a:srgbClr val="20382A"/>
+                          </a:solidFill>
+                          <a:latin typeface="Arial" panose="020B0604020202020204" pitchFamily="34" charset="0"/>
+                        </a:rPr>
+                        <a:t>64.5%</a:t>
+                      </a:r>
+                    </a:p>
+                  </a:txBody>
+                  <a:tcPr marL="114300" marR="76200" marT="63500" marB="50800" anchor="ctr">
+                    <a:lnL w="6350" cmpd="sng">
+                      <a:solidFill>
+                        <a:srgbClr val="D8DFD0"/>
+                      </a:solidFill>
+                    </a:lnL>
+                    <a:lnR w="6350" cmpd="sng">
+                      <a:solidFill>
+                        <a:srgbClr val="D8DFD0"/>
+                      </a:solidFill>
+                    </a:lnR>
+                    <a:lnT w="6350" cmpd="sng">
+                      <a:solidFill>
+                        <a:srgbClr val="D8DFD0"/>
+                      </a:solidFill>
+                    </a:lnT>
+                    <a:lnB w="6350" cmpd="sng">
+                      <a:solidFill>
+                        <a:srgbClr val="D8DFD0"/>
+                      </a:solidFill>
+                    </a:lnB>
+                    <a:solidFill>
+                      <a:srgbClr val="FFFFFF"/>
+                    </a:solidFill>
+                  </a:tcPr>
+                </a:tc>
+                <a:extLst>
+                  <a:ext uri="{0D108BD9-81ED-4DB2-BD59-A6C34878D82A}">
+                    <a16:rowId xmlns:a16="http://schemas.microsoft.com/office/drawing/2014/main" val="61135143"/>
+                  </a:ext>
+                </a:extLst>
+              </a:tr>
+              <a:tr h="650875">
+                <a:tc>
+                  <a:txBody>
+                    <a:bodyPr/>
+                    <a:lstStyle/>
+                    <a:p>
+                      <a:r>
+                        <a:rPr lang="en-IN" sz="1800" b="0">
+                          <a:solidFill>
+                            <a:srgbClr val="20382A"/>
+                          </a:solidFill>
+                          <a:latin typeface="Arial" panose="020B0604020202020204" pitchFamily="34" charset="0"/>
+                        </a:rPr>
+                        <a:t>Learned constant</a:t>
+                      </a:r>
+                    </a:p>
+                  </a:txBody>
+                  <a:tcPr marL="114300" marR="76200" marT="63500" marB="50800" anchor="ctr">
+                    <a:lnL w="6350" cmpd="sng">
+                      <a:solidFill>
+                        <a:srgbClr val="D8DFD0"/>
+                      </a:solidFill>
+                    </a:lnL>
+                    <a:lnR w="6350" cmpd="sng">
+                      <a:solidFill>
+                        <a:srgbClr val="D8DFD0"/>
+                      </a:solidFill>
+                    </a:lnR>
+                    <a:lnT w="6350" cmpd="sng">
+                      <a:solidFill>
+                        <a:srgbClr val="D8DFD0"/>
+                      </a:solidFill>
+                    </a:lnT>
+                    <a:lnB w="6350" cmpd="sng">
+                      <a:solidFill>
+                        <a:srgbClr val="D8DFD0"/>
+                      </a:solidFill>
+                    </a:lnB>
+                    <a:solidFill>
+                      <a:srgbClr val="EEF2E7"/>
+                    </a:solidFill>
+                  </a:tcPr>
+                </a:tc>
+                <a:tc>
+                  <a:txBody>
+                    <a:bodyPr/>
+                    <a:lstStyle/>
+                    <a:p>
+                      <a:r>
+                        <a:rPr lang="en-IN" sz="1800" b="0">
+                          <a:solidFill>
+                            <a:srgbClr val="20382A"/>
+                          </a:solidFill>
+                          <a:latin typeface="Arial" panose="020B0604020202020204" pitchFamily="34" charset="0"/>
+                        </a:rPr>
+                        <a:t>78.8%</a:t>
+                      </a:r>
+                    </a:p>
+                  </a:txBody>
+                  <a:tcPr marL="114300" marR="76200" marT="63500" marB="50800" anchor="ctr">
+                    <a:lnL w="6350" cmpd="sng">
+                      <a:solidFill>
+                        <a:srgbClr val="D8DFD0"/>
+                      </a:solidFill>
+                    </a:lnL>
+                    <a:lnR w="6350" cmpd="sng">
+                      <a:solidFill>
+                        <a:srgbClr val="D8DFD0"/>
+                      </a:solidFill>
+                    </a:lnR>
+                    <a:lnT w="6350" cmpd="sng">
+                      <a:solidFill>
+                        <a:srgbClr val="D8DFD0"/>
+                      </a:solidFill>
+                    </a:lnT>
+                    <a:lnB w="6350" cmpd="sng">
+                      <a:solidFill>
+                        <a:srgbClr val="D8DFD0"/>
+                      </a:solidFill>
+                    </a:lnB>
+                    <a:solidFill>
+                      <a:srgbClr val="EEF2E7"/>
+                    </a:solidFill>
+                  </a:tcPr>
+                </a:tc>
+                <a:tc>
+                  <a:txBody>
+                    <a:bodyPr/>
+                    <a:lstStyle/>
+                    <a:p>
+                      <a:r>
+                        <a:rPr lang="en-IN" sz="1800" b="0">
+                          <a:solidFill>
+                            <a:srgbClr val="20382A"/>
+                          </a:solidFill>
+                          <a:latin typeface="Arial" panose="020B0604020202020204" pitchFamily="34" charset="0"/>
+                        </a:rPr>
+                        <a:t>65.4%</a:t>
+                      </a:r>
+                    </a:p>
+                  </a:txBody>
+                  <a:tcPr marL="114300" marR="76200" marT="63500" marB="50800" anchor="ctr">
+                    <a:lnL w="6350" cmpd="sng">
+                      <a:solidFill>
+                        <a:srgbClr val="D8DFD0"/>
+                      </a:solidFill>
+                    </a:lnL>
+                    <a:lnR w="6350" cmpd="sng">
+                      <a:solidFill>
+                        <a:srgbClr val="D8DFD0"/>
+                      </a:solidFill>
+                    </a:lnR>
+                    <a:lnT w="6350" cmpd="sng">
+                      <a:solidFill>
+                        <a:srgbClr val="D8DFD0"/>
+                      </a:solidFill>
+                    </a:lnT>
+                    <a:lnB w="6350" cmpd="sng">
+                      <a:solidFill>
+                        <a:srgbClr val="D8DFD0"/>
+                      </a:solidFill>
+                    </a:lnB>
+                    <a:solidFill>
+                      <a:srgbClr val="EEF2E7"/>
+                    </a:solidFill>
+                  </a:tcPr>
+                </a:tc>
+                <a:tc>
+                  <a:txBody>
+                    <a:bodyPr/>
+                    <a:lstStyle/>
+                    <a:p>
+                      <a:r>
+                        <a:rPr lang="en-IN" sz="1800" b="0">
+                          <a:solidFill>
+                            <a:srgbClr val="20382A"/>
+                          </a:solidFill>
+                          <a:latin typeface="Arial" panose="020B0604020202020204" pitchFamily="34" charset="0"/>
+                        </a:rPr>
+                        <a:t>64.8%</a:t>
+                      </a:r>
+                    </a:p>
+                  </a:txBody>
+                  <a:tcPr marL="114300" marR="76200" marT="63500" marB="50800" anchor="ctr">
+                    <a:lnL w="6350" cmpd="sng">
+                      <a:solidFill>
+                        <a:srgbClr val="D8DFD0"/>
+                      </a:solidFill>
+                    </a:lnL>
+                    <a:lnR w="6350" cmpd="sng">
+                      <a:solidFill>
+                        <a:srgbClr val="D8DFD0"/>
+                      </a:solidFill>
+                    </a:lnR>
+                    <a:lnT w="6350" cmpd="sng">
+                      <a:solidFill>
+                        <a:srgbClr val="D8DFD0"/>
+                      </a:solidFill>
+                    </a:lnT>
+                    <a:lnB w="6350" cmpd="sng">
+                      <a:solidFill>
+                        <a:srgbClr val="D8DFD0"/>
+                      </a:solidFill>
+                    </a:lnB>
+                    <a:solidFill>
+                      <a:srgbClr val="EEF2E7"/>
+                    </a:solidFill>
+                  </a:tcPr>
+                </a:tc>
+                <a:extLst>
+                  <a:ext uri="{0D108BD9-81ED-4DB2-BD59-A6C34878D82A}">
+                    <a16:rowId xmlns:a16="http://schemas.microsoft.com/office/drawing/2014/main" val="892549171"/>
+                  </a:ext>
+                </a:extLst>
+              </a:tr>
+              <a:tr h="650875">
+                <a:tc>
+                  <a:txBody>
+                    <a:bodyPr/>
+                    <a:lstStyle/>
+                    <a:p>
+                      <a:r>
+                        <a:rPr lang="en-IN" sz="1800" b="0">
+                          <a:solidFill>
+                            <a:srgbClr val="20382A"/>
+                          </a:solidFill>
+                          <a:latin typeface="Arial" panose="020B0604020202020204" pitchFamily="34" charset="0"/>
+                        </a:rPr>
+                        <a:t>Learned adaptive</a:t>
+                      </a:r>
+                    </a:p>
+                  </a:txBody>
+                  <a:tcPr marL="114300" marR="76200" marT="63500" marB="50800" anchor="ctr">
+                    <a:lnL w="6350" cmpd="sng">
+                      <a:solidFill>
+                        <a:srgbClr val="D8DFD0"/>
+                      </a:solidFill>
+                    </a:lnL>
+                    <a:lnR w="6350" cmpd="sng">
+                      <a:solidFill>
+                        <a:srgbClr val="D8DFD0"/>
+                      </a:solidFill>
+                    </a:lnR>
+                    <a:lnT w="6350" cmpd="sng">
+                      <a:solidFill>
+                        <a:srgbClr val="D8DFD0"/>
+                      </a:solidFill>
+                    </a:lnT>
+                    <a:lnB w="6350" cmpd="sng">
+                      <a:solidFill>
+                        <a:srgbClr val="D8DFD0"/>
+                      </a:solidFill>
+                    </a:lnB>
+                    <a:solidFill>
+                      <a:srgbClr val="FFFFFF"/>
+                    </a:solidFill>
+                  </a:tcPr>
+                </a:tc>
+                <a:tc>
+                  <a:txBody>
+                    <a:bodyPr/>
+                    <a:lstStyle/>
+                    <a:p>
+                      <a:r>
+                        <a:rPr lang="en-IN" sz="1800" b="0">
+                          <a:solidFill>
+                            <a:srgbClr val="20382A"/>
+                          </a:solidFill>
+                          <a:latin typeface="Arial" panose="020B0604020202020204" pitchFamily="34" charset="0"/>
+                        </a:rPr>
+                        <a:t>78.8%</a:t>
+                      </a:r>
+                    </a:p>
+                  </a:txBody>
+                  <a:tcPr marL="114300" marR="76200" marT="63500" marB="50800" anchor="ctr">
+                    <a:lnL w="6350" cmpd="sng">
+                      <a:solidFill>
+                        <a:srgbClr val="D8DFD0"/>
+                      </a:solidFill>
+                    </a:lnL>
+                    <a:lnR w="6350" cmpd="sng">
+                      <a:solidFill>
+                        <a:srgbClr val="D8DFD0"/>
+                      </a:solidFill>
+                    </a:lnR>
+                    <a:lnT w="6350" cmpd="sng">
+                      <a:solidFill>
+                        <a:srgbClr val="D8DFD0"/>
+                      </a:solidFill>
+                    </a:lnT>
+                    <a:lnB w="6350" cmpd="sng">
+                      <a:solidFill>
+                        <a:srgbClr val="D8DFD0"/>
+                      </a:solidFill>
+                    </a:lnB>
+                    <a:solidFill>
+                      <a:srgbClr val="FFFFFF"/>
+                    </a:solidFill>
+                  </a:tcPr>
+                </a:tc>
+                <a:tc>
+                  <a:txBody>
+                    <a:bodyPr/>
+                    <a:lstStyle/>
+                    <a:p>
+                      <a:r>
+                        <a:rPr lang="en-IN" sz="1800" b="0">
+                          <a:solidFill>
+                            <a:srgbClr val="20382A"/>
+                          </a:solidFill>
+                          <a:latin typeface="Arial" panose="020B0604020202020204" pitchFamily="34" charset="0"/>
+                        </a:rPr>
+                        <a:t>65.4%</a:t>
+                      </a:r>
+                    </a:p>
+                  </a:txBody>
+                  <a:tcPr marL="114300" marR="76200" marT="63500" marB="50800" anchor="ctr">
+                    <a:lnL w="6350" cmpd="sng">
+                      <a:solidFill>
+                        <a:srgbClr val="D8DFD0"/>
+                      </a:solidFill>
+                    </a:lnL>
+                    <a:lnR w="6350" cmpd="sng">
+                      <a:solidFill>
+                        <a:srgbClr val="D8DFD0"/>
+                      </a:solidFill>
+                    </a:lnR>
+                    <a:lnT w="6350" cmpd="sng">
+                      <a:solidFill>
+                        <a:srgbClr val="D8DFD0"/>
+                      </a:solidFill>
+                    </a:lnT>
+                    <a:lnB w="6350" cmpd="sng">
+                      <a:solidFill>
+                        <a:srgbClr val="D8DFD0"/>
+                      </a:solidFill>
+                    </a:lnB>
+                    <a:solidFill>
+                      <a:srgbClr val="FFFFFF"/>
+                    </a:solidFill>
+                  </a:tcPr>
+                </a:tc>
+                <a:tc>
+                  <a:txBody>
+                    <a:bodyPr/>
+                    <a:lstStyle/>
+                    <a:p>
+                      <a:r>
+                        <a:rPr lang="en-IN" sz="1800" b="0">
+                          <a:solidFill>
+                            <a:srgbClr val="20382A"/>
+                          </a:solidFill>
+                          <a:latin typeface="Arial" panose="020B0604020202020204" pitchFamily="34" charset="0"/>
+                        </a:rPr>
+                        <a:t>64.8%</a:t>
+                      </a:r>
+                    </a:p>
+                  </a:txBody>
+                  <a:tcPr marL="114300" marR="76200" marT="63500" marB="50800" anchor="ctr">
+                    <a:lnL w="6350" cmpd="sng">
+                      <a:solidFill>
+                        <a:srgbClr val="D8DFD0"/>
+                      </a:solidFill>
+                    </a:lnL>
+                    <a:lnR w="6350" cmpd="sng">
+                      <a:solidFill>
+                        <a:srgbClr val="D8DFD0"/>
+                      </a:solidFill>
+                    </a:lnR>
+                    <a:lnT w="6350" cmpd="sng">
+                      <a:solidFill>
+                        <a:srgbClr val="D8DFD0"/>
+                      </a:solidFill>
+                    </a:lnT>
+                    <a:lnB w="6350" cmpd="sng">
+                      <a:solidFill>
+                        <a:srgbClr val="D8DFD0"/>
+                      </a:solidFill>
+                    </a:lnB>
+                    <a:solidFill>
+                      <a:srgbClr val="FFFFFF"/>
+                    </a:solidFill>
+                  </a:tcPr>
+                </a:tc>
+                <a:extLst>
+                  <a:ext uri="{0D108BD9-81ED-4DB2-BD59-A6C34878D82A}">
+                    <a16:rowId xmlns:a16="http://schemas.microsoft.com/office/drawing/2014/main" val="1109583631"/>
+                  </a:ext>
+                </a:extLst>
+              </a:tr>
+            </a:tbl>
+          </a:graphicData>
+        </a:graphic>
+      </p:graphicFrame>
+      <p:sp>
+        <p:nvSpPr>
+          <p:cNvPr id="6" name="TextBox 5">
+            <a:extLst>
+              <a:ext uri="{FF2B5EF4-FFF2-40B4-BE49-F238E27FC236}">
+                <a16:creationId xmlns:a16="http://schemas.microsoft.com/office/drawing/2014/main" id="{EFD6C838-4F0E-29D0-D766-75837E19390C}"/>
+              </a:ext>
+            </a:extLst>
+          </p:cNvPr>
+          <p:cNvSpPr txBox="1"/>
+          <p:nvPr/>
+        </p:nvSpPr>
+        <p:spPr>
+          <a:xfrm>
+            <a:off x="635000" y="5702299"/>
+            <a:ext cx="10858500" cy="533400"/>
+          </a:xfrm>
+          <a:prstGeom prst="rect">
+            <a:avLst/>
+          </a:prstGeom>
+          <a:noFill/>
+        </p:spPr>
+        <p:txBody>
+          <a:bodyPr vert="horz" wrap="square" lIns="0" tIns="0" rIns="0" bIns="0" rtlCol="0">
+            <a:noAutofit/>
+          </a:bodyPr>
+          <a:lstStyle/>
+          <a:p>
+            <a:pPr>
+              <a:spcAft>
+                <a:spcPts val="800"/>
+              </a:spcAft>
+            </a:pPr>
+            <a:r>
+              <a:rPr lang="en-US" sz="1600">
+                <a:solidFill>
+                  <a:srgbClr val="AF623E"/>
+                </a:solidFill>
+                <a:latin typeface="Arial" panose="020B0604020202020204" pitchFamily="34" charset="0"/>
+              </a:rPr>
+              <a:t>No improvement over simpler fusion. The demo retains contrast (619/945).</a:t>
+            </a:r>
+            <a:endParaRPr lang="en-IN" sz="1600">
+              <a:solidFill>
+                <a:srgbClr val="AF623E"/>
+              </a:solidFill>
+              <a:latin typeface="Arial" panose="020B0604020202020204" pitchFamily="34" charset="0"/>
+            </a:endParaRPr>
+          </a:p>
+        </p:txBody>
+      </p:sp>
+      <p:sp>
+        <p:nvSpPr>
+          <p:cNvPr id="7" name="TextBox 6">
+            <a:extLst>
+              <a:ext uri="{FF2B5EF4-FFF2-40B4-BE49-F238E27FC236}">
+                <a16:creationId xmlns:a16="http://schemas.microsoft.com/office/drawing/2014/main" id="{8EC922E8-6A3F-6493-A395-5704E3A72A4D}"/>
+              </a:ext>
+            </a:extLst>
+          </p:cNvPr>
+          <p:cNvSpPr txBox="1"/>
+          <p:nvPr/>
+        </p:nvSpPr>
+        <p:spPr>
+          <a:xfrm>
+            <a:off x="635000" y="6489700"/>
+            <a:ext cx="9525000" cy="190500"/>
+          </a:xfrm>
+          <a:prstGeom prst="rect">
+            <a:avLst/>
+          </a:prstGeom>
+          <a:noFill/>
+        </p:spPr>
+        <p:txBody>
+          <a:bodyPr vert="horz" wrap="square" lIns="0" tIns="0" rIns="0" bIns="0" rtlCol="0">
+            <a:noAutofit/>
+          </a:bodyPr>
+          <a:lstStyle/>
+          <a:p>
+            <a:pPr>
+              <a:spcAft>
+                <a:spcPts val="800"/>
+              </a:spcAft>
+            </a:pPr>
+            <a:r>
+              <a:rPr lang="en-IN" sz="800">
+                <a:solidFill>
+                  <a:srgbClr val="72806B"/>
+                </a:solidFill>
+                <a:latin typeface="Arial" panose="020B0604020202020204" pitchFamily="34" charset="0"/>
+              </a:rPr>
+              <a:t>CRICKET SHOT RECOGNITION / EE604</a:t>
+            </a:r>
+          </a:p>
+        </p:txBody>
+      </p:sp>
+      <p:sp>
+        <p:nvSpPr>
+          <p:cNvPr id="8" name="TextBox 7">
+            <a:extLst>
+              <a:ext uri="{FF2B5EF4-FFF2-40B4-BE49-F238E27FC236}">
+                <a16:creationId xmlns:a16="http://schemas.microsoft.com/office/drawing/2014/main" id="{64C1D8BD-2A7A-D887-4CF7-89C1CF11B4F4}"/>
+              </a:ext>
+            </a:extLst>
+          </p:cNvPr>
+          <p:cNvSpPr txBox="1"/>
+          <p:nvPr/>
+        </p:nvSpPr>
+        <p:spPr>
+          <a:xfrm>
+            <a:off x="11214100" y="6451600"/>
+            <a:ext cx="317500" cy="228600"/>
+          </a:xfrm>
+          <a:prstGeom prst="rect">
+            <a:avLst/>
+          </a:prstGeom>
+          <a:noFill/>
+        </p:spPr>
+        <p:txBody>
+          <a:bodyPr vert="horz" wrap="square" lIns="0" tIns="0" rIns="0" bIns="0" rtlCol="0">
+            <a:noAutofit/>
+          </a:bodyPr>
+          <a:lstStyle/>
+          <a:p>
+            <a:pPr>
+              <a:spcAft>
+                <a:spcPts val="800"/>
+              </a:spcAft>
+            </a:pPr>
+            <a:r>
+              <a:rPr lang="en-IN" sz="1000">
+                <a:solidFill>
+                  <a:srgbClr val="72806B"/>
+                </a:solidFill>
+                <a:latin typeface="Arial" panose="020B0604020202020204" pitchFamily="34" charset="0"/>
+              </a:rPr>
+              <a:t>16</a:t>
+            </a:r>
+          </a:p>
+        </p:txBody>
+      </p:sp>
+    </p:spTree>
+    <p:extLst>
+      <p:ext uri="{BB962C8B-B14F-4D97-AF65-F5344CB8AC3E}">
+        <p14:creationId xmlns:p14="http://schemas.microsoft.com/office/powerpoint/2010/main" val="3994283891"/>
+      </p:ext>
+    </p:extLst>
+  </p:cSld>
+  <p:clrMapOvr>
+    <a:masterClrMapping/>
+  </p:clrMapOvr>
+</p:sld>
+</file>
+
+<file path=ppt/slides/slide17.xml><?xml version="1.0" encoding="utf-8"?>
+<p:sld xmlns:a="http://schemas.openxmlformats.org/drawingml/2006/main" xmlns:r="http://schemas.openxmlformats.org/officeDocument/2006/relationships" xmlns:p="http://schemas.openxmlformats.org/presentationml/2006/main">
+  <p:cSld>
+    <p:bg>
+      <p:bgPr>
+        <a:solidFill>
+          <a:srgbClr val="F7F8F1"/>
+        </a:solidFill>
+        <a:effectLst/>
+      </p:bgPr>
+    </p:bg>
+    <p:spTree>
+      <p:nvGrpSpPr>
+        <p:cNvPr id="1" name=""/>
+        <p:cNvGrpSpPr/>
+        <p:nvPr/>
+      </p:nvGrpSpPr>
+      <p:grpSpPr>
+        <a:xfrm>
+          <a:off x="0" y="0"/>
+          <a:ext cx="0" cy="0"/>
+          <a:chOff x="0" y="0"/>
+          <a:chExt cx="0" cy="0"/>
+        </a:xfrm>
+      </p:grpSpPr>
+      <p:sp>
+        <p:nvSpPr>
+          <p:cNvPr id="2" name="TextBox 1">
+            <a:extLst>
+              <a:ext uri="{FF2B5EF4-FFF2-40B4-BE49-F238E27FC236}">
+                <a16:creationId xmlns:a16="http://schemas.microsoft.com/office/drawing/2014/main" id="{05F37411-EBF4-C149-A4A9-2CA5D2CFE1C1}"/>
               </a:ext>
             </a:extLst>
           </p:cNvPr>
@@ -9900,7 +11081,7 @@
           <p:cNvPr id="3" name="TextBox 2">
             <a:extLst>
               <a:ext uri="{FF2B5EF4-FFF2-40B4-BE49-F238E27FC236}">
-                <a16:creationId xmlns:a16="http://schemas.microsoft.com/office/drawing/2014/main" id="{4EB4B66E-6C03-F341-CA4F-3DC0E0209087}"/>
+                <a16:creationId xmlns:a16="http://schemas.microsoft.com/office/drawing/2014/main" id="{B155BF02-B132-50D2-6CAC-818D68877E8F}"/>
               </a:ext>
             </a:extLst>
           </p:cNvPr>
@@ -9951,7 +11132,7 @@
           <p:cNvPr id="4" name="TextBox 3">
             <a:extLst>
               <a:ext uri="{FF2B5EF4-FFF2-40B4-BE49-F238E27FC236}">
-                <a16:creationId xmlns:a16="http://schemas.microsoft.com/office/drawing/2014/main" id="{55436288-FDD5-BD95-559F-7E6B3607FCAF}"/>
+                <a16:creationId xmlns:a16="http://schemas.microsoft.com/office/drawing/2014/main" id="{49CA2941-4292-574D-F848-C9DE3C517E57}"/>
               </a:ext>
             </a:extLst>
           </p:cNvPr>
@@ -10003,7 +11184,7 @@
           <p:cNvPr id="5" name="Table 4">
             <a:extLst>
               <a:ext uri="{FF2B5EF4-FFF2-40B4-BE49-F238E27FC236}">
-                <a16:creationId xmlns:a16="http://schemas.microsoft.com/office/drawing/2014/main" id="{FCC879BD-36CA-BF78-C412-FFD45A4BE4E8}"/>
+                <a16:creationId xmlns:a16="http://schemas.microsoft.com/office/drawing/2014/main" id="{E84FA85A-F4F8-6D8A-E782-2C58595A57E3}"/>
               </a:ext>
             </a:extLst>
           </p:cNvPr>
@@ -10013,7 +11194,7 @@
           <p:nvPr>
             <p:extLst>
               <p:ext uri="{D42A27DB-BD31-4B8C-83A1-F6EECF244321}">
-                <p14:modId xmlns:p14="http://schemas.microsoft.com/office/powerpoint/2010/main" val="3387001524"/>
+                <p14:modId xmlns:p14="http://schemas.microsoft.com/office/powerpoint/2010/main" val="2909183236"/>
               </p:ext>
             </p:extLst>
           </p:nvPr>
@@ -10032,21 +11213,21 @@
                 <a:gridCol w="5715000">
                   <a:extLst>
                     <a:ext uri="{9D8B030D-6E8A-4147-A177-3AD203B41FA5}">
-                      <a16:colId xmlns:a16="http://schemas.microsoft.com/office/drawing/2014/main" val="948693385"/>
+                      <a16:colId xmlns:a16="http://schemas.microsoft.com/office/drawing/2014/main" val="259443737"/>
                     </a:ext>
                   </a:extLst>
                 </a:gridCol>
                 <a:gridCol w="2603500">
                   <a:extLst>
                     <a:ext uri="{9D8B030D-6E8A-4147-A177-3AD203B41FA5}">
-                      <a16:colId xmlns:a16="http://schemas.microsoft.com/office/drawing/2014/main" val="3169428359"/>
+                      <a16:colId xmlns:a16="http://schemas.microsoft.com/office/drawing/2014/main" val="1978443700"/>
                     </a:ext>
                   </a:extLst>
                 </a:gridCol>
                 <a:gridCol w="2603500">
                   <a:extLst>
                     <a:ext uri="{9D8B030D-6E8A-4147-A177-3AD203B41FA5}">
-                      <a16:colId xmlns:a16="http://schemas.microsoft.com/office/drawing/2014/main" val="4931970"/>
+                      <a16:colId xmlns:a16="http://schemas.microsoft.com/office/drawing/2014/main" val="1840925961"/>
                     </a:ext>
                   </a:extLst>
                 </a:gridCol>
@@ -10180,7 +11361,7 @@
                 </a:tc>
                 <a:extLst>
                   <a:ext uri="{0D108BD9-81ED-4DB2-BD59-A6C34878D82A}">
-                    <a16:rowId xmlns:a16="http://schemas.microsoft.com/office/drawing/2014/main" val="3584294335"/>
+                    <a16:rowId xmlns:a16="http://schemas.microsoft.com/office/drawing/2014/main" val="196141472"/>
                   </a:ext>
                 </a:extLst>
               </a:tr>
@@ -10313,7 +11494,7 @@
                 </a:tc>
                 <a:extLst>
                   <a:ext uri="{0D108BD9-81ED-4DB2-BD59-A6C34878D82A}">
-                    <a16:rowId xmlns:a16="http://schemas.microsoft.com/office/drawing/2014/main" val="1349346348"/>
+                    <a16:rowId xmlns:a16="http://schemas.microsoft.com/office/drawing/2014/main" val="1748093619"/>
                   </a:ext>
                 </a:extLst>
               </a:tr>
@@ -10446,7 +11627,7 @@
                 </a:tc>
                 <a:extLst>
                   <a:ext uri="{0D108BD9-81ED-4DB2-BD59-A6C34878D82A}">
-                    <a16:rowId xmlns:a16="http://schemas.microsoft.com/office/drawing/2014/main" val="2364236726"/>
+                    <a16:rowId xmlns:a16="http://schemas.microsoft.com/office/drawing/2014/main" val="838454932"/>
                   </a:ext>
                 </a:extLst>
               </a:tr>
@@ -10579,7 +11760,7 @@
                 </a:tc>
                 <a:extLst>
                   <a:ext uri="{0D108BD9-81ED-4DB2-BD59-A6C34878D82A}">
-                    <a16:rowId xmlns:a16="http://schemas.microsoft.com/office/drawing/2014/main" val="2329282436"/>
+                    <a16:rowId xmlns:a16="http://schemas.microsoft.com/office/drawing/2014/main" val="1867238904"/>
                   </a:ext>
                 </a:extLst>
               </a:tr>
@@ -10592,7 +11773,7 @@
           <p:cNvPr id="6" name="TextBox 5">
             <a:extLst>
               <a:ext uri="{FF2B5EF4-FFF2-40B4-BE49-F238E27FC236}">
-                <a16:creationId xmlns:a16="http://schemas.microsoft.com/office/drawing/2014/main" id="{9C3F29F0-5C82-1EF9-51F3-737936AF38EE}"/>
+                <a16:creationId xmlns:a16="http://schemas.microsoft.com/office/drawing/2014/main" id="{16921A1A-6D51-3073-A3ED-83DFF40BE7EB}"/>
               </a:ext>
             </a:extLst>
           </p:cNvPr>
@@ -10637,7 +11818,7 @@
           <p:cNvPr id="7" name="TextBox 6">
             <a:extLst>
               <a:ext uri="{FF2B5EF4-FFF2-40B4-BE49-F238E27FC236}">
-                <a16:creationId xmlns:a16="http://schemas.microsoft.com/office/drawing/2014/main" id="{5B9B2B93-F585-3BCD-7DC6-A2B4C5BAE9B2}"/>
+                <a16:creationId xmlns:a16="http://schemas.microsoft.com/office/drawing/2014/main" id="{E61B1D1D-B626-5409-DAA9-ED86459D536A}"/>
               </a:ext>
             </a:extLst>
           </p:cNvPr>
@@ -10672,7 +11853,7 @@
                 </a:solidFill>
                 <a:latin typeface="Arial" panose="020B0604020202020204" pitchFamily="34" charset="0"/>
               </a:rPr>
-              <a:t>16</a:t>
+              <a:t>17</a:t>
             </a:r>
           </a:p>
         </p:txBody>
@@ -10680,7 +11861,7 @@
     </p:spTree>
     <p:extLst>
       <p:ext uri="{BB962C8B-B14F-4D97-AF65-F5344CB8AC3E}">
-        <p14:creationId xmlns:p14="http://schemas.microsoft.com/office/powerpoint/2010/main" val="2884471481"/>
+        <p14:creationId xmlns:p14="http://schemas.microsoft.com/office/powerpoint/2010/main" val="2028197391"/>
       </p:ext>
     </p:extLst>
   </p:cSld>
@@ -10720,7 +11901,7 @@
           <p:cNvPr id="2" name="TextBox 1">
             <a:extLst>
               <a:ext uri="{FF2B5EF4-FFF2-40B4-BE49-F238E27FC236}">
-                <a16:creationId xmlns:a16="http://schemas.microsoft.com/office/drawing/2014/main" id="{081C9969-90C9-A0E8-CE99-A3192A99888D}"/>
+                <a16:creationId xmlns:a16="http://schemas.microsoft.com/office/drawing/2014/main" id="{2F2080C1-3CDB-F433-9EFF-81DAFF9FBFB5}"/>
               </a:ext>
             </a:extLst>
           </p:cNvPr>
@@ -10765,7 +11946,7 @@
           <p:cNvPr id="3" name="TextBox 2">
             <a:extLst>
               <a:ext uri="{FF2B5EF4-FFF2-40B4-BE49-F238E27FC236}">
-                <a16:creationId xmlns:a16="http://schemas.microsoft.com/office/drawing/2014/main" id="{67D0545A-F5C5-0460-AAB1-F9D54E500394}"/>
+                <a16:creationId xmlns:a16="http://schemas.microsoft.com/office/drawing/2014/main" id="{74082120-20FA-122D-6663-1014E3BD1B34}"/>
               </a:ext>
             </a:extLst>
           </p:cNvPr>
@@ -10816,7 +11997,7 @@
           <p:cNvPr id="4" name="TextBox 3">
             <a:extLst>
               <a:ext uri="{FF2B5EF4-FFF2-40B4-BE49-F238E27FC236}">
-                <a16:creationId xmlns:a16="http://schemas.microsoft.com/office/drawing/2014/main" id="{C78D9CFE-5FF4-A058-AE8D-698058481DD6}"/>
+                <a16:creationId xmlns:a16="http://schemas.microsoft.com/office/drawing/2014/main" id="{79A1AD5C-518B-10B4-5274-CF737BD06FB4}"/>
               </a:ext>
             </a:extLst>
           </p:cNvPr>
@@ -10870,7 +12051,7 @@
           <p:cNvPr id="5" name="TextBox 4">
             <a:extLst>
               <a:ext uri="{FF2B5EF4-FFF2-40B4-BE49-F238E27FC236}">
-                <a16:creationId xmlns:a16="http://schemas.microsoft.com/office/drawing/2014/main" id="{A6188B30-24C6-7DF4-67A7-8E2B0D17881D}"/>
+                <a16:creationId xmlns:a16="http://schemas.microsoft.com/office/drawing/2014/main" id="{B3A1B45B-44D2-24FB-0245-CE6122E74F8D}"/>
               </a:ext>
             </a:extLst>
           </p:cNvPr>
@@ -10923,7 +12104,7 @@
           <p:cNvPr id="7" name="Picture 6">
             <a:extLst>
               <a:ext uri="{FF2B5EF4-FFF2-40B4-BE49-F238E27FC236}">
-                <a16:creationId xmlns:a16="http://schemas.microsoft.com/office/drawing/2014/main" id="{740969B3-2C15-BC58-54B9-F93EAF889637}"/>
+                <a16:creationId xmlns:a16="http://schemas.microsoft.com/office/drawing/2014/main" id="{6F1FABA9-29F0-43AB-664A-FFEBA7BC34D4}"/>
               </a:ext>
             </a:extLst>
           </p:cNvPr>
@@ -10959,7 +12140,7 @@
           <p:cNvPr id="8" name="TextBox 7">
             <a:extLst>
               <a:ext uri="{FF2B5EF4-FFF2-40B4-BE49-F238E27FC236}">
-                <a16:creationId xmlns:a16="http://schemas.microsoft.com/office/drawing/2014/main" id="{B8BEDB02-B1B0-F341-FCC9-118632C1A12B}"/>
+                <a16:creationId xmlns:a16="http://schemas.microsoft.com/office/drawing/2014/main" id="{C4E1A229-67E8-4F0E-85E6-FE1A9D70D1CC}"/>
               </a:ext>
             </a:extLst>
           </p:cNvPr>
@@ -11004,7 +12185,7 @@
           <p:cNvPr id="9" name="TextBox 8">
             <a:extLst>
               <a:ext uri="{FF2B5EF4-FFF2-40B4-BE49-F238E27FC236}">
-                <a16:creationId xmlns:a16="http://schemas.microsoft.com/office/drawing/2014/main" id="{C7C5ABA1-02E3-F223-603B-71E3B89AA021}"/>
+                <a16:creationId xmlns:a16="http://schemas.microsoft.com/office/drawing/2014/main" id="{D8355807-0983-4E2A-2F55-676DF742243A}"/>
               </a:ext>
             </a:extLst>
           </p:cNvPr>
@@ -11047,7 +12228,7 @@
     </p:spTree>
     <p:extLst>
       <p:ext uri="{BB962C8B-B14F-4D97-AF65-F5344CB8AC3E}">
-        <p14:creationId xmlns:p14="http://schemas.microsoft.com/office/powerpoint/2010/main" val="3995080891"/>
+        <p14:creationId xmlns:p14="http://schemas.microsoft.com/office/powerpoint/2010/main" val="389173811"/>
       </p:ext>
     </p:extLst>
   </p:cSld>
@@ -11087,7 +12268,7 @@
           <p:cNvPr id="2" name="TextBox 1">
             <a:extLst>
               <a:ext uri="{FF2B5EF4-FFF2-40B4-BE49-F238E27FC236}">
-                <a16:creationId xmlns:a16="http://schemas.microsoft.com/office/drawing/2014/main" id="{7093CBB9-74B9-1BAB-530C-C775061E361B}"/>
+                <a16:creationId xmlns:a16="http://schemas.microsoft.com/office/drawing/2014/main" id="{16308C61-5D4F-D8B8-DBF5-EAB2CED3740B}"/>
               </a:ext>
             </a:extLst>
           </p:cNvPr>
@@ -11132,7 +12313,7 @@
           <p:cNvPr id="3" name="TextBox 2">
             <a:extLst>
               <a:ext uri="{FF2B5EF4-FFF2-40B4-BE49-F238E27FC236}">
-                <a16:creationId xmlns:a16="http://schemas.microsoft.com/office/drawing/2014/main" id="{73F8022A-EF72-265E-7CEF-65122C11DFD7}"/>
+                <a16:creationId xmlns:a16="http://schemas.microsoft.com/office/drawing/2014/main" id="{9EEF89F6-B29C-52C5-54E3-6815888B8F5D}"/>
               </a:ext>
             </a:extLst>
           </p:cNvPr>
@@ -11183,7 +12364,7 @@
           <p:cNvPr id="4" name="TextBox 3">
             <a:extLst>
               <a:ext uri="{FF2B5EF4-FFF2-40B4-BE49-F238E27FC236}">
-                <a16:creationId xmlns:a16="http://schemas.microsoft.com/office/drawing/2014/main" id="{FFB22E3B-DF31-7E04-0946-8D32DE33BAB8}"/>
+                <a16:creationId xmlns:a16="http://schemas.microsoft.com/office/drawing/2014/main" id="{404932AA-AED6-76CF-3BD0-D0915A87B106}"/>
               </a:ext>
             </a:extLst>
           </p:cNvPr>
@@ -11228,7 +12409,7 @@
           <p:cNvPr id="5" name="Table 4">
             <a:extLst>
               <a:ext uri="{FF2B5EF4-FFF2-40B4-BE49-F238E27FC236}">
-                <a16:creationId xmlns:a16="http://schemas.microsoft.com/office/drawing/2014/main" id="{2B09F4F2-37E5-3E05-49A7-756880028B1F}"/>
+                <a16:creationId xmlns:a16="http://schemas.microsoft.com/office/drawing/2014/main" id="{EA3A6F0F-34AE-562B-F2AD-0152B1F1579B}"/>
               </a:ext>
             </a:extLst>
           </p:cNvPr>
@@ -11238,7 +12419,7 @@
           <p:nvPr>
             <p:extLst>
               <p:ext uri="{D42A27DB-BD31-4B8C-83A1-F6EECF244321}">
-                <p14:modId xmlns:p14="http://schemas.microsoft.com/office/powerpoint/2010/main" val="1430504644"/>
+                <p14:modId xmlns:p14="http://schemas.microsoft.com/office/powerpoint/2010/main" val="564499652"/>
               </p:ext>
             </p:extLst>
           </p:nvPr>
@@ -11257,21 +12438,21 @@
                 <a:gridCol w="2603500">
                   <a:extLst>
                     <a:ext uri="{9D8B030D-6E8A-4147-A177-3AD203B41FA5}">
-                      <a16:colId xmlns:a16="http://schemas.microsoft.com/office/drawing/2014/main" val="3950320502"/>
+                      <a16:colId xmlns:a16="http://schemas.microsoft.com/office/drawing/2014/main" val="3446046829"/>
                     </a:ext>
                   </a:extLst>
                 </a:gridCol>
                 <a:gridCol w="4191000">
                   <a:extLst>
                     <a:ext uri="{9D8B030D-6E8A-4147-A177-3AD203B41FA5}">
-                      <a16:colId xmlns:a16="http://schemas.microsoft.com/office/drawing/2014/main" val="868020415"/>
+                      <a16:colId xmlns:a16="http://schemas.microsoft.com/office/drawing/2014/main" val="2709394010"/>
                     </a:ext>
                   </a:extLst>
                 </a:gridCol>
                 <a:gridCol w="4127500">
                   <a:extLst>
                     <a:ext uri="{9D8B030D-6E8A-4147-A177-3AD203B41FA5}">
-                      <a16:colId xmlns:a16="http://schemas.microsoft.com/office/drawing/2014/main" val="1316956723"/>
+                      <a16:colId xmlns:a16="http://schemas.microsoft.com/office/drawing/2014/main" val="2717998459"/>
                     </a:ext>
                   </a:extLst>
                 </a:gridCol>
@@ -11405,7 +12586,7 @@
                 </a:tc>
                 <a:extLst>
                   <a:ext uri="{0D108BD9-81ED-4DB2-BD59-A6C34878D82A}">
-                    <a16:rowId xmlns:a16="http://schemas.microsoft.com/office/drawing/2014/main" val="196126918"/>
+                    <a16:rowId xmlns:a16="http://schemas.microsoft.com/office/drawing/2014/main" val="348043410"/>
                   </a:ext>
                 </a:extLst>
               </a:tr>
@@ -11552,7 +12733,7 @@
                 </a:tc>
                 <a:extLst>
                   <a:ext uri="{0D108BD9-81ED-4DB2-BD59-A6C34878D82A}">
-                    <a16:rowId xmlns:a16="http://schemas.microsoft.com/office/drawing/2014/main" val="2717118345"/>
+                    <a16:rowId xmlns:a16="http://schemas.microsoft.com/office/drawing/2014/main" val="2733395364"/>
                   </a:ext>
                 </a:extLst>
               </a:tr>
@@ -11701,7 +12882,7 @@
                 </a:tc>
                 <a:extLst>
                   <a:ext uri="{0D108BD9-81ED-4DB2-BD59-A6C34878D82A}">
-                    <a16:rowId xmlns:a16="http://schemas.microsoft.com/office/drawing/2014/main" val="1426222621"/>
+                    <a16:rowId xmlns:a16="http://schemas.microsoft.com/office/drawing/2014/main" val="4065325065"/>
                   </a:ext>
                 </a:extLst>
               </a:tr>
@@ -11714,7 +12895,7 @@
           <p:cNvPr id="6" name="TextBox 5">
             <a:extLst>
               <a:ext uri="{FF2B5EF4-FFF2-40B4-BE49-F238E27FC236}">
-                <a16:creationId xmlns:a16="http://schemas.microsoft.com/office/drawing/2014/main" id="{0B93C31F-9EB9-4D4D-ED08-080EC5838F36}"/>
+                <a16:creationId xmlns:a16="http://schemas.microsoft.com/office/drawing/2014/main" id="{B9155C5E-D14F-0405-98F5-0C223DB1911A}"/>
               </a:ext>
             </a:extLst>
           </p:cNvPr>
@@ -11765,7 +12946,7 @@
           <p:cNvPr id="7" name="TextBox 6">
             <a:extLst>
               <a:ext uri="{FF2B5EF4-FFF2-40B4-BE49-F238E27FC236}">
-                <a16:creationId xmlns:a16="http://schemas.microsoft.com/office/drawing/2014/main" id="{70FD8DF0-AD51-E4B0-79A7-D1C933228F8D}"/>
+                <a16:creationId xmlns:a16="http://schemas.microsoft.com/office/drawing/2014/main" id="{1C17F858-0ED2-BC9A-91D6-DB202EA5ED25}"/>
               </a:ext>
             </a:extLst>
           </p:cNvPr>
@@ -11810,7 +12991,7 @@
           <p:cNvPr id="8" name="TextBox 7">
             <a:extLst>
               <a:ext uri="{FF2B5EF4-FFF2-40B4-BE49-F238E27FC236}">
-                <a16:creationId xmlns:a16="http://schemas.microsoft.com/office/drawing/2014/main" id="{B32CFBB0-4ACE-CE32-A41B-C2DFF826E323}"/>
+                <a16:creationId xmlns:a16="http://schemas.microsoft.com/office/drawing/2014/main" id="{C29DE25C-25EC-4711-AC49-BCFC4FC21D2C}"/>
               </a:ext>
             </a:extLst>
           </p:cNvPr>
@@ -11853,7 +13034,7 @@
     </p:spTree>
     <p:extLst>
       <p:ext uri="{BB962C8B-B14F-4D97-AF65-F5344CB8AC3E}">
-        <p14:creationId xmlns:p14="http://schemas.microsoft.com/office/powerpoint/2010/main" val="2024908939"/>
+        <p14:creationId xmlns:p14="http://schemas.microsoft.com/office/powerpoint/2010/main" val="4008385910"/>
       </p:ext>
     </p:extLst>
   </p:cSld>
@@ -11893,7 +13074,7 @@
           <p:cNvPr id="2" name="TextBox 1">
             <a:extLst>
               <a:ext uri="{FF2B5EF4-FFF2-40B4-BE49-F238E27FC236}">
-                <a16:creationId xmlns:a16="http://schemas.microsoft.com/office/drawing/2014/main" id="{C3A92D6F-119C-8F4E-3E69-91BD59B3A1E5}"/>
+                <a16:creationId xmlns:a16="http://schemas.microsoft.com/office/drawing/2014/main" id="{421AEC14-6E81-08D8-63F2-578E1C7D434F}"/>
               </a:ext>
             </a:extLst>
           </p:cNvPr>
@@ -11944,7 +13125,7 @@
           <p:cNvPr id="3" name="TextBox 2">
             <a:extLst>
               <a:ext uri="{FF2B5EF4-FFF2-40B4-BE49-F238E27FC236}">
-                <a16:creationId xmlns:a16="http://schemas.microsoft.com/office/drawing/2014/main" id="{E6CF889F-4D4B-70C1-8D3C-DB9F0A25CBDB}"/>
+                <a16:creationId xmlns:a16="http://schemas.microsoft.com/office/drawing/2014/main" id="{0D6A8D7D-8F34-45DE-B601-1AFC23C75DC2}"/>
               </a:ext>
             </a:extLst>
           </p:cNvPr>
@@ -11995,7 +13176,7 @@
           <p:cNvPr id="4" name="TextBox 3">
             <a:extLst>
               <a:ext uri="{FF2B5EF4-FFF2-40B4-BE49-F238E27FC236}">
-                <a16:creationId xmlns:a16="http://schemas.microsoft.com/office/drawing/2014/main" id="{3CF15159-C9F0-BD56-5DF8-EFFC42C4CFE3}"/>
+                <a16:creationId xmlns:a16="http://schemas.microsoft.com/office/drawing/2014/main" id="{524A6E4B-CD42-F4F1-654E-6583698910FB}"/>
               </a:ext>
             </a:extLst>
           </p:cNvPr>
@@ -12047,7 +13228,7 @@
           <p:cNvPr id="5" name="Table 4">
             <a:extLst>
               <a:ext uri="{FF2B5EF4-FFF2-40B4-BE49-F238E27FC236}">
-                <a16:creationId xmlns:a16="http://schemas.microsoft.com/office/drawing/2014/main" id="{E06D0556-379B-3F23-4710-06B22B8DA2EC}"/>
+                <a16:creationId xmlns:a16="http://schemas.microsoft.com/office/drawing/2014/main" id="{B40478EF-A25C-A043-2C87-BC29D3250BBC}"/>
               </a:ext>
             </a:extLst>
           </p:cNvPr>
@@ -12057,7 +13238,7 @@
           <p:nvPr>
             <p:extLst>
               <p:ext uri="{D42A27DB-BD31-4B8C-83A1-F6EECF244321}">
-                <p14:modId xmlns:p14="http://schemas.microsoft.com/office/powerpoint/2010/main" val="3747710869"/>
+                <p14:modId xmlns:p14="http://schemas.microsoft.com/office/powerpoint/2010/main" val="1182239654"/>
               </p:ext>
             </p:extLst>
           </p:nvPr>
@@ -12076,28 +13257,28 @@
                 <a:gridCol w="4064000">
                   <a:extLst>
                     <a:ext uri="{9D8B030D-6E8A-4147-A177-3AD203B41FA5}">
-                      <a16:colId xmlns:a16="http://schemas.microsoft.com/office/drawing/2014/main" val="4240250660"/>
+                      <a16:colId xmlns:a16="http://schemas.microsoft.com/office/drawing/2014/main" val="51852827"/>
                     </a:ext>
                   </a:extLst>
                 </a:gridCol>
                 <a:gridCol w="2286000">
                   <a:extLst>
                     <a:ext uri="{9D8B030D-6E8A-4147-A177-3AD203B41FA5}">
-                      <a16:colId xmlns:a16="http://schemas.microsoft.com/office/drawing/2014/main" val="3280819196"/>
+                      <a16:colId xmlns:a16="http://schemas.microsoft.com/office/drawing/2014/main" val="247636588"/>
                     </a:ext>
                   </a:extLst>
                 </a:gridCol>
                 <a:gridCol w="2286000">
                   <a:extLst>
                     <a:ext uri="{9D8B030D-6E8A-4147-A177-3AD203B41FA5}">
-                      <a16:colId xmlns:a16="http://schemas.microsoft.com/office/drawing/2014/main" val="3455703620"/>
+                      <a16:colId xmlns:a16="http://schemas.microsoft.com/office/drawing/2014/main" val="1714982424"/>
                     </a:ext>
                   </a:extLst>
                 </a:gridCol>
                 <a:gridCol w="2286000">
                   <a:extLst>
                     <a:ext uri="{9D8B030D-6E8A-4147-A177-3AD203B41FA5}">
-                      <a16:colId xmlns:a16="http://schemas.microsoft.com/office/drawing/2014/main" val="936531746"/>
+                      <a16:colId xmlns:a16="http://schemas.microsoft.com/office/drawing/2014/main" val="3596683838"/>
                     </a:ext>
                   </a:extLst>
                 </a:gridCol>
@@ -12273,7 +13454,7 @@
                 </a:tc>
                 <a:extLst>
                   <a:ext uri="{0D108BD9-81ED-4DB2-BD59-A6C34878D82A}">
-                    <a16:rowId xmlns:a16="http://schemas.microsoft.com/office/drawing/2014/main" val="1304179206"/>
+                    <a16:rowId xmlns:a16="http://schemas.microsoft.com/office/drawing/2014/main" val="193349694"/>
                   </a:ext>
                 </a:extLst>
               </a:tr>
@@ -12448,7 +13629,7 @@
                 </a:tc>
                 <a:extLst>
                   <a:ext uri="{0D108BD9-81ED-4DB2-BD59-A6C34878D82A}">
-                    <a16:rowId xmlns:a16="http://schemas.microsoft.com/office/drawing/2014/main" val="1468912456"/>
+                    <a16:rowId xmlns:a16="http://schemas.microsoft.com/office/drawing/2014/main" val="2116204715"/>
                   </a:ext>
                 </a:extLst>
               </a:tr>
@@ -12623,7 +13804,7 @@
                 </a:tc>
                 <a:extLst>
                   <a:ext uri="{0D108BD9-81ED-4DB2-BD59-A6C34878D82A}">
-                    <a16:rowId xmlns:a16="http://schemas.microsoft.com/office/drawing/2014/main" val="1551063131"/>
+                    <a16:rowId xmlns:a16="http://schemas.microsoft.com/office/drawing/2014/main" val="1635081204"/>
                   </a:ext>
                 </a:extLst>
               </a:tr>
@@ -12798,7 +13979,7 @@
                 </a:tc>
                 <a:extLst>
                   <a:ext uri="{0D108BD9-81ED-4DB2-BD59-A6C34878D82A}">
-                    <a16:rowId xmlns:a16="http://schemas.microsoft.com/office/drawing/2014/main" val="1347555616"/>
+                    <a16:rowId xmlns:a16="http://schemas.microsoft.com/office/drawing/2014/main" val="3883683791"/>
                   </a:ext>
                 </a:extLst>
               </a:tr>
@@ -12973,7 +14154,7 @@
                 </a:tc>
                 <a:extLst>
                   <a:ext uri="{0D108BD9-81ED-4DB2-BD59-A6C34878D82A}">
-                    <a16:rowId xmlns:a16="http://schemas.microsoft.com/office/drawing/2014/main" val="1768019722"/>
+                    <a16:rowId xmlns:a16="http://schemas.microsoft.com/office/drawing/2014/main" val="3800439291"/>
                   </a:ext>
                 </a:extLst>
               </a:tr>
@@ -12986,7 +14167,7 @@
           <p:cNvPr id="6" name="TextBox 5">
             <a:extLst>
               <a:ext uri="{FF2B5EF4-FFF2-40B4-BE49-F238E27FC236}">
-                <a16:creationId xmlns:a16="http://schemas.microsoft.com/office/drawing/2014/main" id="{5474F76D-4812-6AE5-088E-1876BA9831F7}"/>
+                <a16:creationId xmlns:a16="http://schemas.microsoft.com/office/drawing/2014/main" id="{4616BE09-4BDC-5A65-4920-97B906418D83}"/>
               </a:ext>
             </a:extLst>
           </p:cNvPr>
@@ -13031,7 +14212,7 @@
           <p:cNvPr id="7" name="TextBox 6">
             <a:extLst>
               <a:ext uri="{FF2B5EF4-FFF2-40B4-BE49-F238E27FC236}">
-                <a16:creationId xmlns:a16="http://schemas.microsoft.com/office/drawing/2014/main" id="{9EC6AFBC-F7C6-BB9D-E9B1-E70991310DA9}"/>
+                <a16:creationId xmlns:a16="http://schemas.microsoft.com/office/drawing/2014/main" id="{FE64A3C2-E395-7D1A-A5E4-A9702D63E8DD}"/>
               </a:ext>
             </a:extLst>
           </p:cNvPr>
@@ -13074,7 +14255,7 @@
     </p:spTree>
     <p:extLst>
       <p:ext uri="{BB962C8B-B14F-4D97-AF65-F5344CB8AC3E}">
-        <p14:creationId xmlns:p14="http://schemas.microsoft.com/office/powerpoint/2010/main" val="3146023693"/>
+        <p14:creationId xmlns:p14="http://schemas.microsoft.com/office/powerpoint/2010/main" val="2076556371"/>
       </p:ext>
     </p:extLst>
   </p:cSld>
@@ -13114,7 +14295,7 @@
           <p:cNvPr id="2" name="TextBox 1">
             <a:extLst>
               <a:ext uri="{FF2B5EF4-FFF2-40B4-BE49-F238E27FC236}">
-                <a16:creationId xmlns:a16="http://schemas.microsoft.com/office/drawing/2014/main" id="{2B5F9FD1-865E-518F-73F4-105B2F7ECCE0}"/>
+                <a16:creationId xmlns:a16="http://schemas.microsoft.com/office/drawing/2014/main" id="{8D226672-D290-40A5-5F38-AA57FC13EC92}"/>
               </a:ext>
             </a:extLst>
           </p:cNvPr>
@@ -13165,7 +14346,7 @@
           <p:cNvPr id="3" name="TextBox 2">
             <a:extLst>
               <a:ext uri="{FF2B5EF4-FFF2-40B4-BE49-F238E27FC236}">
-                <a16:creationId xmlns:a16="http://schemas.microsoft.com/office/drawing/2014/main" id="{8BE4C6D6-5FDD-995D-0643-7D6BAE3ED292}"/>
+                <a16:creationId xmlns:a16="http://schemas.microsoft.com/office/drawing/2014/main" id="{089C8662-2FAC-99BC-B64D-9466DF430684}"/>
               </a:ext>
             </a:extLst>
           </p:cNvPr>
@@ -13216,7 +14397,7 @@
           <p:cNvPr id="4" name="Table 3">
             <a:extLst>
               <a:ext uri="{FF2B5EF4-FFF2-40B4-BE49-F238E27FC236}">
-                <a16:creationId xmlns:a16="http://schemas.microsoft.com/office/drawing/2014/main" id="{C86929ED-79A9-4D58-C762-D19E510A255E}"/>
+                <a16:creationId xmlns:a16="http://schemas.microsoft.com/office/drawing/2014/main" id="{E80F4386-CE45-9F8B-1A3E-049A0D4170DF}"/>
               </a:ext>
             </a:extLst>
           </p:cNvPr>
@@ -13226,7 +14407,7 @@
           <p:nvPr>
             <p:extLst>
               <p:ext uri="{D42A27DB-BD31-4B8C-83A1-F6EECF244321}">
-                <p14:modId xmlns:p14="http://schemas.microsoft.com/office/powerpoint/2010/main" val="1256962775"/>
+                <p14:modId xmlns:p14="http://schemas.microsoft.com/office/powerpoint/2010/main" val="4094439080"/>
               </p:ext>
             </p:extLst>
           </p:nvPr>
@@ -13245,21 +14426,21 @@
                 <a:gridCol w="3810000">
                   <a:extLst>
                     <a:ext uri="{9D8B030D-6E8A-4147-A177-3AD203B41FA5}">
-                      <a16:colId xmlns:a16="http://schemas.microsoft.com/office/drawing/2014/main" val="2326982087"/>
+                      <a16:colId xmlns:a16="http://schemas.microsoft.com/office/drawing/2014/main" val="69029476"/>
                     </a:ext>
                   </a:extLst>
                 </a:gridCol>
                 <a:gridCol w="3302000">
                   <a:extLst>
                     <a:ext uri="{9D8B030D-6E8A-4147-A177-3AD203B41FA5}">
-                      <a16:colId xmlns:a16="http://schemas.microsoft.com/office/drawing/2014/main" val="3515128273"/>
+                      <a16:colId xmlns:a16="http://schemas.microsoft.com/office/drawing/2014/main" val="758016958"/>
                     </a:ext>
                   </a:extLst>
                 </a:gridCol>
                 <a:gridCol w="3810000">
                   <a:extLst>
                     <a:ext uri="{9D8B030D-6E8A-4147-A177-3AD203B41FA5}">
-                      <a16:colId xmlns:a16="http://schemas.microsoft.com/office/drawing/2014/main" val="3019342547"/>
+                      <a16:colId xmlns:a16="http://schemas.microsoft.com/office/drawing/2014/main" val="3207620416"/>
                     </a:ext>
                   </a:extLst>
                 </a:gridCol>
@@ -13393,7 +14574,7 @@
                 </a:tc>
                 <a:extLst>
                   <a:ext uri="{0D108BD9-81ED-4DB2-BD59-A6C34878D82A}">
-                    <a16:rowId xmlns:a16="http://schemas.microsoft.com/office/drawing/2014/main" val="3137844428"/>
+                    <a16:rowId xmlns:a16="http://schemas.microsoft.com/office/drawing/2014/main" val="423366103"/>
                   </a:ext>
                 </a:extLst>
               </a:tr>
@@ -13526,7 +14707,7 @@
                 </a:tc>
                 <a:extLst>
                   <a:ext uri="{0D108BD9-81ED-4DB2-BD59-A6C34878D82A}">
-                    <a16:rowId xmlns:a16="http://schemas.microsoft.com/office/drawing/2014/main" val="512638069"/>
+                    <a16:rowId xmlns:a16="http://schemas.microsoft.com/office/drawing/2014/main" val="1256394020"/>
                   </a:ext>
                 </a:extLst>
               </a:tr>
@@ -13665,7 +14846,7 @@
                 </a:tc>
                 <a:extLst>
                   <a:ext uri="{0D108BD9-81ED-4DB2-BD59-A6C34878D82A}">
-                    <a16:rowId xmlns:a16="http://schemas.microsoft.com/office/drawing/2014/main" val="3989803062"/>
+                    <a16:rowId xmlns:a16="http://schemas.microsoft.com/office/drawing/2014/main" val="1300193859"/>
                   </a:ext>
                 </a:extLst>
               </a:tr>
@@ -13798,7 +14979,7 @@
                 </a:tc>
                 <a:extLst>
                   <a:ext uri="{0D108BD9-81ED-4DB2-BD59-A6C34878D82A}">
-                    <a16:rowId xmlns:a16="http://schemas.microsoft.com/office/drawing/2014/main" val="1638595399"/>
+                    <a16:rowId xmlns:a16="http://schemas.microsoft.com/office/drawing/2014/main" val="264132339"/>
                   </a:ext>
                 </a:extLst>
               </a:tr>
@@ -13937,7 +15118,7 @@
                 </a:tc>
                 <a:extLst>
                   <a:ext uri="{0D108BD9-81ED-4DB2-BD59-A6C34878D82A}">
-                    <a16:rowId xmlns:a16="http://schemas.microsoft.com/office/drawing/2014/main" val="2247959618"/>
+                    <a16:rowId xmlns:a16="http://schemas.microsoft.com/office/drawing/2014/main" val="1014041085"/>
                   </a:ext>
                 </a:extLst>
               </a:tr>
@@ -13950,7 +15131,7 @@
           <p:cNvPr id="5" name="TextBox 4">
             <a:extLst>
               <a:ext uri="{FF2B5EF4-FFF2-40B4-BE49-F238E27FC236}">
-                <a16:creationId xmlns:a16="http://schemas.microsoft.com/office/drawing/2014/main" id="{851F107E-C93F-6FA8-8795-36A7B67BE928}"/>
+                <a16:creationId xmlns:a16="http://schemas.microsoft.com/office/drawing/2014/main" id="{5562C74D-E921-4F59-7F78-096780C6BA41}"/>
               </a:ext>
             </a:extLst>
           </p:cNvPr>
@@ -14001,7 +15182,7 @@
           <p:cNvPr id="6" name="TextBox 5">
             <a:extLst>
               <a:ext uri="{FF2B5EF4-FFF2-40B4-BE49-F238E27FC236}">
-                <a16:creationId xmlns:a16="http://schemas.microsoft.com/office/drawing/2014/main" id="{DA25196B-9EB0-6717-ACD3-2F1FA357151D}"/>
+                <a16:creationId xmlns:a16="http://schemas.microsoft.com/office/drawing/2014/main" id="{39CD496D-FE83-51DB-26FF-02B0DCBBA1A6}"/>
               </a:ext>
             </a:extLst>
           </p:cNvPr>
@@ -14046,7 +15227,7 @@
           <p:cNvPr id="7" name="TextBox 6">
             <a:extLst>
               <a:ext uri="{FF2B5EF4-FFF2-40B4-BE49-F238E27FC236}">
-                <a16:creationId xmlns:a16="http://schemas.microsoft.com/office/drawing/2014/main" id="{713AF0BE-BB33-D985-36B0-C389A49425F6}"/>
+                <a16:creationId xmlns:a16="http://schemas.microsoft.com/office/drawing/2014/main" id="{BFBC28AA-83FA-F9A1-4B9C-7CAA085C03F0}"/>
               </a:ext>
             </a:extLst>
           </p:cNvPr>
@@ -14089,7 +15270,7 @@
     </p:spTree>
     <p:extLst>
       <p:ext uri="{BB962C8B-B14F-4D97-AF65-F5344CB8AC3E}">
-        <p14:creationId xmlns:p14="http://schemas.microsoft.com/office/powerpoint/2010/main" val="3241774398"/>
+        <p14:creationId xmlns:p14="http://schemas.microsoft.com/office/powerpoint/2010/main" val="2826811538"/>
       </p:ext>
     </p:extLst>
   </p:cSld>
@@ -14129,7 +15310,7 @@
           <p:cNvPr id="2" name="TextBox 1">
             <a:extLst>
               <a:ext uri="{FF2B5EF4-FFF2-40B4-BE49-F238E27FC236}">
-                <a16:creationId xmlns:a16="http://schemas.microsoft.com/office/drawing/2014/main" id="{B1177534-9845-7A6D-79A7-CA3E25702C91}"/>
+                <a16:creationId xmlns:a16="http://schemas.microsoft.com/office/drawing/2014/main" id="{E3EF35A5-DEB2-4556-F72B-DB774AC173D5}"/>
               </a:ext>
             </a:extLst>
           </p:cNvPr>
@@ -14174,7 +15355,7 @@
           <p:cNvPr id="3" name="TextBox 2">
             <a:extLst>
               <a:ext uri="{FF2B5EF4-FFF2-40B4-BE49-F238E27FC236}">
-                <a16:creationId xmlns:a16="http://schemas.microsoft.com/office/drawing/2014/main" id="{E01C27BC-C535-449B-FB1A-083ED58598E2}"/>
+                <a16:creationId xmlns:a16="http://schemas.microsoft.com/office/drawing/2014/main" id="{661F9EE7-A79A-2AFE-9C5D-C0A1C3613899}"/>
               </a:ext>
             </a:extLst>
           </p:cNvPr>
@@ -14225,7 +15406,7 @@
           <p:cNvPr id="5" name="Picture 4">
             <a:extLst>
               <a:ext uri="{FF2B5EF4-FFF2-40B4-BE49-F238E27FC236}">
-                <a16:creationId xmlns:a16="http://schemas.microsoft.com/office/drawing/2014/main" id="{2D021BDF-5B64-50C1-5430-C63F6058CEAA}"/>
+                <a16:creationId xmlns:a16="http://schemas.microsoft.com/office/drawing/2014/main" id="{B76E3F6F-2E3C-5D73-117B-46E6625B8AB7}"/>
               </a:ext>
             </a:extLst>
           </p:cNvPr>
@@ -14261,7 +15442,7 @@
           <p:cNvPr id="6" name="TextBox 5">
             <a:extLst>
               <a:ext uri="{FF2B5EF4-FFF2-40B4-BE49-F238E27FC236}">
-                <a16:creationId xmlns:a16="http://schemas.microsoft.com/office/drawing/2014/main" id="{AFBB1E70-C412-6146-5090-026236A3F3A2}"/>
+                <a16:creationId xmlns:a16="http://schemas.microsoft.com/office/drawing/2014/main" id="{8B351DFE-843A-808E-EBFA-A2027EBDEFAB}"/>
               </a:ext>
             </a:extLst>
           </p:cNvPr>
@@ -14312,7 +15493,7 @@
           <p:cNvPr id="7" name="TextBox 6">
             <a:extLst>
               <a:ext uri="{FF2B5EF4-FFF2-40B4-BE49-F238E27FC236}">
-                <a16:creationId xmlns:a16="http://schemas.microsoft.com/office/drawing/2014/main" id="{90B352BD-8303-4FEA-4838-7F030976896B}"/>
+                <a16:creationId xmlns:a16="http://schemas.microsoft.com/office/drawing/2014/main" id="{1B2A3CD3-F3C8-2A5F-9DE6-673014D47EA4}"/>
               </a:ext>
             </a:extLst>
           </p:cNvPr>
@@ -14357,7 +15538,7 @@
           <p:cNvPr id="8" name="TextBox 7">
             <a:extLst>
               <a:ext uri="{FF2B5EF4-FFF2-40B4-BE49-F238E27FC236}">
-                <a16:creationId xmlns:a16="http://schemas.microsoft.com/office/drawing/2014/main" id="{352FD84C-AC3A-F553-CDE1-29785ADB4E48}"/>
+                <a16:creationId xmlns:a16="http://schemas.microsoft.com/office/drawing/2014/main" id="{AF5470AD-E4E2-3557-5ACF-992214F54CFC}"/>
               </a:ext>
             </a:extLst>
           </p:cNvPr>
@@ -14400,7 +15581,7 @@
     </p:spTree>
     <p:extLst>
       <p:ext uri="{BB962C8B-B14F-4D97-AF65-F5344CB8AC3E}">
-        <p14:creationId xmlns:p14="http://schemas.microsoft.com/office/powerpoint/2010/main" val="2730475874"/>
+        <p14:creationId xmlns:p14="http://schemas.microsoft.com/office/powerpoint/2010/main" val="3853846565"/>
       </p:ext>
     </p:extLst>
   </p:cSld>
@@ -14440,7 +15621,7 @@
           <p:cNvPr id="2" name="TextBox 1">
             <a:extLst>
               <a:ext uri="{FF2B5EF4-FFF2-40B4-BE49-F238E27FC236}">
-                <a16:creationId xmlns:a16="http://schemas.microsoft.com/office/drawing/2014/main" id="{89E67D05-A244-FDB6-F2F2-680F37107249}"/>
+                <a16:creationId xmlns:a16="http://schemas.microsoft.com/office/drawing/2014/main" id="{BE731B54-E805-8220-60EA-2E2EECFE0F23}"/>
               </a:ext>
             </a:extLst>
           </p:cNvPr>
@@ -14491,7 +15672,7 @@
           <p:cNvPr id="3" name="TextBox 2">
             <a:extLst>
               <a:ext uri="{FF2B5EF4-FFF2-40B4-BE49-F238E27FC236}">
-                <a16:creationId xmlns:a16="http://schemas.microsoft.com/office/drawing/2014/main" id="{B2B3F2C9-FFC0-3CB8-CC19-B537CE5B5ED5}"/>
+                <a16:creationId xmlns:a16="http://schemas.microsoft.com/office/drawing/2014/main" id="{31F1845C-C32F-249D-4EDA-6CE9A88B0B50}"/>
               </a:ext>
             </a:extLst>
           </p:cNvPr>
@@ -14542,7 +15723,7 @@
           <p:cNvPr id="5" name="Picture 4">
             <a:extLst>
               <a:ext uri="{FF2B5EF4-FFF2-40B4-BE49-F238E27FC236}">
-                <a16:creationId xmlns:a16="http://schemas.microsoft.com/office/drawing/2014/main" id="{DCB5A3EB-109B-9FA3-7545-0F82E55D6A5B}"/>
+                <a16:creationId xmlns:a16="http://schemas.microsoft.com/office/drawing/2014/main" id="{72F41A71-CFFA-0F40-DC23-ABA30838204C}"/>
               </a:ext>
             </a:extLst>
           </p:cNvPr>
@@ -14578,7 +15759,7 @@
           <p:cNvPr id="6" name="Table 5">
             <a:extLst>
               <a:ext uri="{FF2B5EF4-FFF2-40B4-BE49-F238E27FC236}">
-                <a16:creationId xmlns:a16="http://schemas.microsoft.com/office/drawing/2014/main" id="{C204978F-1231-0D03-9A28-1503B190830A}"/>
+                <a16:creationId xmlns:a16="http://schemas.microsoft.com/office/drawing/2014/main" id="{3E43B0A3-FCEA-77FC-182D-6837D076482C}"/>
               </a:ext>
             </a:extLst>
           </p:cNvPr>
@@ -14588,7 +15769,7 @@
           <p:nvPr>
             <p:extLst>
               <p:ext uri="{D42A27DB-BD31-4B8C-83A1-F6EECF244321}">
-                <p14:modId xmlns:p14="http://schemas.microsoft.com/office/powerpoint/2010/main" val="2810868110"/>
+                <p14:modId xmlns:p14="http://schemas.microsoft.com/office/powerpoint/2010/main" val="3191640866"/>
               </p:ext>
             </p:extLst>
           </p:nvPr>
@@ -14607,14 +15788,14 @@
                 <a:gridCol w="2095500">
                   <a:extLst>
                     <a:ext uri="{9D8B030D-6E8A-4147-A177-3AD203B41FA5}">
-                      <a16:colId xmlns:a16="http://schemas.microsoft.com/office/drawing/2014/main" val="3757413207"/>
+                      <a16:colId xmlns:a16="http://schemas.microsoft.com/office/drawing/2014/main" val="3493810504"/>
                     </a:ext>
                   </a:extLst>
                 </a:gridCol>
                 <a:gridCol w="3683000">
                   <a:extLst>
                     <a:ext uri="{9D8B030D-6E8A-4147-A177-3AD203B41FA5}">
-                      <a16:colId xmlns:a16="http://schemas.microsoft.com/office/drawing/2014/main" val="2775934503"/>
+                      <a16:colId xmlns:a16="http://schemas.microsoft.com/office/drawing/2014/main" val="2675876793"/>
                     </a:ext>
                   </a:extLst>
                 </a:gridCol>
@@ -14706,7 +15887,7 @@
                 </a:tc>
                 <a:extLst>
                   <a:ext uri="{0D108BD9-81ED-4DB2-BD59-A6C34878D82A}">
-                    <a16:rowId xmlns:a16="http://schemas.microsoft.com/office/drawing/2014/main" val="3017170068"/>
+                    <a16:rowId xmlns:a16="http://schemas.microsoft.com/office/drawing/2014/main" val="3031441284"/>
                   </a:ext>
                 </a:extLst>
               </a:tr>
@@ -14797,7 +15978,7 @@
                 </a:tc>
                 <a:extLst>
                   <a:ext uri="{0D108BD9-81ED-4DB2-BD59-A6C34878D82A}">
-                    <a16:rowId xmlns:a16="http://schemas.microsoft.com/office/drawing/2014/main" val="1772222138"/>
+                    <a16:rowId xmlns:a16="http://schemas.microsoft.com/office/drawing/2014/main" val="2730262386"/>
                   </a:ext>
                 </a:extLst>
               </a:tr>
@@ -14888,7 +16069,7 @@
                 </a:tc>
                 <a:extLst>
                   <a:ext uri="{0D108BD9-81ED-4DB2-BD59-A6C34878D82A}">
-                    <a16:rowId xmlns:a16="http://schemas.microsoft.com/office/drawing/2014/main" val="977965795"/>
+                    <a16:rowId xmlns:a16="http://schemas.microsoft.com/office/drawing/2014/main" val="791308707"/>
                   </a:ext>
                 </a:extLst>
               </a:tr>
@@ -14985,7 +16166,7 @@
                 </a:tc>
                 <a:extLst>
                   <a:ext uri="{0D108BD9-81ED-4DB2-BD59-A6C34878D82A}">
-                    <a16:rowId xmlns:a16="http://schemas.microsoft.com/office/drawing/2014/main" val="3380548906"/>
+                    <a16:rowId xmlns:a16="http://schemas.microsoft.com/office/drawing/2014/main" val="2166898490"/>
                   </a:ext>
                 </a:extLst>
               </a:tr>
@@ -15076,7 +16257,7 @@
                 </a:tc>
                 <a:extLst>
                   <a:ext uri="{0D108BD9-81ED-4DB2-BD59-A6C34878D82A}">
-                    <a16:rowId xmlns:a16="http://schemas.microsoft.com/office/drawing/2014/main" val="2057878320"/>
+                    <a16:rowId xmlns:a16="http://schemas.microsoft.com/office/drawing/2014/main" val="523706423"/>
                   </a:ext>
                 </a:extLst>
               </a:tr>
@@ -15173,7 +16354,7 @@
                 </a:tc>
                 <a:extLst>
                   <a:ext uri="{0D108BD9-81ED-4DB2-BD59-A6C34878D82A}">
-                    <a16:rowId xmlns:a16="http://schemas.microsoft.com/office/drawing/2014/main" val="182976912"/>
+                    <a16:rowId xmlns:a16="http://schemas.microsoft.com/office/drawing/2014/main" val="144826843"/>
                   </a:ext>
                 </a:extLst>
               </a:tr>
@@ -15186,7 +16367,7 @@
           <p:cNvPr id="7" name="TextBox 6">
             <a:extLst>
               <a:ext uri="{FF2B5EF4-FFF2-40B4-BE49-F238E27FC236}">
-                <a16:creationId xmlns:a16="http://schemas.microsoft.com/office/drawing/2014/main" id="{3D376E5C-A807-2830-3F89-0C14F488F350}"/>
+                <a16:creationId xmlns:a16="http://schemas.microsoft.com/office/drawing/2014/main" id="{3CB50D89-A6FA-F243-9802-17A6A9A970DF}"/>
               </a:ext>
             </a:extLst>
           </p:cNvPr>
@@ -15237,7 +16418,7 @@
           <p:cNvPr id="8" name="TextBox 7">
             <a:extLst>
               <a:ext uri="{FF2B5EF4-FFF2-40B4-BE49-F238E27FC236}">
-                <a16:creationId xmlns:a16="http://schemas.microsoft.com/office/drawing/2014/main" id="{DD25A54E-9795-3AC9-1764-3E51DD1B1D1F}"/>
+                <a16:creationId xmlns:a16="http://schemas.microsoft.com/office/drawing/2014/main" id="{90D2D411-9E49-1D49-D0EF-31E6BCFFE0C3}"/>
               </a:ext>
             </a:extLst>
           </p:cNvPr>
@@ -15282,7 +16463,7 @@
           <p:cNvPr id="9" name="TextBox 8">
             <a:extLst>
               <a:ext uri="{FF2B5EF4-FFF2-40B4-BE49-F238E27FC236}">
-                <a16:creationId xmlns:a16="http://schemas.microsoft.com/office/drawing/2014/main" id="{10D9A29D-026D-9900-0B6C-23D4D714F8D8}"/>
+                <a16:creationId xmlns:a16="http://schemas.microsoft.com/office/drawing/2014/main" id="{984FBE04-CADD-5F49-AE67-E32790342A37}"/>
               </a:ext>
             </a:extLst>
           </p:cNvPr>
@@ -15325,7 +16506,7 @@
     </p:spTree>
     <p:extLst>
       <p:ext uri="{BB962C8B-B14F-4D97-AF65-F5344CB8AC3E}">
-        <p14:creationId xmlns:p14="http://schemas.microsoft.com/office/powerpoint/2010/main" val="3827166992"/>
+        <p14:creationId xmlns:p14="http://schemas.microsoft.com/office/powerpoint/2010/main" val="116421532"/>
       </p:ext>
     </p:extLst>
   </p:cSld>
@@ -15365,7 +16546,7 @@
           <p:cNvPr id="2" name="TextBox 1">
             <a:extLst>
               <a:ext uri="{FF2B5EF4-FFF2-40B4-BE49-F238E27FC236}">
-                <a16:creationId xmlns:a16="http://schemas.microsoft.com/office/drawing/2014/main" id="{4243E131-17AE-2C61-8098-CC0F892428C6}"/>
+                <a16:creationId xmlns:a16="http://schemas.microsoft.com/office/drawing/2014/main" id="{BC885A81-0695-4012-536D-D12053AF7A0F}"/>
               </a:ext>
             </a:extLst>
           </p:cNvPr>
@@ -15416,7 +16597,7 @@
           <p:cNvPr id="3" name="TextBox 2">
             <a:extLst>
               <a:ext uri="{FF2B5EF4-FFF2-40B4-BE49-F238E27FC236}">
-                <a16:creationId xmlns:a16="http://schemas.microsoft.com/office/drawing/2014/main" id="{8E6D1A39-401A-A307-A78B-72E25AC41821}"/>
+                <a16:creationId xmlns:a16="http://schemas.microsoft.com/office/drawing/2014/main" id="{518C91E1-EB55-9A73-0AAE-2730BD14ACF5}"/>
               </a:ext>
             </a:extLst>
           </p:cNvPr>
@@ -15467,7 +16648,7 @@
           <p:cNvPr id="4" name="TextBox 3">
             <a:extLst>
               <a:ext uri="{FF2B5EF4-FFF2-40B4-BE49-F238E27FC236}">
-                <a16:creationId xmlns:a16="http://schemas.microsoft.com/office/drawing/2014/main" id="{3E400F46-8FA7-C273-F888-EE78ADF8B3CB}"/>
+                <a16:creationId xmlns:a16="http://schemas.microsoft.com/office/drawing/2014/main" id="{1F408630-9D30-EB41-DF44-22429CD4075D}"/>
               </a:ext>
             </a:extLst>
           </p:cNvPr>
@@ -15519,7 +16700,7 @@
           <p:cNvPr id="5" name="Table 4">
             <a:extLst>
               <a:ext uri="{FF2B5EF4-FFF2-40B4-BE49-F238E27FC236}">
-                <a16:creationId xmlns:a16="http://schemas.microsoft.com/office/drawing/2014/main" id="{810EAC42-0669-44A8-0753-E3D7681CA9F4}"/>
+                <a16:creationId xmlns:a16="http://schemas.microsoft.com/office/drawing/2014/main" id="{2909899B-3729-E9FA-83ED-2B1D7BF98781}"/>
               </a:ext>
             </a:extLst>
           </p:cNvPr>
@@ -15529,7 +16710,7 @@
           <p:nvPr>
             <p:extLst>
               <p:ext uri="{D42A27DB-BD31-4B8C-83A1-F6EECF244321}">
-                <p14:modId xmlns:p14="http://schemas.microsoft.com/office/powerpoint/2010/main" val="2892003583"/>
+                <p14:modId xmlns:p14="http://schemas.microsoft.com/office/powerpoint/2010/main" val="409092027"/>
               </p:ext>
             </p:extLst>
           </p:nvPr>
@@ -15548,21 +16729,21 @@
                 <a:gridCol w="3810000">
                   <a:extLst>
                     <a:ext uri="{9D8B030D-6E8A-4147-A177-3AD203B41FA5}">
-                      <a16:colId xmlns:a16="http://schemas.microsoft.com/office/drawing/2014/main" val="3842377772"/>
+                      <a16:colId xmlns:a16="http://schemas.microsoft.com/office/drawing/2014/main" val="2810859001"/>
                     </a:ext>
                   </a:extLst>
                 </a:gridCol>
                 <a:gridCol w="4572000">
                   <a:extLst>
                     <a:ext uri="{9D8B030D-6E8A-4147-A177-3AD203B41FA5}">
-                      <a16:colId xmlns:a16="http://schemas.microsoft.com/office/drawing/2014/main" val="451885387"/>
+                      <a16:colId xmlns:a16="http://schemas.microsoft.com/office/drawing/2014/main" val="19413319"/>
                     </a:ext>
                   </a:extLst>
                 </a:gridCol>
                 <a:gridCol w="2540000">
                   <a:extLst>
                     <a:ext uri="{9D8B030D-6E8A-4147-A177-3AD203B41FA5}">
-                      <a16:colId xmlns:a16="http://schemas.microsoft.com/office/drawing/2014/main" val="1933106445"/>
+                      <a16:colId xmlns:a16="http://schemas.microsoft.com/office/drawing/2014/main" val="3514906362"/>
                     </a:ext>
                   </a:extLst>
                 </a:gridCol>
@@ -15696,7 +16877,7 @@
                 </a:tc>
                 <a:extLst>
                   <a:ext uri="{0D108BD9-81ED-4DB2-BD59-A6C34878D82A}">
-                    <a16:rowId xmlns:a16="http://schemas.microsoft.com/office/drawing/2014/main" val="1418020894"/>
+                    <a16:rowId xmlns:a16="http://schemas.microsoft.com/office/drawing/2014/main" val="1169514602"/>
                   </a:ext>
                 </a:extLst>
               </a:tr>
@@ -15829,7 +17010,7 @@
                 </a:tc>
                 <a:extLst>
                   <a:ext uri="{0D108BD9-81ED-4DB2-BD59-A6C34878D82A}">
-                    <a16:rowId xmlns:a16="http://schemas.microsoft.com/office/drawing/2014/main" val="4156437194"/>
+                    <a16:rowId xmlns:a16="http://schemas.microsoft.com/office/drawing/2014/main" val="1793120236"/>
                   </a:ext>
                 </a:extLst>
               </a:tr>
@@ -15962,7 +17143,7 @@
                 </a:tc>
                 <a:extLst>
                   <a:ext uri="{0D108BD9-81ED-4DB2-BD59-A6C34878D82A}">
-                    <a16:rowId xmlns:a16="http://schemas.microsoft.com/office/drawing/2014/main" val="2752199131"/>
+                    <a16:rowId xmlns:a16="http://schemas.microsoft.com/office/drawing/2014/main" val="1432322939"/>
                   </a:ext>
                 </a:extLst>
               </a:tr>
@@ -16095,7 +17276,7 @@
                 </a:tc>
                 <a:extLst>
                   <a:ext uri="{0D108BD9-81ED-4DB2-BD59-A6C34878D82A}">
-                    <a16:rowId xmlns:a16="http://schemas.microsoft.com/office/drawing/2014/main" val="3035348186"/>
+                    <a16:rowId xmlns:a16="http://schemas.microsoft.com/office/drawing/2014/main" val="3461550511"/>
                   </a:ext>
                 </a:extLst>
               </a:tr>
@@ -16228,7 +17409,7 @@
                 </a:tc>
                 <a:extLst>
                   <a:ext uri="{0D108BD9-81ED-4DB2-BD59-A6C34878D82A}">
-                    <a16:rowId xmlns:a16="http://schemas.microsoft.com/office/drawing/2014/main" val="2322666053"/>
+                    <a16:rowId xmlns:a16="http://schemas.microsoft.com/office/drawing/2014/main" val="3282168290"/>
                   </a:ext>
                 </a:extLst>
               </a:tr>
@@ -16241,7 +17422,7 @@
           <p:cNvPr id="6" name="TextBox 5">
             <a:extLst>
               <a:ext uri="{FF2B5EF4-FFF2-40B4-BE49-F238E27FC236}">
-                <a16:creationId xmlns:a16="http://schemas.microsoft.com/office/drawing/2014/main" id="{BBDFB472-41E9-004B-6C01-5AEA93B55158}"/>
+                <a16:creationId xmlns:a16="http://schemas.microsoft.com/office/drawing/2014/main" id="{7248D453-FE69-87AA-F1FF-BCD0FDF1492E}"/>
               </a:ext>
             </a:extLst>
           </p:cNvPr>
@@ -16286,7 +17467,7 @@
           <p:cNvPr id="7" name="TextBox 6">
             <a:extLst>
               <a:ext uri="{FF2B5EF4-FFF2-40B4-BE49-F238E27FC236}">
-                <a16:creationId xmlns:a16="http://schemas.microsoft.com/office/drawing/2014/main" id="{3256E32D-E1A6-0992-8FD8-B8D94141E8ED}"/>
+                <a16:creationId xmlns:a16="http://schemas.microsoft.com/office/drawing/2014/main" id="{B836EFC9-B99A-FE2D-47F3-00F33692BDC8}"/>
               </a:ext>
             </a:extLst>
           </p:cNvPr>
@@ -16329,7 +17510,7 @@
     </p:spTree>
     <p:extLst>
       <p:ext uri="{BB962C8B-B14F-4D97-AF65-F5344CB8AC3E}">
-        <p14:creationId xmlns:p14="http://schemas.microsoft.com/office/powerpoint/2010/main" val="3160738275"/>
+        <p14:creationId xmlns:p14="http://schemas.microsoft.com/office/powerpoint/2010/main" val="3994622029"/>
       </p:ext>
     </p:extLst>
   </p:cSld>
@@ -16369,7 +17550,7 @@
           <p:cNvPr id="2" name="TextBox 1">
             <a:extLst>
               <a:ext uri="{FF2B5EF4-FFF2-40B4-BE49-F238E27FC236}">
-                <a16:creationId xmlns:a16="http://schemas.microsoft.com/office/drawing/2014/main" id="{6754BA4F-2081-6184-CADA-B1BB1B456DF7}"/>
+                <a16:creationId xmlns:a16="http://schemas.microsoft.com/office/drawing/2014/main" id="{797519FE-1363-A121-5331-474C92696FCD}"/>
               </a:ext>
             </a:extLst>
           </p:cNvPr>
@@ -16414,7 +17595,7 @@
           <p:cNvPr id="3" name="TextBox 2">
             <a:extLst>
               <a:ext uri="{FF2B5EF4-FFF2-40B4-BE49-F238E27FC236}">
-                <a16:creationId xmlns:a16="http://schemas.microsoft.com/office/drawing/2014/main" id="{96C0138E-FD65-9CAC-375B-68D8326ED1A6}"/>
+                <a16:creationId xmlns:a16="http://schemas.microsoft.com/office/drawing/2014/main" id="{107B6E85-7F0F-5811-517F-5A13C2F2EE34}"/>
               </a:ext>
             </a:extLst>
           </p:cNvPr>
@@ -16465,7 +17646,7 @@
           <p:cNvPr id="4" name="Table 3">
             <a:extLst>
               <a:ext uri="{FF2B5EF4-FFF2-40B4-BE49-F238E27FC236}">
-                <a16:creationId xmlns:a16="http://schemas.microsoft.com/office/drawing/2014/main" id="{06773C2D-0F05-4D4F-D982-43565BC41D90}"/>
+                <a16:creationId xmlns:a16="http://schemas.microsoft.com/office/drawing/2014/main" id="{C0E850F9-928C-6489-8A52-C4BA0F12C4AC}"/>
               </a:ext>
             </a:extLst>
           </p:cNvPr>
@@ -16475,7 +17656,7 @@
           <p:nvPr>
             <p:extLst>
               <p:ext uri="{D42A27DB-BD31-4B8C-83A1-F6EECF244321}">
-                <p14:modId xmlns:p14="http://schemas.microsoft.com/office/powerpoint/2010/main" val="959667966"/>
+                <p14:modId xmlns:p14="http://schemas.microsoft.com/office/powerpoint/2010/main" val="2854085564"/>
               </p:ext>
             </p:extLst>
           </p:nvPr>
@@ -16494,35 +17675,35 @@
                 <a:gridCol w="3810000">
                   <a:extLst>
                     <a:ext uri="{9D8B030D-6E8A-4147-A177-3AD203B41FA5}">
-                      <a16:colId xmlns:a16="http://schemas.microsoft.com/office/drawing/2014/main" val="48464989"/>
+                      <a16:colId xmlns:a16="http://schemas.microsoft.com/office/drawing/2014/main" val="3516369988"/>
                     </a:ext>
                   </a:extLst>
                 </a:gridCol>
                 <a:gridCol w="1016000">
                   <a:extLst>
                     <a:ext uri="{9D8B030D-6E8A-4147-A177-3AD203B41FA5}">
-                      <a16:colId xmlns:a16="http://schemas.microsoft.com/office/drawing/2014/main" val="2021075385"/>
+                      <a16:colId xmlns:a16="http://schemas.microsoft.com/office/drawing/2014/main" val="559975301"/>
                     </a:ext>
                   </a:extLst>
                 </a:gridCol>
                 <a:gridCol w="2032000">
                   <a:extLst>
                     <a:ext uri="{9D8B030D-6E8A-4147-A177-3AD203B41FA5}">
-                      <a16:colId xmlns:a16="http://schemas.microsoft.com/office/drawing/2014/main" val="2017696373"/>
+                      <a16:colId xmlns:a16="http://schemas.microsoft.com/office/drawing/2014/main" val="2455341719"/>
                     </a:ext>
                   </a:extLst>
                 </a:gridCol>
                 <a:gridCol w="2032000">
                   <a:extLst>
                     <a:ext uri="{9D8B030D-6E8A-4147-A177-3AD203B41FA5}">
-                      <a16:colId xmlns:a16="http://schemas.microsoft.com/office/drawing/2014/main" val="3276573649"/>
+                      <a16:colId xmlns:a16="http://schemas.microsoft.com/office/drawing/2014/main" val="227727977"/>
                     </a:ext>
                   </a:extLst>
                 </a:gridCol>
                 <a:gridCol w="2032000">
                   <a:extLst>
                     <a:ext uri="{9D8B030D-6E8A-4147-A177-3AD203B41FA5}">
-                      <a16:colId xmlns:a16="http://schemas.microsoft.com/office/drawing/2014/main" val="1496618332"/>
+                      <a16:colId xmlns:a16="http://schemas.microsoft.com/office/drawing/2014/main" val="1708841700"/>
                     </a:ext>
                   </a:extLst>
                 </a:gridCol>
@@ -16740,7 +17921,7 @@
                 </a:tc>
                 <a:extLst>
                   <a:ext uri="{0D108BD9-81ED-4DB2-BD59-A6C34878D82A}">
-                    <a16:rowId xmlns:a16="http://schemas.microsoft.com/office/drawing/2014/main" val="1541756970"/>
+                    <a16:rowId xmlns:a16="http://schemas.microsoft.com/office/drawing/2014/main" val="833538895"/>
                   </a:ext>
                 </a:extLst>
               </a:tr>
@@ -16957,7 +18138,7 @@
                 </a:tc>
                 <a:extLst>
                   <a:ext uri="{0D108BD9-81ED-4DB2-BD59-A6C34878D82A}">
-                    <a16:rowId xmlns:a16="http://schemas.microsoft.com/office/drawing/2014/main" val="3695385704"/>
+                    <a16:rowId xmlns:a16="http://schemas.microsoft.com/office/drawing/2014/main" val="1924183128"/>
                   </a:ext>
                 </a:extLst>
               </a:tr>
@@ -17174,7 +18355,7 @@
                 </a:tc>
                 <a:extLst>
                   <a:ext uri="{0D108BD9-81ED-4DB2-BD59-A6C34878D82A}">
-                    <a16:rowId xmlns:a16="http://schemas.microsoft.com/office/drawing/2014/main" val="2143837066"/>
+                    <a16:rowId xmlns:a16="http://schemas.microsoft.com/office/drawing/2014/main" val="2532238401"/>
                   </a:ext>
                 </a:extLst>
               </a:tr>
@@ -17391,7 +18572,7 @@
                 </a:tc>
                 <a:extLst>
                   <a:ext uri="{0D108BD9-81ED-4DB2-BD59-A6C34878D82A}">
-                    <a16:rowId xmlns:a16="http://schemas.microsoft.com/office/drawing/2014/main" val="2730495830"/>
+                    <a16:rowId xmlns:a16="http://schemas.microsoft.com/office/drawing/2014/main" val="1913551000"/>
                   </a:ext>
                 </a:extLst>
               </a:tr>
@@ -17608,7 +18789,7 @@
                 </a:tc>
                 <a:extLst>
                   <a:ext uri="{0D108BD9-81ED-4DB2-BD59-A6C34878D82A}">
-                    <a16:rowId xmlns:a16="http://schemas.microsoft.com/office/drawing/2014/main" val="3294962298"/>
+                    <a16:rowId xmlns:a16="http://schemas.microsoft.com/office/drawing/2014/main" val="1517836891"/>
                   </a:ext>
                 </a:extLst>
               </a:tr>
@@ -17825,7 +19006,7 @@
                 </a:tc>
                 <a:extLst>
                   <a:ext uri="{0D108BD9-81ED-4DB2-BD59-A6C34878D82A}">
-                    <a16:rowId xmlns:a16="http://schemas.microsoft.com/office/drawing/2014/main" val="4053149952"/>
+                    <a16:rowId xmlns:a16="http://schemas.microsoft.com/office/drawing/2014/main" val="3588157338"/>
                   </a:ext>
                 </a:extLst>
               </a:tr>
@@ -17838,7 +19019,7 @@
           <p:cNvPr id="5" name="TextBox 4">
             <a:extLst>
               <a:ext uri="{FF2B5EF4-FFF2-40B4-BE49-F238E27FC236}">
-                <a16:creationId xmlns:a16="http://schemas.microsoft.com/office/drawing/2014/main" id="{E5CE15E1-73EA-51D2-115C-41080844E63C}"/>
+                <a16:creationId xmlns:a16="http://schemas.microsoft.com/office/drawing/2014/main" id="{452502CC-591A-C7B1-94F5-3B85505F7778}"/>
               </a:ext>
             </a:extLst>
           </p:cNvPr>
@@ -17889,7 +19070,7 @@
           <p:cNvPr id="6" name="TextBox 5">
             <a:extLst>
               <a:ext uri="{FF2B5EF4-FFF2-40B4-BE49-F238E27FC236}">
-                <a16:creationId xmlns:a16="http://schemas.microsoft.com/office/drawing/2014/main" id="{DD1BB334-010A-803C-4B89-C19C80B13100}"/>
+                <a16:creationId xmlns:a16="http://schemas.microsoft.com/office/drawing/2014/main" id="{8CACB467-4200-F708-5EDD-A1DEC4819EE8}"/>
               </a:ext>
             </a:extLst>
           </p:cNvPr>
@@ -17934,7 +19115,7 @@
           <p:cNvPr id="7" name="TextBox 6">
             <a:extLst>
               <a:ext uri="{FF2B5EF4-FFF2-40B4-BE49-F238E27FC236}">
-                <a16:creationId xmlns:a16="http://schemas.microsoft.com/office/drawing/2014/main" id="{CA47ACCF-AC19-864D-EC59-3BCED631FA44}"/>
+                <a16:creationId xmlns:a16="http://schemas.microsoft.com/office/drawing/2014/main" id="{295CF2CA-09BE-202A-6006-A92F2D45A009}"/>
               </a:ext>
             </a:extLst>
           </p:cNvPr>
@@ -17977,7 +19158,7 @@
     </p:spTree>
     <p:extLst>
       <p:ext uri="{BB962C8B-B14F-4D97-AF65-F5344CB8AC3E}">
-        <p14:creationId xmlns:p14="http://schemas.microsoft.com/office/powerpoint/2010/main" val="1700884233"/>
+        <p14:creationId xmlns:p14="http://schemas.microsoft.com/office/powerpoint/2010/main" val="3452411671"/>
       </p:ext>
     </p:extLst>
   </p:cSld>

</xml_diff>